<commit_message>
Atualiza apresentação: tudo em nome da Nunes, capacidade 1.000 t/mês e análise interna
- Novo slide de capacidade e logística (1.000 t/mês, cargas de 14 t, energia/mês)
- Material descrito como mistura de fibras (explica o PCI alto)
- Pedido de cotação formal em R$/t nos próximos passos
- Metadados do arquivo em nome da Nunes & Lucato
- analise-comercial-interna.md com frete, saldos, preço mínimo e R$/GJ
</commit_message>
<xml_diff>
--- a/apresentacao-mineradora/Nunes_Lucato_Residuo_Textil_Mineradora.pptx
+++ b/apresentacao-mineradora/Nunes_Lucato_Residuo_Textil_Mineradora.pptx
@@ -18,6 +18,7 @@
     <p:sldId id="266" r:id="rId17"/>
     <p:sldId id="267" r:id="rId18"/>
     <p:sldId id="268" r:id="rId19"/>
+    <p:sldId id="269" r:id="rId20"/>
   </p:sldIdLst>
   <p:sldSz cx="12191695" cy="6858000" type="screen4x3"/>
   <p:notesSz cx="6858000" cy="9144000"/>
@@ -3799,6 +3800,1115 @@
                 </a:solidFill>
                 <a:latin typeface="Montserrat"/>
               </a:rPr>
+              <a:t>Capacidade e logística</a:t>
+            </a:r>
+          </a:p>
+        </p:txBody>
+      </p:sp>
+      <p:sp>
+        <p:nvSpPr>
+          <p:cNvPr id="4" name="TextBox 3"/>
+          <p:cNvSpPr txBox="1"/>
+          <p:nvPr/>
+        </p:nvSpPr>
+        <p:spPr>
+          <a:xfrm>
+            <a:off x="758952" y="777240"/>
+            <a:ext cx="10698480" cy="640080"/>
+          </a:xfrm>
+          <a:prstGeom prst="rect">
+            <a:avLst/>
+          </a:prstGeom>
+          <a:noFill/>
+        </p:spPr>
+        <p:txBody>
+          <a:bodyPr wrap="square" lIns="0" rIns="0" tIns="0" bIns="0" anchor="t">
+            <a:spAutoFit/>
+          </a:bodyPr>
+          <a:lstStyle/>
+          <a:p>
+            <a:pPr algn="l">
+              <a:lnSpc>
+                <a:spcPct val="115000"/>
+              </a:lnSpc>
+            </a:pPr>
+            <a:r>
+              <a:rPr sz="2800" b="0">
+                <a:solidFill>
+                  <a:srgbClr val="1B1B2F"/>
+                </a:solidFill>
+                <a:latin typeface="Montserrat"/>
+              </a:rPr>
+              <a:t>Fornecimento recorrente de </a:t>
+            </a:r>
+            <a:r>
+              <a:rPr sz="2800" b="1">
+                <a:solidFill>
+                  <a:srgbClr val="1B1B2F"/>
+                </a:solidFill>
+                <a:latin typeface="Montserrat"/>
+              </a:rPr>
+              <a:t>1.000 toneladas por mês</a:t>
+            </a:r>
+          </a:p>
+        </p:txBody>
+      </p:sp>
+      <p:sp>
+        <p:nvSpPr>
+          <p:cNvPr id="5" name="TextBox 4"/>
+          <p:cNvSpPr txBox="1"/>
+          <p:nvPr/>
+        </p:nvSpPr>
+        <p:spPr>
+          <a:xfrm>
+            <a:off x="758952" y="1463040"/>
+            <a:ext cx="10515600" cy="457200"/>
+          </a:xfrm>
+          <a:prstGeom prst="rect">
+            <a:avLst/>
+          </a:prstGeom>
+          <a:noFill/>
+        </p:spPr>
+        <p:txBody>
+          <a:bodyPr wrap="square" lIns="0" rIns="0" tIns="0" bIns="0" anchor="t">
+            <a:spAutoFit/>
+          </a:bodyPr>
+          <a:lstStyle/>
+          <a:p>
+            <a:pPr algn="l">
+              <a:lnSpc>
+                <a:spcPct val="115000"/>
+              </a:lnSpc>
+            </a:pPr>
+            <a:r>
+              <a:rPr sz="1200" b="0">
+                <a:solidFill>
+                  <a:srgbClr val="6B6B80"/>
+                </a:solidFill>
+                <a:latin typeface="Montserrat"/>
+              </a:rPr>
+              <a:t>Base operacional em São Paulo/SP (Belenzinho), com entrega programada na unidade do cliente.</a:t>
+            </a:r>
+          </a:p>
+        </p:txBody>
+      </p:sp>
+      <p:sp>
+        <p:nvSpPr>
+          <p:cNvPr id="6" name="Rectangle 5"/>
+          <p:cNvSpPr/>
+          <p:nvPr/>
+        </p:nvSpPr>
+        <p:spPr>
+          <a:xfrm>
+            <a:off x="758952" y="2103120"/>
+            <a:ext cx="2514600" cy="2377440"/>
+          </a:xfrm>
+          <a:prstGeom prst="rect">
+            <a:avLst/>
+          </a:prstGeom>
+          <a:solidFill>
+            <a:srgbClr val="F4F5FC"/>
+          </a:solidFill>
+          <a:ln>
+            <a:noFill/>
+          </a:ln>
+          <a:effectLst/>
+        </p:spPr>
+        <p:txBody>
+          <a:bodyPr rtlCol="0" anchor="ctr"/>
+          <a:lstStyle/>
+          <a:p>
+            <a:pPr algn="ctr"/>
+          </a:p>
+        </p:txBody>
+      </p:sp>
+      <p:sp>
+        <p:nvSpPr>
+          <p:cNvPr id="7" name="Rectangle 6"/>
+          <p:cNvSpPr/>
+          <p:nvPr/>
+        </p:nvSpPr>
+        <p:spPr>
+          <a:xfrm>
+            <a:off x="758952" y="2103120"/>
+            <a:ext cx="2514600" cy="54864"/>
+          </a:xfrm>
+          <a:prstGeom prst="rect">
+            <a:avLst/>
+          </a:prstGeom>
+          <a:solidFill>
+            <a:srgbClr val="3432C9"/>
+          </a:solidFill>
+          <a:ln>
+            <a:noFill/>
+          </a:ln>
+          <a:effectLst/>
+        </p:spPr>
+        <p:txBody>
+          <a:bodyPr rtlCol="0" anchor="ctr"/>
+          <a:lstStyle/>
+          <a:p>
+            <a:pPr algn="ctr"/>
+          </a:p>
+        </p:txBody>
+      </p:sp>
+      <p:sp>
+        <p:nvSpPr>
+          <p:cNvPr id="8" name="TextBox 7"/>
+          <p:cNvSpPr txBox="1"/>
+          <p:nvPr/>
+        </p:nvSpPr>
+        <p:spPr>
+          <a:xfrm>
+            <a:off x="1033271" y="2377440"/>
+            <a:ext cx="2194560" cy="731520"/>
+          </a:xfrm>
+          <a:prstGeom prst="rect">
+            <a:avLst/>
+          </a:prstGeom>
+          <a:noFill/>
+        </p:spPr>
+        <p:txBody>
+          <a:bodyPr wrap="square" lIns="0" rIns="0" tIns="0" bIns="0" anchor="t">
+            <a:spAutoFit/>
+          </a:bodyPr>
+          <a:lstStyle/>
+          <a:p>
+            <a:pPr algn="l">
+              <a:lnSpc>
+                <a:spcPct val="115000"/>
+              </a:lnSpc>
+            </a:pPr>
+            <a:r>
+              <a:rPr sz="3000" b="1">
+                <a:solidFill>
+                  <a:srgbClr val="3432C9"/>
+                </a:solidFill>
+                <a:latin typeface="Montserrat"/>
+              </a:rPr>
+              <a:t>1.000</a:t>
+            </a:r>
+            <a:r>
+              <a:rPr sz="1100" b="0">
+                <a:solidFill>
+                  <a:srgbClr val="3432C9"/>
+                </a:solidFill>
+                <a:latin typeface="Montserrat"/>
+              </a:rPr>
+              <a:t> t/mês</a:t>
+            </a:r>
+          </a:p>
+        </p:txBody>
+      </p:sp>
+      <p:sp>
+        <p:nvSpPr>
+          <p:cNvPr id="9" name="TextBox 8"/>
+          <p:cNvSpPr txBox="1"/>
+          <p:nvPr/>
+        </p:nvSpPr>
+        <p:spPr>
+          <a:xfrm>
+            <a:off x="1033271" y="3246120"/>
+            <a:ext cx="2103120" cy="365760"/>
+          </a:xfrm>
+          <a:prstGeom prst="rect">
+            <a:avLst/>
+          </a:prstGeom>
+          <a:noFill/>
+        </p:spPr>
+        <p:txBody>
+          <a:bodyPr wrap="square" lIns="0" rIns="0" tIns="0" bIns="0" anchor="t">
+            <a:spAutoFit/>
+          </a:bodyPr>
+          <a:lstStyle/>
+          <a:p>
+            <a:pPr algn="l">
+              <a:lnSpc>
+                <a:spcPct val="115000"/>
+              </a:lnSpc>
+            </a:pPr>
+            <a:r>
+              <a:rPr sz="1200" b="1">
+                <a:solidFill>
+                  <a:srgbClr val="1B1B2F"/>
+                </a:solidFill>
+                <a:latin typeface="Montserrat"/>
+              </a:rPr>
+              <a:t>Volume disponível</a:t>
+            </a:r>
+          </a:p>
+        </p:txBody>
+      </p:sp>
+      <p:sp>
+        <p:nvSpPr>
+          <p:cNvPr id="10" name="TextBox 9"/>
+          <p:cNvSpPr txBox="1"/>
+          <p:nvPr/>
+        </p:nvSpPr>
+        <p:spPr>
+          <a:xfrm>
+            <a:off x="1033271" y="3611880"/>
+            <a:ext cx="2103120" cy="731520"/>
+          </a:xfrm>
+          <a:prstGeom prst="rect">
+            <a:avLst/>
+          </a:prstGeom>
+          <a:noFill/>
+        </p:spPr>
+        <p:txBody>
+          <a:bodyPr wrap="square" lIns="0" rIns="0" tIns="0" bIns="0" anchor="t">
+            <a:spAutoFit/>
+          </a:bodyPr>
+          <a:lstStyle/>
+          <a:p>
+            <a:pPr algn="l">
+              <a:lnSpc>
+                <a:spcPct val="115000"/>
+              </a:lnSpc>
+            </a:pPr>
+            <a:r>
+              <a:rPr sz="1000" b="0">
+                <a:solidFill>
+                  <a:srgbClr val="6B6B80"/>
+                </a:solidFill>
+                <a:latin typeface="Montserrat"/>
+              </a:rPr>
+              <a:t>Fornecimento contínuo e programado</a:t>
+            </a:r>
+          </a:p>
+        </p:txBody>
+      </p:sp>
+      <p:sp>
+        <p:nvSpPr>
+          <p:cNvPr id="11" name="Rectangle 10"/>
+          <p:cNvSpPr/>
+          <p:nvPr/>
+        </p:nvSpPr>
+        <p:spPr>
+          <a:xfrm>
+            <a:off x="3474720" y="2103120"/>
+            <a:ext cx="2514600" cy="2377440"/>
+          </a:xfrm>
+          <a:prstGeom prst="rect">
+            <a:avLst/>
+          </a:prstGeom>
+          <a:solidFill>
+            <a:srgbClr val="F4F5FC"/>
+          </a:solidFill>
+          <a:ln>
+            <a:noFill/>
+          </a:ln>
+          <a:effectLst/>
+        </p:spPr>
+        <p:txBody>
+          <a:bodyPr rtlCol="0" anchor="ctr"/>
+          <a:lstStyle/>
+          <a:p>
+            <a:pPr algn="ctr"/>
+          </a:p>
+        </p:txBody>
+      </p:sp>
+      <p:sp>
+        <p:nvSpPr>
+          <p:cNvPr id="12" name="Rectangle 11"/>
+          <p:cNvSpPr/>
+          <p:nvPr/>
+        </p:nvSpPr>
+        <p:spPr>
+          <a:xfrm>
+            <a:off x="3474720" y="2103120"/>
+            <a:ext cx="2514600" cy="54864"/>
+          </a:xfrm>
+          <a:prstGeom prst="rect">
+            <a:avLst/>
+          </a:prstGeom>
+          <a:solidFill>
+            <a:srgbClr val="1E86C9"/>
+          </a:solidFill>
+          <a:ln>
+            <a:noFill/>
+          </a:ln>
+          <a:effectLst/>
+        </p:spPr>
+        <p:txBody>
+          <a:bodyPr rtlCol="0" anchor="ctr"/>
+          <a:lstStyle/>
+          <a:p>
+            <a:pPr algn="ctr"/>
+          </a:p>
+        </p:txBody>
+      </p:sp>
+      <p:sp>
+        <p:nvSpPr>
+          <p:cNvPr id="13" name="TextBox 12"/>
+          <p:cNvSpPr txBox="1"/>
+          <p:nvPr/>
+        </p:nvSpPr>
+        <p:spPr>
+          <a:xfrm>
+            <a:off x="3749040" y="2377440"/>
+            <a:ext cx="2194560" cy="731520"/>
+          </a:xfrm>
+          <a:prstGeom prst="rect">
+            <a:avLst/>
+          </a:prstGeom>
+          <a:noFill/>
+        </p:spPr>
+        <p:txBody>
+          <a:bodyPr wrap="square" lIns="0" rIns="0" tIns="0" bIns="0" anchor="t">
+            <a:spAutoFit/>
+          </a:bodyPr>
+          <a:lstStyle/>
+          <a:p>
+            <a:pPr algn="l">
+              <a:lnSpc>
+                <a:spcPct val="115000"/>
+              </a:lnSpc>
+            </a:pPr>
+            <a:r>
+              <a:rPr sz="3000" b="1">
+                <a:solidFill>
+                  <a:srgbClr val="1E86C9"/>
+                </a:solidFill>
+                <a:latin typeface="Montserrat"/>
+              </a:rPr>
+              <a:t>14</a:t>
+            </a:r>
+            <a:r>
+              <a:rPr sz="1100" b="0">
+                <a:solidFill>
+                  <a:srgbClr val="1E86C9"/>
+                </a:solidFill>
+                <a:latin typeface="Montserrat"/>
+              </a:rPr>
+              <a:t> t</a:t>
+            </a:r>
+          </a:p>
+        </p:txBody>
+      </p:sp>
+      <p:sp>
+        <p:nvSpPr>
+          <p:cNvPr id="14" name="TextBox 13"/>
+          <p:cNvSpPr txBox="1"/>
+          <p:nvPr/>
+        </p:nvSpPr>
+        <p:spPr>
+          <a:xfrm>
+            <a:off x="3749040" y="3246120"/>
+            <a:ext cx="2103120" cy="365760"/>
+          </a:xfrm>
+          <a:prstGeom prst="rect">
+            <a:avLst/>
+          </a:prstGeom>
+          <a:noFill/>
+        </p:spPr>
+        <p:txBody>
+          <a:bodyPr wrap="square" lIns="0" rIns="0" tIns="0" bIns="0" anchor="t">
+            <a:spAutoFit/>
+          </a:bodyPr>
+          <a:lstStyle/>
+          <a:p>
+            <a:pPr algn="l">
+              <a:lnSpc>
+                <a:spcPct val="115000"/>
+              </a:lnSpc>
+            </a:pPr>
+            <a:r>
+              <a:rPr sz="1200" b="1">
+                <a:solidFill>
+                  <a:srgbClr val="1B1B2F"/>
+                </a:solidFill>
+                <a:latin typeface="Montserrat"/>
+              </a:rPr>
+              <a:t>Por carga (truck)</a:t>
+            </a:r>
+          </a:p>
+        </p:txBody>
+      </p:sp>
+      <p:sp>
+        <p:nvSpPr>
+          <p:cNvPr id="15" name="TextBox 14"/>
+          <p:cNvSpPr txBox="1"/>
+          <p:nvPr/>
+        </p:nvSpPr>
+        <p:spPr>
+          <a:xfrm>
+            <a:off x="3749040" y="3611880"/>
+            <a:ext cx="2103120" cy="731520"/>
+          </a:xfrm>
+          <a:prstGeom prst="rect">
+            <a:avLst/>
+          </a:prstGeom>
+          <a:noFill/>
+        </p:spPr>
+        <p:txBody>
+          <a:bodyPr wrap="square" lIns="0" rIns="0" tIns="0" bIns="0" anchor="t">
+            <a:spAutoFit/>
+          </a:bodyPr>
+          <a:lstStyle/>
+          <a:p>
+            <a:pPr algn="l">
+              <a:lnSpc>
+                <a:spcPct val="115000"/>
+              </a:lnSpc>
+            </a:pPr>
+            <a:r>
+              <a:rPr sz="1000" b="0">
+                <a:solidFill>
+                  <a:srgbClr val="6B6B80"/>
+                </a:solidFill>
+                <a:latin typeface="Montserrat"/>
+              </a:rPr>
+              <a:t>Sacos de até 30 kg, carga padronizada</a:t>
+            </a:r>
+          </a:p>
+        </p:txBody>
+      </p:sp>
+      <p:sp>
+        <p:nvSpPr>
+          <p:cNvPr id="16" name="Rectangle 15"/>
+          <p:cNvSpPr/>
+          <p:nvPr/>
+        </p:nvSpPr>
+        <p:spPr>
+          <a:xfrm>
+            <a:off x="6190488" y="2103120"/>
+            <a:ext cx="2514600" cy="2377440"/>
+          </a:xfrm>
+          <a:prstGeom prst="rect">
+            <a:avLst/>
+          </a:prstGeom>
+          <a:solidFill>
+            <a:srgbClr val="F4F5FC"/>
+          </a:solidFill>
+          <a:ln>
+            <a:noFill/>
+          </a:ln>
+          <a:effectLst/>
+        </p:spPr>
+        <p:txBody>
+          <a:bodyPr rtlCol="0" anchor="ctr"/>
+          <a:lstStyle/>
+          <a:p>
+            <a:pPr algn="ctr"/>
+          </a:p>
+        </p:txBody>
+      </p:sp>
+      <p:sp>
+        <p:nvSpPr>
+          <p:cNvPr id="17" name="Rectangle 16"/>
+          <p:cNvSpPr/>
+          <p:nvPr/>
+        </p:nvSpPr>
+        <p:spPr>
+          <a:xfrm>
+            <a:off x="6190488" y="2103120"/>
+            <a:ext cx="2514600" cy="54864"/>
+          </a:xfrm>
+          <a:prstGeom prst="rect">
+            <a:avLst/>
+          </a:prstGeom>
+          <a:solidFill>
+            <a:srgbClr val="12A87B"/>
+          </a:solidFill>
+          <a:ln>
+            <a:noFill/>
+          </a:ln>
+          <a:effectLst/>
+        </p:spPr>
+        <p:txBody>
+          <a:bodyPr rtlCol="0" anchor="ctr"/>
+          <a:lstStyle/>
+          <a:p>
+            <a:pPr algn="ctr"/>
+          </a:p>
+        </p:txBody>
+      </p:sp>
+      <p:sp>
+        <p:nvSpPr>
+          <p:cNvPr id="18" name="TextBox 17"/>
+          <p:cNvSpPr txBox="1"/>
+          <p:nvPr/>
+        </p:nvSpPr>
+        <p:spPr>
+          <a:xfrm>
+            <a:off x="6464808" y="2377440"/>
+            <a:ext cx="2194560" cy="731520"/>
+          </a:xfrm>
+          <a:prstGeom prst="rect">
+            <a:avLst/>
+          </a:prstGeom>
+          <a:noFill/>
+        </p:spPr>
+        <p:txBody>
+          <a:bodyPr wrap="square" lIns="0" rIns="0" tIns="0" bIns="0" anchor="t">
+            <a:spAutoFit/>
+          </a:bodyPr>
+          <a:lstStyle/>
+          <a:p>
+            <a:pPr algn="l">
+              <a:lnSpc>
+                <a:spcPct val="115000"/>
+              </a:lnSpc>
+            </a:pPr>
+            <a:r>
+              <a:rPr sz="3000" b="1">
+                <a:solidFill>
+                  <a:srgbClr val="12A87B"/>
+                </a:solidFill>
+                <a:latin typeface="Montserrat"/>
+              </a:rPr>
+              <a:t>~72</a:t>
+            </a:r>
+            <a:r>
+              <a:rPr sz="1100" b="0">
+                <a:solidFill>
+                  <a:srgbClr val="12A87B"/>
+                </a:solidFill>
+                <a:latin typeface="Montserrat"/>
+              </a:rPr>
+              <a:t> cargas/mês</a:t>
+            </a:r>
+          </a:p>
+        </p:txBody>
+      </p:sp>
+      <p:sp>
+        <p:nvSpPr>
+          <p:cNvPr id="19" name="TextBox 18"/>
+          <p:cNvSpPr txBox="1"/>
+          <p:nvPr/>
+        </p:nvSpPr>
+        <p:spPr>
+          <a:xfrm>
+            <a:off x="6464808" y="3246120"/>
+            <a:ext cx="2103120" cy="365760"/>
+          </a:xfrm>
+          <a:prstGeom prst="rect">
+            <a:avLst/>
+          </a:prstGeom>
+          <a:noFill/>
+        </p:spPr>
+        <p:txBody>
+          <a:bodyPr wrap="square" lIns="0" rIns="0" tIns="0" bIns="0" anchor="t">
+            <a:spAutoFit/>
+          </a:bodyPr>
+          <a:lstStyle/>
+          <a:p>
+            <a:pPr algn="l">
+              <a:lnSpc>
+                <a:spcPct val="115000"/>
+              </a:lnSpc>
+            </a:pPr>
+            <a:r>
+              <a:rPr sz="1200" b="1">
+                <a:solidFill>
+                  <a:srgbClr val="1B1B2F"/>
+                </a:solidFill>
+                <a:latin typeface="Montserrat"/>
+              </a:rPr>
+              <a:t>Entregas mensais</a:t>
+            </a:r>
+          </a:p>
+        </p:txBody>
+      </p:sp>
+      <p:sp>
+        <p:nvSpPr>
+          <p:cNvPr id="20" name="TextBox 19"/>
+          <p:cNvSpPr txBox="1"/>
+          <p:nvPr/>
+        </p:nvSpPr>
+        <p:spPr>
+          <a:xfrm>
+            <a:off x="6464808" y="3611880"/>
+            <a:ext cx="2103120" cy="731520"/>
+          </a:xfrm>
+          <a:prstGeom prst="rect">
+            <a:avLst/>
+          </a:prstGeom>
+          <a:noFill/>
+        </p:spPr>
+        <p:txBody>
+          <a:bodyPr wrap="square" lIns="0" rIns="0" tIns="0" bIns="0" anchor="t">
+            <a:spAutoFit/>
+          </a:bodyPr>
+          <a:lstStyle/>
+          <a:p>
+            <a:pPr algn="l">
+              <a:lnSpc>
+                <a:spcPct val="115000"/>
+              </a:lnSpc>
+            </a:pPr>
+            <a:r>
+              <a:rPr sz="1000" b="0">
+                <a:solidFill>
+                  <a:srgbClr val="6B6B80"/>
+                </a:solidFill>
+                <a:latin typeface="Montserrat"/>
+              </a:rPr>
+              <a:t>Cerca de 3 cargas por dia útil</a:t>
+            </a:r>
+          </a:p>
+        </p:txBody>
+      </p:sp>
+      <p:sp>
+        <p:nvSpPr>
+          <p:cNvPr id="21" name="Rectangle 20"/>
+          <p:cNvSpPr/>
+          <p:nvPr/>
+        </p:nvSpPr>
+        <p:spPr>
+          <a:xfrm>
+            <a:off x="8906256" y="2103120"/>
+            <a:ext cx="2514600" cy="2377440"/>
+          </a:xfrm>
+          <a:prstGeom prst="rect">
+            <a:avLst/>
+          </a:prstGeom>
+          <a:solidFill>
+            <a:srgbClr val="F4F5FC"/>
+          </a:solidFill>
+          <a:ln>
+            <a:noFill/>
+          </a:ln>
+          <a:effectLst/>
+        </p:spPr>
+        <p:txBody>
+          <a:bodyPr rtlCol="0" anchor="ctr"/>
+          <a:lstStyle/>
+          <a:p>
+            <a:pPr algn="ctr"/>
+          </a:p>
+        </p:txBody>
+      </p:sp>
+      <p:sp>
+        <p:nvSpPr>
+          <p:cNvPr id="22" name="Rectangle 21"/>
+          <p:cNvSpPr/>
+          <p:nvPr/>
+        </p:nvSpPr>
+        <p:spPr>
+          <a:xfrm>
+            <a:off x="8906256" y="2103120"/>
+            <a:ext cx="2514600" cy="54864"/>
+          </a:xfrm>
+          <a:prstGeom prst="rect">
+            <a:avLst/>
+          </a:prstGeom>
+          <a:solidFill>
+            <a:srgbClr val="3432C9"/>
+          </a:solidFill>
+          <a:ln>
+            <a:noFill/>
+          </a:ln>
+          <a:effectLst/>
+        </p:spPr>
+        <p:txBody>
+          <a:bodyPr rtlCol="0" anchor="ctr"/>
+          <a:lstStyle/>
+          <a:p>
+            <a:pPr algn="ctr"/>
+          </a:p>
+        </p:txBody>
+      </p:sp>
+      <p:sp>
+        <p:nvSpPr>
+          <p:cNvPr id="23" name="TextBox 22"/>
+          <p:cNvSpPr txBox="1"/>
+          <p:nvPr/>
+        </p:nvSpPr>
+        <p:spPr>
+          <a:xfrm>
+            <a:off x="9180576" y="2377440"/>
+            <a:ext cx="2194560" cy="731520"/>
+          </a:xfrm>
+          <a:prstGeom prst="rect">
+            <a:avLst/>
+          </a:prstGeom>
+          <a:noFill/>
+        </p:spPr>
+        <p:txBody>
+          <a:bodyPr wrap="square" lIns="0" rIns="0" tIns="0" bIns="0" anchor="t">
+            <a:spAutoFit/>
+          </a:bodyPr>
+          <a:lstStyle/>
+          <a:p>
+            <a:pPr algn="l">
+              <a:lnSpc>
+                <a:spcPct val="115000"/>
+              </a:lnSpc>
+            </a:pPr>
+            <a:r>
+              <a:rPr sz="3000" b="1">
+                <a:solidFill>
+                  <a:srgbClr val="3432C9"/>
+                </a:solidFill>
+                <a:latin typeface="Montserrat"/>
+              </a:rPr>
+              <a:t>~41.700</a:t>
+            </a:r>
+            <a:r>
+              <a:rPr sz="1100" b="0">
+                <a:solidFill>
+                  <a:srgbClr val="3432C9"/>
+                </a:solidFill>
+                <a:latin typeface="Montserrat"/>
+              </a:rPr>
+              <a:t> GJ/mês</a:t>
+            </a:r>
+          </a:p>
+        </p:txBody>
+      </p:sp>
+      <p:sp>
+        <p:nvSpPr>
+          <p:cNvPr id="24" name="TextBox 23"/>
+          <p:cNvSpPr txBox="1"/>
+          <p:nvPr/>
+        </p:nvSpPr>
+        <p:spPr>
+          <a:xfrm>
+            <a:off x="9180576" y="3246120"/>
+            <a:ext cx="2103120" cy="365760"/>
+          </a:xfrm>
+          <a:prstGeom prst="rect">
+            <a:avLst/>
+          </a:prstGeom>
+          <a:noFill/>
+        </p:spPr>
+        <p:txBody>
+          <a:bodyPr wrap="square" lIns="0" rIns="0" tIns="0" bIns="0" anchor="t">
+            <a:spAutoFit/>
+          </a:bodyPr>
+          <a:lstStyle/>
+          <a:p>
+            <a:pPr algn="l">
+              <a:lnSpc>
+                <a:spcPct val="115000"/>
+              </a:lnSpc>
+            </a:pPr>
+            <a:r>
+              <a:rPr sz="1200" b="1">
+                <a:solidFill>
+                  <a:srgbClr val="1B1B2F"/>
+                </a:solidFill>
+                <a:latin typeface="Montserrat"/>
+              </a:rPr>
+              <a:t>Energia disponível</a:t>
+            </a:r>
+          </a:p>
+        </p:txBody>
+      </p:sp>
+      <p:sp>
+        <p:nvSpPr>
+          <p:cNvPr id="25" name="TextBox 24"/>
+          <p:cNvSpPr txBox="1"/>
+          <p:nvPr/>
+        </p:nvSpPr>
+        <p:spPr>
+          <a:xfrm>
+            <a:off x="9180576" y="3611880"/>
+            <a:ext cx="2103120" cy="731520"/>
+          </a:xfrm>
+          <a:prstGeom prst="rect">
+            <a:avLst/>
+          </a:prstGeom>
+          <a:noFill/>
+        </p:spPr>
+        <p:txBody>
+          <a:bodyPr wrap="square" lIns="0" rIns="0" tIns="0" bIns="0" anchor="t">
+            <a:spAutoFit/>
+          </a:bodyPr>
+          <a:lstStyle/>
+          <a:p>
+            <a:pPr algn="l">
+              <a:lnSpc>
+                <a:spcPct val="115000"/>
+              </a:lnSpc>
+            </a:pPr>
+            <a:r>
+              <a:rPr sz="1000" b="0">
+                <a:solidFill>
+                  <a:srgbClr val="6B6B80"/>
+                </a:solidFill>
+                <a:latin typeface="Montserrat"/>
+              </a:rPr>
+              <a:t>≈ 9,95 bilhões de kcal/mês</a:t>
+            </a:r>
+          </a:p>
+        </p:txBody>
+      </p:sp>
+      <p:cxnSp>
+        <p:nvCxnSpPr>
+          <p:cNvPr id="26" name="Connector 25"/>
+          <p:cNvCxnSpPr/>
+          <p:nvPr/>
+        </p:nvCxnSpPr>
+        <p:spPr>
+          <a:xfrm>
+            <a:off x="758952" y="4800600"/>
+            <a:ext cx="10671048" cy="0"/>
+          </a:xfrm>
+          <a:prstGeom prst="line">
+            <a:avLst/>
+          </a:prstGeom>
+          <a:ln w="9525">
+            <a:solidFill>
+              <a:srgbClr val="DDDEEE"/>
+            </a:solidFill>
+          </a:ln>
+        </p:spPr>
+      </p:cxnSp>
+      <p:sp>
+        <p:nvSpPr>
+          <p:cNvPr id="27" name="TextBox 26"/>
+          <p:cNvSpPr txBox="1"/>
+          <p:nvPr/>
+        </p:nvSpPr>
+        <p:spPr>
+          <a:xfrm>
+            <a:off x="758952" y="4983480"/>
+            <a:ext cx="10607040" cy="457200"/>
+          </a:xfrm>
+          <a:prstGeom prst="rect">
+            <a:avLst/>
+          </a:prstGeom>
+          <a:noFill/>
+        </p:spPr>
+        <p:txBody>
+          <a:bodyPr wrap="square" lIns="0" rIns="0" tIns="0" bIns="0" anchor="t">
+            <a:spAutoFit/>
+          </a:bodyPr>
+          <a:lstStyle/>
+          <a:p>
+            <a:pPr algn="l">
+              <a:lnSpc>
+                <a:spcPct val="115000"/>
+              </a:lnSpc>
+            </a:pPr>
+            <a:r>
+              <a:rPr sz="1300" b="1">
+                <a:solidFill>
+                  <a:srgbClr val="3432C9"/>
+                </a:solidFill>
+                <a:latin typeface="Montserrat"/>
+              </a:rPr>
+              <a:t>Volume recorrente e escala </a:t>
+            </a:r>
+            <a:r>
+              <a:rPr sz="1300" b="0">
+                <a:solidFill>
+                  <a:srgbClr val="1B1B2F"/>
+                </a:solidFill>
+                <a:latin typeface="Montserrat"/>
+              </a:rPr>
+              <a:t>para substituir parte relevante do combustível do processo, com cronograma de entregas combinado com a operação.</a:t>
+            </a:r>
+          </a:p>
+        </p:txBody>
+      </p:sp>
+      <p:sp>
+        <p:nvSpPr>
+          <p:cNvPr id="28" name="TextBox 27"/>
+          <p:cNvSpPr txBox="1"/>
+          <p:nvPr/>
+        </p:nvSpPr>
+        <p:spPr>
+          <a:xfrm>
+            <a:off x="758952" y="5577840"/>
+            <a:ext cx="10607040" cy="320040"/>
+          </a:xfrm>
+          <a:prstGeom prst="rect">
+            <a:avLst/>
+          </a:prstGeom>
+          <a:noFill/>
+        </p:spPr>
+        <p:txBody>
+          <a:bodyPr wrap="square" lIns="0" rIns="0" tIns="0" bIns="0" anchor="t">
+            <a:spAutoFit/>
+          </a:bodyPr>
+          <a:lstStyle/>
+          <a:p>
+            <a:pPr algn="l">
+              <a:lnSpc>
+                <a:spcPct val="115000"/>
+              </a:lnSpc>
+            </a:pPr>
+            <a:r>
+              <a:rPr sz="900" b="0">
+                <a:solidFill>
+                  <a:srgbClr val="6B6B80"/>
+                </a:solidFill>
+                <a:latin typeface="Montserrat"/>
+              </a:rPr>
+              <a:t>Energia calculada pelo PCI em base seca do laudo (9.953,8 kcal/kg ≈ 41,7 MJ/kg).</a:t>
+            </a:r>
+          </a:p>
+        </p:txBody>
+      </p:sp>
+      <p:cxnSp>
+        <p:nvCxnSpPr>
+          <p:cNvPr id="29" name="Connector 28"/>
+          <p:cNvCxnSpPr/>
+          <p:nvPr/>
+        </p:nvCxnSpPr>
+        <p:spPr>
+          <a:xfrm>
+            <a:off x="758952" y="6199632"/>
+            <a:ext cx="10671048" cy="0"/>
+          </a:xfrm>
+          <a:prstGeom prst="line">
+            <a:avLst/>
+          </a:prstGeom>
+          <a:ln w="9525">
+            <a:solidFill>
+              <a:srgbClr val="DDDEEE"/>
+            </a:solidFill>
+          </a:ln>
+        </p:spPr>
+      </p:cxnSp>
+      <p:pic>
+        <p:nvPicPr>
+          <p:cNvPr id="30" name="Picture 29" descr="logo_dark.png"/>
+          <p:cNvPicPr>
+            <a:picLocks noChangeAspect="1"/>
+          </p:cNvPicPr>
+          <p:nvPr/>
+        </p:nvPicPr>
+        <p:blipFill>
+          <a:blip r:embed="rId2"/>
+          <a:stretch>
+            <a:fillRect/>
+          </a:stretch>
+        </p:blipFill>
+        <p:spPr>
+          <a:xfrm>
+            <a:off x="758952" y="6309360"/>
+            <a:ext cx="1150185" cy="274320"/>
+          </a:xfrm>
+          <a:prstGeom prst="rect">
+            <a:avLst/>
+          </a:prstGeom>
+        </p:spPr>
+      </p:pic>
+      <p:sp>
+        <p:nvSpPr>
+          <p:cNvPr id="31" name="TextBox 30"/>
+          <p:cNvSpPr txBox="1"/>
+          <p:nvPr/>
+        </p:nvSpPr>
+        <p:spPr>
+          <a:xfrm>
+            <a:off x="7772400" y="6355080"/>
+            <a:ext cx="3657600" cy="228600"/>
+          </a:xfrm>
+          <a:prstGeom prst="rect">
+            <a:avLst/>
+          </a:prstGeom>
+          <a:noFill/>
+        </p:spPr>
+        <p:txBody>
+          <a:bodyPr wrap="square" lIns="0" rIns="0" tIns="0" bIns="0" anchor="t">
+            <a:spAutoFit/>
+          </a:bodyPr>
+          <a:lstStyle/>
+          <a:p>
+            <a:pPr algn="r">
+              <a:lnSpc>
+                <a:spcPct val="115000"/>
+              </a:lnSpc>
+            </a:pPr>
+            <a:r>
+              <a:rPr sz="800" b="0">
+                <a:solidFill>
+                  <a:srgbClr val="6B6B80"/>
+                </a:solidFill>
+                <a:latin typeface="Montserrat"/>
+              </a:rPr>
+              <a:t>Resíduo Têxtil · Mineração   |   10</a:t>
+            </a:r>
+          </a:p>
+        </p:txBody>
+      </p:sp>
+    </p:spTree>
+  </p:cSld>
+  <p:clrMapOvr>
+    <a:masterClrMapping/>
+  </p:clrMapOvr>
+</p:sld>
+</file>
+
+<file path=ppt/slides/slide11.xml><?xml version="1.0" encoding="utf-8"?>
+<p:sld xmlns:a="http://schemas.openxmlformats.org/drawingml/2006/main" xmlns:p="http://schemas.openxmlformats.org/presentationml/2006/main" xmlns:r="http://schemas.openxmlformats.org/officeDocument/2006/relationships">
+  <p:cSld>
+    <p:bg>
+      <p:bgPr>
+        <a:solidFill>
+          <a:srgbClr val="FFFFFF"/>
+        </a:solidFill>
+        <a:effectLst/>
+      </p:bgPr>
+    </p:bg>
+    <p:spTree>
+      <p:nvGrpSpPr>
+        <p:cNvPr id="1" name=""/>
+        <p:cNvGrpSpPr/>
+        <p:nvPr/>
+      </p:nvGrpSpPr>
+      <p:grpSpPr/>
+      <p:cxnSp>
+        <p:nvCxnSpPr>
+          <p:cNvPr id="2" name="Connector 1"/>
+          <p:cNvCxnSpPr/>
+          <p:nvPr/>
+        </p:nvCxnSpPr>
+        <p:spPr>
+          <a:xfrm>
+            <a:off x="758952" y="594360"/>
+            <a:ext cx="292608" cy="0"/>
+          </a:xfrm>
+          <a:prstGeom prst="line">
+            <a:avLst/>
+          </a:prstGeom>
+          <a:ln w="12700">
+            <a:solidFill>
+              <a:srgbClr val="3432C9"/>
+            </a:solidFill>
+          </a:ln>
+        </p:spPr>
+      </p:cxnSp>
+      <p:sp>
+        <p:nvSpPr>
+          <p:cNvPr id="3" name="TextBox 2"/>
+          <p:cNvSpPr txBox="1"/>
+          <p:nvPr/>
+        </p:nvSpPr>
+        <p:spPr>
+          <a:xfrm>
+            <a:off x="1170432" y="502920"/>
+            <a:ext cx="5486400" cy="228600"/>
+          </a:xfrm>
+          <a:prstGeom prst="rect">
+            <a:avLst/>
+          </a:prstGeom>
+          <a:noFill/>
+        </p:spPr>
+        <p:txBody>
+          <a:bodyPr wrap="square" lIns="0" rIns="0" tIns="0" bIns="0" anchor="t">
+            <a:spAutoFit/>
+          </a:bodyPr>
+          <a:lstStyle/>
+          <a:p>
+            <a:pPr algn="l">
+              <a:lnSpc>
+                <a:spcPct val="115000"/>
+              </a:lnSpc>
+            </a:pPr>
+            <a:r>
+              <a:rPr sz="900" b="0" spc="200">
+                <a:solidFill>
+                  <a:srgbClr val="3432C9"/>
+                </a:solidFill>
+                <a:latin typeface="Montserrat"/>
+              </a:rPr>
               <a:t>Especificação</a:t>
             </a:r>
           </a:p>
@@ -3861,8 +4971,8 @@
           <p:nvPr/>
         </p:nvGraphicFramePr>
         <p:xfrm>
-          <a:off x="758952" y="1600200"/>
-          <a:ext cx="10671048" cy="4206240"/>
+          <a:off x="758952" y="1554480"/>
+          <a:ext cx="10671048" cy="4389120"/>
         </p:xfrm>
         <a:graphic>
           <a:graphicData uri="http://schemas.openxmlformats.org/drawingml/2006/table">
@@ -3874,7 +4984,7 @@
                 <a:gridCol w="3291840"/>
                 <a:gridCol w="7379208"/>
               </a:tblGrid>
-              <a:tr h="467360">
+              <a:tr h="438912">
                 <a:tc>
                   <a:txBody>
                     <a:bodyPr/>
@@ -3909,7 +5019,7 @@
                           </a:solidFill>
                           <a:latin typeface="Montserrat"/>
                         </a:rPr>
-                        <a:t>Resíduo têxtil pós-industrial picotado</a:t>
+                        <a:t>Resíduo têxtil pós-industrial picotado (mistura de fibras)</a:t>
                       </a:r>
                     </a:p>
                   </a:txBody>
@@ -3920,7 +5030,7 @@
                   </a:tcPr>
                 </a:tc>
               </a:tr>
-              <a:tr h="467360">
+              <a:tr h="438912">
                 <a:tc>
                   <a:txBody>
                     <a:bodyPr/>
@@ -3966,7 +5076,7 @@
                   </a:tcPr>
                 </a:tc>
               </a:tr>
-              <a:tr h="467360">
+              <a:tr h="438912">
                 <a:tc>
                   <a:txBody>
                     <a:bodyPr/>
@@ -4012,7 +5122,7 @@
                   </a:tcPr>
                 </a:tc>
               </a:tr>
-              <a:tr h="467360">
+              <a:tr h="438912">
                 <a:tc>
                   <a:txBody>
                     <a:bodyPr/>
@@ -4058,7 +5168,7 @@
                   </a:tcPr>
                 </a:tc>
               </a:tr>
-              <a:tr h="467360">
+              <a:tr h="438912">
                 <a:tc>
                   <a:txBody>
                     <a:bodyPr/>
@@ -4104,7 +5214,7 @@
                   </a:tcPr>
                 </a:tc>
               </a:tr>
-              <a:tr h="467360">
+              <a:tr h="438912">
                 <a:tc>
                   <a:txBody>
                     <a:bodyPr/>
@@ -4150,7 +5260,7 @@
                   </a:tcPr>
                 </a:tc>
               </a:tr>
-              <a:tr h="467360">
+              <a:tr h="438912">
                 <a:tc>
                   <a:txBody>
                     <a:bodyPr/>
@@ -4196,7 +5306,7 @@
                   </a:tcPr>
                 </a:tc>
               </a:tr>
-              <a:tr h="467360">
+              <a:tr h="438912">
                 <a:tc>
                   <a:txBody>
                     <a:bodyPr/>
@@ -4242,7 +5352,7 @@
                   </a:tcPr>
                 </a:tc>
               </a:tr>
-              <a:tr h="467360">
+              <a:tr h="438912">
                 <a:tc>
                   <a:txBody>
                     <a:bodyPr/>
@@ -4255,7 +5365,7 @@
                           </a:solidFill>
                           <a:latin typeface="Montserrat"/>
                         </a:rPr>
-                        <a:t>Documentação</a:t>
+                        <a:t>Capacidade</a:t>
                       </a:r>
                     </a:p>
                   </a:txBody>
@@ -4277,13 +5387,59 @@
                           </a:solidFill>
                           <a:latin typeface="Montserrat"/>
                         </a:rPr>
+                        <a:t>Até 1.000 t/mês, em cargas de 14 t</a:t>
+                      </a:r>
+                    </a:p>
+                  </a:txBody>
+                  <a:tcPr marL="228600" anchor="ctr">
+                    <a:solidFill>
+                      <a:srgbClr val="F4F5FC"/>
+                    </a:solidFill>
+                  </a:tcPr>
+                </a:tc>
+              </a:tr>
+              <a:tr h="438912">
+                <a:tc>
+                  <a:txBody>
+                    <a:bodyPr/>
+                    <a:lstStyle/>
+                    <a:p>
+                      <a:r>
+                        <a:rPr sz="1200" b="1">
+                          <a:solidFill>
+                            <a:srgbClr val="3432C9"/>
+                          </a:solidFill>
+                          <a:latin typeface="Montserrat"/>
+                        </a:rPr>
+                        <a:t>Documentação</a:t>
+                      </a:r>
+                    </a:p>
+                  </a:txBody>
+                  <a:tcPr marL="228600" anchor="ctr">
+                    <a:solidFill>
+                      <a:srgbClr val="FFFFFF"/>
+                    </a:solidFill>
+                  </a:tcPr>
+                </a:tc>
+                <a:tc>
+                  <a:txBody>
+                    <a:bodyPr/>
+                    <a:lstStyle/>
+                    <a:p>
+                      <a:r>
+                        <a:rPr sz="1200" b="0">
+                          <a:solidFill>
+                            <a:srgbClr val="1B1B2F"/>
+                          </a:solidFill>
+                          <a:latin typeface="Montserrat"/>
+                        </a:rPr>
                         <a:t>Laudo analítico, MTR e certificado de destinação por lote</a:t>
                       </a:r>
                     </a:p>
                   </a:txBody>
                   <a:tcPr marL="228600" anchor="ctr">
                     <a:solidFill>
-                      <a:srgbClr val="F4F5FC"/>
+                      <a:srgbClr val="FFFFFF"/>
                     </a:solidFill>
                   </a:tcPr>
                 </a:tc>
@@ -4340,869 +5496,6 @@
       <p:sp>
         <p:nvSpPr>
           <p:cNvPr id="8" name="TextBox 7"/>
-          <p:cNvSpPr txBox="1"/>
-          <p:nvPr/>
-        </p:nvSpPr>
-        <p:spPr>
-          <a:xfrm>
-            <a:off x="7772400" y="6355080"/>
-            <a:ext cx="3657600" cy="228600"/>
-          </a:xfrm>
-          <a:prstGeom prst="rect">
-            <a:avLst/>
-          </a:prstGeom>
-          <a:noFill/>
-        </p:spPr>
-        <p:txBody>
-          <a:bodyPr wrap="square" lIns="0" rIns="0" tIns="0" bIns="0" anchor="t">
-            <a:spAutoFit/>
-          </a:bodyPr>
-          <a:lstStyle/>
-          <a:p>
-            <a:pPr algn="r">
-              <a:lnSpc>
-                <a:spcPct val="115000"/>
-              </a:lnSpc>
-            </a:pPr>
-            <a:r>
-              <a:rPr sz="800" b="0">
-                <a:solidFill>
-                  <a:srgbClr val="6B6B80"/>
-                </a:solidFill>
-                <a:latin typeface="Montserrat"/>
-              </a:rPr>
-              <a:t>Resíduo Têxtil · Mineração   |   10</a:t>
-            </a:r>
-          </a:p>
-        </p:txBody>
-      </p:sp>
-    </p:spTree>
-  </p:cSld>
-  <p:clrMapOvr>
-    <a:masterClrMapping/>
-  </p:clrMapOvr>
-</p:sld>
-</file>
-
-<file path=ppt/slides/slide11.xml><?xml version="1.0" encoding="utf-8"?>
-<p:sld xmlns:a="http://schemas.openxmlformats.org/drawingml/2006/main" xmlns:p="http://schemas.openxmlformats.org/presentationml/2006/main" xmlns:r="http://schemas.openxmlformats.org/officeDocument/2006/relationships">
-  <p:cSld>
-    <p:bg>
-      <p:bgPr>
-        <a:solidFill>
-          <a:srgbClr val="FFFFFF"/>
-        </a:solidFill>
-        <a:effectLst/>
-      </p:bgPr>
-    </p:bg>
-    <p:spTree>
-      <p:nvGrpSpPr>
-        <p:cNvPr id="1" name=""/>
-        <p:cNvGrpSpPr/>
-        <p:nvPr/>
-      </p:nvGrpSpPr>
-      <p:grpSpPr/>
-      <p:cxnSp>
-        <p:nvCxnSpPr>
-          <p:cNvPr id="2" name="Connector 1"/>
-          <p:cNvCxnSpPr/>
-          <p:nvPr/>
-        </p:nvCxnSpPr>
-        <p:spPr>
-          <a:xfrm>
-            <a:off x="758952" y="594360"/>
-            <a:ext cx="292608" cy="0"/>
-          </a:xfrm>
-          <a:prstGeom prst="line">
-            <a:avLst/>
-          </a:prstGeom>
-          <a:ln w="12700">
-            <a:solidFill>
-              <a:srgbClr val="3432C9"/>
-            </a:solidFill>
-          </a:ln>
-        </p:spPr>
-      </p:cxnSp>
-      <p:sp>
-        <p:nvSpPr>
-          <p:cNvPr id="3" name="TextBox 2"/>
-          <p:cNvSpPr txBox="1"/>
-          <p:nvPr/>
-        </p:nvSpPr>
-        <p:spPr>
-          <a:xfrm>
-            <a:off x="1170432" y="502920"/>
-            <a:ext cx="5486400" cy="228600"/>
-          </a:xfrm>
-          <a:prstGeom prst="rect">
-            <a:avLst/>
-          </a:prstGeom>
-          <a:noFill/>
-        </p:spPr>
-        <p:txBody>
-          <a:bodyPr wrap="square" lIns="0" rIns="0" tIns="0" bIns="0" anchor="t">
-            <a:spAutoFit/>
-          </a:bodyPr>
-          <a:lstStyle/>
-          <a:p>
-            <a:pPr algn="l">
-              <a:lnSpc>
-                <a:spcPct val="115000"/>
-              </a:lnSpc>
-            </a:pPr>
-            <a:r>
-              <a:rPr sz="900" b="0" spc="200">
-                <a:solidFill>
-                  <a:srgbClr val="3432C9"/>
-                </a:solidFill>
-                <a:latin typeface="Montserrat"/>
-              </a:rPr>
-              <a:t>Conformidade</a:t>
-            </a:r>
-          </a:p>
-        </p:txBody>
-      </p:sp>
-      <p:sp>
-        <p:nvSpPr>
-          <p:cNvPr id="4" name="TextBox 3"/>
-          <p:cNvSpPr txBox="1"/>
-          <p:nvPr/>
-        </p:nvSpPr>
-        <p:spPr>
-          <a:xfrm>
-            <a:off x="758952" y="777240"/>
-            <a:ext cx="10698480" cy="640080"/>
-          </a:xfrm>
-          <a:prstGeom prst="rect">
-            <a:avLst/>
-          </a:prstGeom>
-          <a:noFill/>
-        </p:spPr>
-        <p:txBody>
-          <a:bodyPr wrap="square" lIns="0" rIns="0" tIns="0" bIns="0" anchor="t">
-            <a:spAutoFit/>
-          </a:bodyPr>
-          <a:lstStyle/>
-          <a:p>
-            <a:pPr algn="l">
-              <a:lnSpc>
-                <a:spcPct val="115000"/>
-              </a:lnSpc>
-            </a:pPr>
-            <a:r>
-              <a:rPr sz="2800" b="0">
-                <a:solidFill>
-                  <a:srgbClr val="1B1B2F"/>
-                </a:solidFill>
-                <a:latin typeface="Montserrat"/>
-              </a:rPr>
-              <a:t>Rastreabilidade e </a:t>
-            </a:r>
-            <a:r>
-              <a:rPr sz="2800" b="1">
-                <a:solidFill>
-                  <a:srgbClr val="1B1B2F"/>
-                </a:solidFill>
-                <a:latin typeface="Montserrat"/>
-              </a:rPr>
-              <a:t>conformidade ambiental</a:t>
-            </a:r>
-          </a:p>
-        </p:txBody>
-      </p:sp>
-      <p:sp>
-        <p:nvSpPr>
-          <p:cNvPr id="5" name="Rectangle 4"/>
-          <p:cNvSpPr/>
-          <p:nvPr/>
-        </p:nvSpPr>
-        <p:spPr>
-          <a:xfrm>
-            <a:off x="758952" y="1645920"/>
-            <a:ext cx="2514600" cy="2286000"/>
-          </a:xfrm>
-          <a:prstGeom prst="rect">
-            <a:avLst/>
-          </a:prstGeom>
-          <a:solidFill>
-            <a:srgbClr val="FFFFFF"/>
-          </a:solidFill>
-          <a:ln w="9525">
-            <a:solidFill>
-              <a:srgbClr val="DDDEEE"/>
-            </a:solidFill>
-          </a:ln>
-          <a:effectLst/>
-        </p:spPr>
-        <p:txBody>
-          <a:bodyPr rtlCol="0" anchor="ctr"/>
-          <a:lstStyle/>
-          <a:p>
-            <a:pPr algn="ctr"/>
-          </a:p>
-        </p:txBody>
-      </p:sp>
-      <p:sp>
-        <p:nvSpPr>
-          <p:cNvPr id="6" name="Rectangle 5"/>
-          <p:cNvSpPr/>
-          <p:nvPr/>
-        </p:nvSpPr>
-        <p:spPr>
-          <a:xfrm>
-            <a:off x="758952" y="1645920"/>
-            <a:ext cx="2514600" cy="54864"/>
-          </a:xfrm>
-          <a:prstGeom prst="rect">
-            <a:avLst/>
-          </a:prstGeom>
-          <a:solidFill>
-            <a:srgbClr val="3432C9"/>
-          </a:solidFill>
-          <a:ln>
-            <a:noFill/>
-          </a:ln>
-          <a:effectLst/>
-        </p:spPr>
-        <p:txBody>
-          <a:bodyPr rtlCol="0" anchor="ctr"/>
-          <a:lstStyle/>
-          <a:p>
-            <a:pPr algn="ctr"/>
-          </a:p>
-        </p:txBody>
-      </p:sp>
-      <p:sp>
-        <p:nvSpPr>
-          <p:cNvPr id="7" name="TextBox 6"/>
-          <p:cNvSpPr txBox="1"/>
-          <p:nvPr/>
-        </p:nvSpPr>
-        <p:spPr>
-          <a:xfrm>
-            <a:off x="1033271" y="1920240"/>
-            <a:ext cx="1965960" cy="365760"/>
-          </a:xfrm>
-          <a:prstGeom prst="rect">
-            <a:avLst/>
-          </a:prstGeom>
-          <a:noFill/>
-        </p:spPr>
-        <p:txBody>
-          <a:bodyPr wrap="square" lIns="0" rIns="0" tIns="0" bIns="0" anchor="t">
-            <a:spAutoFit/>
-          </a:bodyPr>
-          <a:lstStyle/>
-          <a:p>
-            <a:pPr algn="l">
-              <a:lnSpc>
-                <a:spcPct val="115000"/>
-              </a:lnSpc>
-            </a:pPr>
-            <a:r>
-              <a:rPr sz="1300" b="1">
-                <a:solidFill>
-                  <a:srgbClr val="1B1B2F"/>
-                </a:solidFill>
-                <a:latin typeface="Montserrat"/>
-              </a:rPr>
-              <a:t>MTR</a:t>
-            </a:r>
-          </a:p>
-        </p:txBody>
-      </p:sp>
-      <p:sp>
-        <p:nvSpPr>
-          <p:cNvPr id="8" name="TextBox 7"/>
-          <p:cNvSpPr txBox="1"/>
-          <p:nvPr/>
-        </p:nvSpPr>
-        <p:spPr>
-          <a:xfrm>
-            <a:off x="1033271" y="2331720"/>
-            <a:ext cx="1965960" cy="1508760"/>
-          </a:xfrm>
-          <a:prstGeom prst="rect">
-            <a:avLst/>
-          </a:prstGeom>
-          <a:noFill/>
-        </p:spPr>
-        <p:txBody>
-          <a:bodyPr wrap="square" lIns="0" rIns="0" tIns="0" bIns="0" anchor="t">
-            <a:spAutoFit/>
-          </a:bodyPr>
-          <a:lstStyle/>
-          <a:p>
-            <a:pPr algn="l">
-              <a:lnSpc>
-                <a:spcPct val="115000"/>
-              </a:lnSpc>
-            </a:pPr>
-            <a:r>
-              <a:rPr sz="1000" b="0">
-                <a:solidFill>
-                  <a:srgbClr val="6B6B80"/>
-                </a:solidFill>
-                <a:latin typeface="Montserrat"/>
-              </a:rPr>
-              <a:t>Manifesto de Transporte de Resíduos emitido em cada coleta e expedição.</a:t>
-            </a:r>
-          </a:p>
-        </p:txBody>
-      </p:sp>
-      <p:sp>
-        <p:nvSpPr>
-          <p:cNvPr id="9" name="Rectangle 8"/>
-          <p:cNvSpPr/>
-          <p:nvPr/>
-        </p:nvSpPr>
-        <p:spPr>
-          <a:xfrm>
-            <a:off x="3474720" y="1645920"/>
-            <a:ext cx="2514600" cy="2286000"/>
-          </a:xfrm>
-          <a:prstGeom prst="rect">
-            <a:avLst/>
-          </a:prstGeom>
-          <a:solidFill>
-            <a:srgbClr val="FFFFFF"/>
-          </a:solidFill>
-          <a:ln w="9525">
-            <a:solidFill>
-              <a:srgbClr val="DDDEEE"/>
-            </a:solidFill>
-          </a:ln>
-          <a:effectLst/>
-        </p:spPr>
-        <p:txBody>
-          <a:bodyPr rtlCol="0" anchor="ctr"/>
-          <a:lstStyle/>
-          <a:p>
-            <a:pPr algn="ctr"/>
-          </a:p>
-        </p:txBody>
-      </p:sp>
-      <p:sp>
-        <p:nvSpPr>
-          <p:cNvPr id="10" name="Rectangle 9"/>
-          <p:cNvSpPr/>
-          <p:nvPr/>
-        </p:nvSpPr>
-        <p:spPr>
-          <a:xfrm>
-            <a:off x="3474720" y="1645920"/>
-            <a:ext cx="2514600" cy="54864"/>
-          </a:xfrm>
-          <a:prstGeom prst="rect">
-            <a:avLst/>
-          </a:prstGeom>
-          <a:solidFill>
-            <a:srgbClr val="3432C9"/>
-          </a:solidFill>
-          <a:ln>
-            <a:noFill/>
-          </a:ln>
-          <a:effectLst/>
-        </p:spPr>
-        <p:txBody>
-          <a:bodyPr rtlCol="0" anchor="ctr"/>
-          <a:lstStyle/>
-          <a:p>
-            <a:pPr algn="ctr"/>
-          </a:p>
-        </p:txBody>
-      </p:sp>
-      <p:sp>
-        <p:nvSpPr>
-          <p:cNvPr id="11" name="TextBox 10"/>
-          <p:cNvSpPr txBox="1"/>
-          <p:nvPr/>
-        </p:nvSpPr>
-        <p:spPr>
-          <a:xfrm>
-            <a:off x="3749040" y="1920240"/>
-            <a:ext cx="1965960" cy="365760"/>
-          </a:xfrm>
-          <a:prstGeom prst="rect">
-            <a:avLst/>
-          </a:prstGeom>
-          <a:noFill/>
-        </p:spPr>
-        <p:txBody>
-          <a:bodyPr wrap="square" lIns="0" rIns="0" tIns="0" bIns="0" anchor="t">
-            <a:spAutoFit/>
-          </a:bodyPr>
-          <a:lstStyle/>
-          <a:p>
-            <a:pPr algn="l">
-              <a:lnSpc>
-                <a:spcPct val="115000"/>
-              </a:lnSpc>
-            </a:pPr>
-            <a:r>
-              <a:rPr sz="1300" b="1">
-                <a:solidFill>
-                  <a:srgbClr val="1B1B2F"/>
-                </a:solidFill>
-                <a:latin typeface="Montserrat"/>
-              </a:rPr>
-              <a:t>Laudo analítico</a:t>
-            </a:r>
-          </a:p>
-        </p:txBody>
-      </p:sp>
-      <p:sp>
-        <p:nvSpPr>
-          <p:cNvPr id="12" name="TextBox 11"/>
-          <p:cNvSpPr txBox="1"/>
-          <p:nvPr/>
-        </p:nvSpPr>
-        <p:spPr>
-          <a:xfrm>
-            <a:off x="3749040" y="2331720"/>
-            <a:ext cx="1965960" cy="1508760"/>
-          </a:xfrm>
-          <a:prstGeom prst="rect">
-            <a:avLst/>
-          </a:prstGeom>
-          <a:noFill/>
-        </p:spPr>
-        <p:txBody>
-          <a:bodyPr wrap="square" lIns="0" rIns="0" tIns="0" bIns="0" anchor="t">
-            <a:spAutoFit/>
-          </a:bodyPr>
-          <a:lstStyle/>
-          <a:p>
-            <a:pPr algn="l">
-              <a:lnSpc>
-                <a:spcPct val="115000"/>
-              </a:lnSpc>
-            </a:pPr>
-            <a:r>
-              <a:rPr sz="1000" b="0">
-                <a:solidFill>
-                  <a:srgbClr val="6B6B80"/>
-                </a:solidFill>
-                <a:latin typeface="Montserrat"/>
-              </a:rPr>
-              <a:t>Caracterização energética (PCI, cloro, umidade) do material fornecido.</a:t>
-            </a:r>
-          </a:p>
-        </p:txBody>
-      </p:sp>
-      <p:sp>
-        <p:nvSpPr>
-          <p:cNvPr id="13" name="Rectangle 12"/>
-          <p:cNvSpPr/>
-          <p:nvPr/>
-        </p:nvSpPr>
-        <p:spPr>
-          <a:xfrm>
-            <a:off x="6190488" y="1645920"/>
-            <a:ext cx="2514600" cy="2286000"/>
-          </a:xfrm>
-          <a:prstGeom prst="rect">
-            <a:avLst/>
-          </a:prstGeom>
-          <a:solidFill>
-            <a:srgbClr val="FFFFFF"/>
-          </a:solidFill>
-          <a:ln w="9525">
-            <a:solidFill>
-              <a:srgbClr val="DDDEEE"/>
-            </a:solidFill>
-          </a:ln>
-          <a:effectLst/>
-        </p:spPr>
-        <p:txBody>
-          <a:bodyPr rtlCol="0" anchor="ctr"/>
-          <a:lstStyle/>
-          <a:p>
-            <a:pPr algn="ctr"/>
-          </a:p>
-        </p:txBody>
-      </p:sp>
-      <p:sp>
-        <p:nvSpPr>
-          <p:cNvPr id="14" name="Rectangle 13"/>
-          <p:cNvSpPr/>
-          <p:nvPr/>
-        </p:nvSpPr>
-        <p:spPr>
-          <a:xfrm>
-            <a:off x="6190488" y="1645920"/>
-            <a:ext cx="2514600" cy="54864"/>
-          </a:xfrm>
-          <a:prstGeom prst="rect">
-            <a:avLst/>
-          </a:prstGeom>
-          <a:solidFill>
-            <a:srgbClr val="3432C9"/>
-          </a:solidFill>
-          <a:ln>
-            <a:noFill/>
-          </a:ln>
-          <a:effectLst/>
-        </p:spPr>
-        <p:txBody>
-          <a:bodyPr rtlCol="0" anchor="ctr"/>
-          <a:lstStyle/>
-          <a:p>
-            <a:pPr algn="ctr"/>
-          </a:p>
-        </p:txBody>
-      </p:sp>
-      <p:sp>
-        <p:nvSpPr>
-          <p:cNvPr id="15" name="TextBox 14"/>
-          <p:cNvSpPr txBox="1"/>
-          <p:nvPr/>
-        </p:nvSpPr>
-        <p:spPr>
-          <a:xfrm>
-            <a:off x="6464808" y="1920240"/>
-            <a:ext cx="1965960" cy="365760"/>
-          </a:xfrm>
-          <a:prstGeom prst="rect">
-            <a:avLst/>
-          </a:prstGeom>
-          <a:noFill/>
-        </p:spPr>
-        <p:txBody>
-          <a:bodyPr wrap="square" lIns="0" rIns="0" tIns="0" bIns="0" anchor="t">
-            <a:spAutoFit/>
-          </a:bodyPr>
-          <a:lstStyle/>
-          <a:p>
-            <a:pPr algn="l">
-              <a:lnSpc>
-                <a:spcPct val="115000"/>
-              </a:lnSpc>
-            </a:pPr>
-            <a:r>
-              <a:rPr sz="1300" b="1">
-                <a:solidFill>
-                  <a:srgbClr val="1B1B2F"/>
-                </a:solidFill>
-                <a:latin typeface="Montserrat"/>
-              </a:rPr>
-              <a:t>Controle por lote</a:t>
-            </a:r>
-          </a:p>
-        </p:txBody>
-      </p:sp>
-      <p:sp>
-        <p:nvSpPr>
-          <p:cNvPr id="16" name="TextBox 15"/>
-          <p:cNvSpPr txBox="1"/>
-          <p:nvPr/>
-        </p:nvSpPr>
-        <p:spPr>
-          <a:xfrm>
-            <a:off x="6464808" y="2331720"/>
-            <a:ext cx="1965960" cy="1508760"/>
-          </a:xfrm>
-          <a:prstGeom prst="rect">
-            <a:avLst/>
-          </a:prstGeom>
-          <a:noFill/>
-        </p:spPr>
-        <p:txBody>
-          <a:bodyPr wrap="square" lIns="0" rIns="0" tIns="0" bIns="0" anchor="t">
-            <a:spAutoFit/>
-          </a:bodyPr>
-          <a:lstStyle/>
-          <a:p>
-            <a:pPr algn="l">
-              <a:lnSpc>
-                <a:spcPct val="115000"/>
-              </a:lnSpc>
-            </a:pPr>
-            <a:r>
-              <a:rPr sz="1000" b="0">
-                <a:solidFill>
-                  <a:srgbClr val="6B6B80"/>
-                </a:solidFill>
-                <a:latin typeface="Montserrat"/>
-              </a:rPr>
-              <a:t>Registro fotográfico, pesagem e identificação de cada lote.</a:t>
-            </a:r>
-          </a:p>
-        </p:txBody>
-      </p:sp>
-      <p:sp>
-        <p:nvSpPr>
-          <p:cNvPr id="17" name="Rectangle 16"/>
-          <p:cNvSpPr/>
-          <p:nvPr/>
-        </p:nvSpPr>
-        <p:spPr>
-          <a:xfrm>
-            <a:off x="8906256" y="1645920"/>
-            <a:ext cx="2514600" cy="2286000"/>
-          </a:xfrm>
-          <a:prstGeom prst="rect">
-            <a:avLst/>
-          </a:prstGeom>
-          <a:solidFill>
-            <a:srgbClr val="FFFFFF"/>
-          </a:solidFill>
-          <a:ln w="9525">
-            <a:solidFill>
-              <a:srgbClr val="DDDEEE"/>
-            </a:solidFill>
-          </a:ln>
-          <a:effectLst/>
-        </p:spPr>
-        <p:txBody>
-          <a:bodyPr rtlCol="0" anchor="ctr"/>
-          <a:lstStyle/>
-          <a:p>
-            <a:pPr algn="ctr"/>
-          </a:p>
-        </p:txBody>
-      </p:sp>
-      <p:sp>
-        <p:nvSpPr>
-          <p:cNvPr id="18" name="Rectangle 17"/>
-          <p:cNvSpPr/>
-          <p:nvPr/>
-        </p:nvSpPr>
-        <p:spPr>
-          <a:xfrm>
-            <a:off x="8906256" y="1645920"/>
-            <a:ext cx="2514600" cy="54864"/>
-          </a:xfrm>
-          <a:prstGeom prst="rect">
-            <a:avLst/>
-          </a:prstGeom>
-          <a:solidFill>
-            <a:srgbClr val="12A87B"/>
-          </a:solidFill>
-          <a:ln>
-            <a:noFill/>
-          </a:ln>
-          <a:effectLst/>
-        </p:spPr>
-        <p:txBody>
-          <a:bodyPr rtlCol="0" anchor="ctr"/>
-          <a:lstStyle/>
-          <a:p>
-            <a:pPr algn="ctr"/>
-          </a:p>
-        </p:txBody>
-      </p:sp>
-      <p:sp>
-        <p:nvSpPr>
-          <p:cNvPr id="19" name="TextBox 18"/>
-          <p:cNvSpPr txBox="1"/>
-          <p:nvPr/>
-        </p:nvSpPr>
-        <p:spPr>
-          <a:xfrm>
-            <a:off x="9180576" y="1920240"/>
-            <a:ext cx="1965960" cy="365760"/>
-          </a:xfrm>
-          <a:prstGeom prst="rect">
-            <a:avLst/>
-          </a:prstGeom>
-          <a:noFill/>
-        </p:spPr>
-        <p:txBody>
-          <a:bodyPr wrap="square" lIns="0" rIns="0" tIns="0" bIns="0" anchor="t">
-            <a:spAutoFit/>
-          </a:bodyPr>
-          <a:lstStyle/>
-          <a:p>
-            <a:pPr algn="l">
-              <a:lnSpc>
-                <a:spcPct val="115000"/>
-              </a:lnSpc>
-            </a:pPr>
-            <a:r>
-              <a:rPr sz="1300" b="1">
-                <a:solidFill>
-                  <a:srgbClr val="1B1B2F"/>
-                </a:solidFill>
-                <a:latin typeface="Montserrat"/>
-              </a:rPr>
-              <a:t>Destinação comprovada</a:t>
-            </a:r>
-          </a:p>
-        </p:txBody>
-      </p:sp>
-      <p:sp>
-        <p:nvSpPr>
-          <p:cNvPr id="20" name="TextBox 19"/>
-          <p:cNvSpPr txBox="1"/>
-          <p:nvPr/>
-        </p:nvSpPr>
-        <p:spPr>
-          <a:xfrm>
-            <a:off x="9180576" y="2331720"/>
-            <a:ext cx="1965960" cy="1508760"/>
-          </a:xfrm>
-          <a:prstGeom prst="rect">
-            <a:avLst/>
-          </a:prstGeom>
-          <a:noFill/>
-        </p:spPr>
-        <p:txBody>
-          <a:bodyPr wrap="square" lIns="0" rIns="0" tIns="0" bIns="0" anchor="t">
-            <a:spAutoFit/>
-          </a:bodyPr>
-          <a:lstStyle/>
-          <a:p>
-            <a:pPr algn="l">
-              <a:lnSpc>
-                <a:spcPct val="115000"/>
-              </a:lnSpc>
-            </a:pPr>
-            <a:r>
-              <a:rPr sz="1000" b="0">
-                <a:solidFill>
-                  <a:srgbClr val="6B6B80"/>
-                </a:solidFill>
-                <a:latin typeface="Montserrat"/>
-              </a:rPr>
-              <a:t>Certificado de destinação final ambientalmente adequada.</a:t>
-            </a:r>
-          </a:p>
-        </p:txBody>
-      </p:sp>
-      <p:cxnSp>
-        <p:nvCxnSpPr>
-          <p:cNvPr id="21" name="Connector 20"/>
-          <p:cNvCxnSpPr/>
-          <p:nvPr/>
-        </p:nvCxnSpPr>
-        <p:spPr>
-          <a:xfrm>
-            <a:off x="758952" y="4297680"/>
-            <a:ext cx="10671048" cy="0"/>
-          </a:xfrm>
-          <a:prstGeom prst="line">
-            <a:avLst/>
-          </a:prstGeom>
-          <a:ln w="9525">
-            <a:solidFill>
-              <a:srgbClr val="DDDEEE"/>
-            </a:solidFill>
-          </a:ln>
-        </p:spPr>
-      </p:cxnSp>
-      <p:sp>
-        <p:nvSpPr>
-          <p:cNvPr id="22" name="TextBox 21"/>
-          <p:cNvSpPr txBox="1"/>
-          <p:nvPr/>
-        </p:nvSpPr>
-        <p:spPr>
-          <a:xfrm>
-            <a:off x="758952" y="4480560"/>
-            <a:ext cx="10607040" cy="1280160"/>
-          </a:xfrm>
-          <a:prstGeom prst="rect">
-            <a:avLst/>
-          </a:prstGeom>
-          <a:noFill/>
-        </p:spPr>
-        <p:txBody>
-          <a:bodyPr wrap="square" lIns="0" rIns="0" tIns="0" bIns="0" anchor="t">
-            <a:spAutoFit/>
-          </a:bodyPr>
-          <a:lstStyle/>
-          <a:p>
-            <a:pPr algn="l">
-              <a:lnSpc>
-                <a:spcPct val="140000"/>
-              </a:lnSpc>
-            </a:pPr>
-            <a:r>
-              <a:rPr sz="1500" b="1">
-                <a:solidFill>
-                  <a:srgbClr val="3432C9"/>
-                </a:solidFill>
-                <a:latin typeface="Montserrat"/>
-              </a:rPr>
-              <a:t>Rastreabilidade completa: </a:t>
-            </a:r>
-            <a:r>
-              <a:rPr sz="1500" b="0">
-                <a:solidFill>
-                  <a:srgbClr val="1B1B2F"/>
-                </a:solidFill>
-                <a:latin typeface="Montserrat"/>
-              </a:rPr>
-              <a:t>da indústria geradora ao forno da mineradora.</a:t>
-            </a:r>
-          </a:p>
-          <a:p>
-            <a:pPr algn="l">
-              <a:lnSpc>
-                <a:spcPct val="140000"/>
-              </a:lnSpc>
-            </a:pPr>
-            <a:r>
-              <a:rPr sz="1100" b="0">
-                <a:solidFill>
-                  <a:srgbClr val="6B6B80"/>
-                </a:solidFill>
-                <a:latin typeface="Montserrat"/>
-              </a:rPr>
-              <a:t>Apoio técnico à mineradora nas etapas de licenciamento para uso de combustível derivado de resíduo (ex.: Resolução SIMA nº 47/2020 no Estado de São Paulo).</a:t>
-            </a:r>
-          </a:p>
-        </p:txBody>
-      </p:sp>
-      <p:cxnSp>
-        <p:nvCxnSpPr>
-          <p:cNvPr id="23" name="Connector 22"/>
-          <p:cNvCxnSpPr/>
-          <p:nvPr/>
-        </p:nvCxnSpPr>
-        <p:spPr>
-          <a:xfrm>
-            <a:off x="758952" y="6199632"/>
-            <a:ext cx="10671048" cy="0"/>
-          </a:xfrm>
-          <a:prstGeom prst="line">
-            <a:avLst/>
-          </a:prstGeom>
-          <a:ln w="9525">
-            <a:solidFill>
-              <a:srgbClr val="DDDEEE"/>
-            </a:solidFill>
-          </a:ln>
-        </p:spPr>
-      </p:cxnSp>
-      <p:pic>
-        <p:nvPicPr>
-          <p:cNvPr id="24" name="Picture 23" descr="logo_dark.png"/>
-          <p:cNvPicPr>
-            <a:picLocks noChangeAspect="1"/>
-          </p:cNvPicPr>
-          <p:nvPr/>
-        </p:nvPicPr>
-        <p:blipFill>
-          <a:blip r:embed="rId2"/>
-          <a:stretch>
-            <a:fillRect/>
-          </a:stretch>
-        </p:blipFill>
-        <p:spPr>
-          <a:xfrm>
-            <a:off x="758952" y="6309360"/>
-            <a:ext cx="1150185" cy="274320"/>
-          </a:xfrm>
-          <a:prstGeom prst="rect">
-            <a:avLst/>
-          </a:prstGeom>
-        </p:spPr>
-      </p:pic>
-      <p:sp>
-        <p:nvSpPr>
-          <p:cNvPr id="25" name="TextBox 24"/>
           <p:cNvSpPr txBox="1"/>
           <p:nvPr/>
         </p:nvSpPr>
@@ -5320,7 +5613,7 @@
                 </a:solidFill>
                 <a:latin typeface="Montserrat"/>
               </a:rPr>
-              <a:t>Implantação</a:t>
+              <a:t>Conformidade</a:t>
             </a:r>
           </a:p>
         </p:txBody>
@@ -5359,7 +5652,7 @@
                 </a:solidFill>
                 <a:latin typeface="Montserrat"/>
               </a:rPr>
-              <a:t>Próximos </a:t>
+              <a:t>Rastreabilidade e </a:t>
             </a:r>
             <a:r>
               <a:rPr sz="2800" b="1">
@@ -5368,7 +5661,7 @@
                 </a:solidFill>
                 <a:latin typeface="Montserrat"/>
               </a:rPr>
-              <a:t>passos</a:t>
+              <a:t>conformidade ambiental</a:t>
             </a:r>
           </a:p>
         </p:txBody>
@@ -5381,17 +5674,19 @@
         </p:nvSpPr>
         <p:spPr>
           <a:xfrm>
-            <a:off x="758952" y="1828800"/>
-            <a:ext cx="2011680" cy="2743200"/>
+            <a:off x="758952" y="1645920"/>
+            <a:ext cx="2514600" cy="2286000"/>
           </a:xfrm>
           <a:prstGeom prst="rect">
             <a:avLst/>
           </a:prstGeom>
           <a:solidFill>
-            <a:srgbClr val="F4F5FC"/>
+            <a:srgbClr val="FFFFFF"/>
           </a:solidFill>
-          <a:ln>
-            <a:noFill/>
+          <a:ln w="9525">
+            <a:solidFill>
+              <a:srgbClr val="DDDEEE"/>
+            </a:solidFill>
           </a:ln>
           <a:effectLst/>
         </p:spPr>
@@ -5411,8 +5706,8 @@
         </p:nvSpPr>
         <p:spPr>
           <a:xfrm>
-            <a:off x="758952" y="1828800"/>
-            <a:ext cx="2011680" cy="54864"/>
+            <a:off x="758952" y="1645920"/>
+            <a:ext cx="2514600" cy="54864"/>
           </a:xfrm>
           <a:prstGeom prst="rect">
             <a:avLst/>
@@ -5441,8 +5736,8 @@
         </p:nvSpPr>
         <p:spPr>
           <a:xfrm>
-            <a:off x="987552" y="2103120"/>
-            <a:ext cx="1371600" cy="457200"/>
+            <a:off x="1033271" y="1920240"/>
+            <a:ext cx="1965960" cy="365760"/>
           </a:xfrm>
           <a:prstGeom prst="rect">
             <a:avLst/>
@@ -5461,13 +5756,13 @@
               </a:lnSpc>
             </a:pPr>
             <a:r>
-              <a:rPr sz="2400" b="0">
-                <a:solidFill>
-                  <a:srgbClr val="3432C9"/>
-                </a:solidFill>
-                <a:latin typeface="Montserrat"/>
-              </a:rPr>
-              <a:t>01</a:t>
+              <a:rPr sz="1300" b="1">
+                <a:solidFill>
+                  <a:srgbClr val="1B1B2F"/>
+                </a:solidFill>
+                <a:latin typeface="Montserrat"/>
+              </a:rPr>
+              <a:t>MTR</a:t>
             </a:r>
           </a:p>
         </p:txBody>
@@ -5480,8 +5775,8 @@
         </p:nvSpPr>
         <p:spPr>
           <a:xfrm>
-            <a:off x="987552" y="2743200"/>
-            <a:ext cx="1645920" cy="548640"/>
+            <a:off x="1033271" y="2331720"/>
+            <a:ext cx="1965960" cy="1508760"/>
           </a:xfrm>
           <a:prstGeom prst="rect">
             <a:avLst/>
@@ -5500,53 +5795,46 @@
               </a:lnSpc>
             </a:pPr>
             <a:r>
-              <a:rPr sz="1200" b="1">
-                <a:solidFill>
-                  <a:srgbClr val="1B1B2F"/>
-                </a:solidFill>
-                <a:latin typeface="Montserrat"/>
-              </a:rPr>
-              <a:t>Envio de amostra</a:t>
-            </a:r>
-          </a:p>
-        </p:txBody>
-      </p:sp>
-      <p:sp>
-        <p:nvSpPr>
-          <p:cNvPr id="9" name="TextBox 8"/>
-          <p:cNvSpPr txBox="1"/>
-          <p:nvPr/>
-        </p:nvSpPr>
-        <p:spPr>
-          <a:xfrm>
-            <a:off x="987552" y="3337560"/>
-            <a:ext cx="1645920" cy="1097280"/>
-          </a:xfrm>
-          <a:prstGeom prst="rect">
-            <a:avLst/>
-          </a:prstGeom>
-          <a:noFill/>
-        </p:spPr>
-        <p:txBody>
-          <a:bodyPr wrap="square" lIns="0" rIns="0" tIns="0" bIns="0" anchor="t">
-            <a:spAutoFit/>
-          </a:bodyPr>
-          <a:lstStyle/>
-          <a:p>
-            <a:pPr algn="l">
-              <a:lnSpc>
-                <a:spcPct val="115000"/>
-              </a:lnSpc>
-            </a:pPr>
-            <a:r>
               <a:rPr sz="1000" b="0">
                 <a:solidFill>
                   <a:srgbClr val="6B6B80"/>
                 </a:solidFill>
                 <a:latin typeface="Montserrat"/>
               </a:rPr>
-              <a:t>Material representativo para análise da mineradora.</a:t>
-            </a:r>
+              <a:t>Manifesto de Transporte de Resíduos emitido em cada coleta e expedição.</a:t>
+            </a:r>
+          </a:p>
+        </p:txBody>
+      </p:sp>
+      <p:sp>
+        <p:nvSpPr>
+          <p:cNvPr id="9" name="Rectangle 8"/>
+          <p:cNvSpPr/>
+          <p:nvPr/>
+        </p:nvSpPr>
+        <p:spPr>
+          <a:xfrm>
+            <a:off x="3474720" y="1645920"/>
+            <a:ext cx="2514600" cy="2286000"/>
+          </a:xfrm>
+          <a:prstGeom prst="rect">
+            <a:avLst/>
+          </a:prstGeom>
+          <a:solidFill>
+            <a:srgbClr val="FFFFFF"/>
+          </a:solidFill>
+          <a:ln w="9525">
+            <a:solidFill>
+              <a:srgbClr val="DDDEEE"/>
+            </a:solidFill>
+          </a:ln>
+          <a:effectLst/>
+        </p:spPr>
+        <p:txBody>
+          <a:bodyPr rtlCol="0" anchor="ctr"/>
+          <a:lstStyle/>
+          <a:p>
+            <a:pPr algn="ctr"/>
           </a:p>
         </p:txBody>
       </p:sp>
@@ -5558,38 +5846,8 @@
         </p:nvSpPr>
         <p:spPr>
           <a:xfrm>
-            <a:off x="2926080" y="1828800"/>
-            <a:ext cx="2011680" cy="2743200"/>
-          </a:xfrm>
-          <a:prstGeom prst="rect">
-            <a:avLst/>
-          </a:prstGeom>
-          <a:solidFill>
-            <a:srgbClr val="F4F5FC"/>
-          </a:solidFill>
-          <a:ln>
-            <a:noFill/>
-          </a:ln>
-          <a:effectLst/>
-        </p:spPr>
-        <p:txBody>
-          <a:bodyPr rtlCol="0" anchor="ctr"/>
-          <a:lstStyle/>
-          <a:p>
-            <a:pPr algn="ctr"/>
-          </a:p>
-        </p:txBody>
-      </p:sp>
-      <p:sp>
-        <p:nvSpPr>
-          <p:cNvPr id="11" name="Rectangle 10"/>
-          <p:cNvSpPr/>
-          <p:nvPr/>
-        </p:nvSpPr>
-        <p:spPr>
-          <a:xfrm>
-            <a:off x="2926080" y="1828800"/>
-            <a:ext cx="2011680" cy="54864"/>
+            <a:off x="3474720" y="1645920"/>
+            <a:ext cx="2514600" cy="54864"/>
           </a:xfrm>
           <a:prstGeom prst="rect">
             <a:avLst/>
@@ -5612,14 +5870,53 @@
       </p:sp>
       <p:sp>
         <p:nvSpPr>
+          <p:cNvPr id="11" name="TextBox 10"/>
+          <p:cNvSpPr txBox="1"/>
+          <p:nvPr/>
+        </p:nvSpPr>
+        <p:spPr>
+          <a:xfrm>
+            <a:off x="3749040" y="1920240"/>
+            <a:ext cx="1965960" cy="365760"/>
+          </a:xfrm>
+          <a:prstGeom prst="rect">
+            <a:avLst/>
+          </a:prstGeom>
+          <a:noFill/>
+        </p:spPr>
+        <p:txBody>
+          <a:bodyPr wrap="square" lIns="0" rIns="0" tIns="0" bIns="0" anchor="t">
+            <a:spAutoFit/>
+          </a:bodyPr>
+          <a:lstStyle/>
+          <a:p>
+            <a:pPr algn="l">
+              <a:lnSpc>
+                <a:spcPct val="115000"/>
+              </a:lnSpc>
+            </a:pPr>
+            <a:r>
+              <a:rPr sz="1300" b="1">
+                <a:solidFill>
+                  <a:srgbClr val="1B1B2F"/>
+                </a:solidFill>
+                <a:latin typeface="Montserrat"/>
+              </a:rPr>
+              <a:t>Laudo analítico</a:t>
+            </a:r>
+          </a:p>
+        </p:txBody>
+      </p:sp>
+      <p:sp>
+        <p:nvSpPr>
           <p:cNvPr id="12" name="TextBox 11"/>
           <p:cNvSpPr txBox="1"/>
           <p:nvPr/>
         </p:nvSpPr>
         <p:spPr>
           <a:xfrm>
-            <a:off x="3154680" y="2103120"/>
-            <a:ext cx="1371600" cy="457200"/>
+            <a:off x="3749040" y="2331720"/>
+            <a:ext cx="1965960" cy="1508760"/>
           </a:xfrm>
           <a:prstGeom prst="rect">
             <a:avLst/>
@@ -5638,114 +5935,38 @@
               </a:lnSpc>
             </a:pPr>
             <a:r>
-              <a:rPr sz="2400" b="0">
-                <a:solidFill>
-                  <a:srgbClr val="3432C9"/>
-                </a:solidFill>
-                <a:latin typeface="Montserrat"/>
-              </a:rPr>
-              <a:t>02</a:t>
-            </a:r>
-          </a:p>
-        </p:txBody>
-      </p:sp>
-      <p:sp>
-        <p:nvSpPr>
-          <p:cNvPr id="13" name="TextBox 12"/>
-          <p:cNvSpPr txBox="1"/>
-          <p:nvPr/>
-        </p:nvSpPr>
-        <p:spPr>
-          <a:xfrm>
-            <a:off x="3154680" y="2743200"/>
-            <a:ext cx="1645920" cy="548640"/>
-          </a:xfrm>
-          <a:prstGeom prst="rect">
-            <a:avLst/>
-          </a:prstGeom>
-          <a:noFill/>
-        </p:spPr>
-        <p:txBody>
-          <a:bodyPr wrap="square" lIns="0" rIns="0" tIns="0" bIns="0" anchor="t">
-            <a:spAutoFit/>
-          </a:bodyPr>
-          <a:lstStyle/>
-          <a:p>
-            <a:pPr algn="l">
-              <a:lnSpc>
-                <a:spcPct val="115000"/>
-              </a:lnSpc>
-            </a:pPr>
-            <a:r>
-              <a:rPr sz="1200" b="1">
-                <a:solidFill>
-                  <a:srgbClr val="1B1B2F"/>
-                </a:solidFill>
-                <a:latin typeface="Montserrat"/>
-              </a:rPr>
-              <a:t>Teste de queima</a:t>
-            </a:r>
-          </a:p>
-        </p:txBody>
-      </p:sp>
-      <p:sp>
-        <p:nvSpPr>
-          <p:cNvPr id="14" name="TextBox 13"/>
-          <p:cNvSpPr txBox="1"/>
-          <p:nvPr/>
-        </p:nvSpPr>
-        <p:spPr>
-          <a:xfrm>
-            <a:off x="3154680" y="3337560"/>
-            <a:ext cx="1645920" cy="1097280"/>
-          </a:xfrm>
-          <a:prstGeom prst="rect">
-            <a:avLst/>
-          </a:prstGeom>
-          <a:noFill/>
-        </p:spPr>
-        <p:txBody>
-          <a:bodyPr wrap="square" lIns="0" rIns="0" tIns="0" bIns="0" anchor="t">
-            <a:spAutoFit/>
-          </a:bodyPr>
-          <a:lstStyle/>
-          <a:p>
-            <a:pPr algn="l">
-              <a:lnSpc>
-                <a:spcPct val="115000"/>
-              </a:lnSpc>
-            </a:pPr>
-            <a:r>
               <a:rPr sz="1000" b="0">
                 <a:solidFill>
                   <a:srgbClr val="6B6B80"/>
                 </a:solidFill>
                 <a:latin typeface="Montserrat"/>
               </a:rPr>
-              <a:t>Ensaio controlado no equipamento de destino.</a:t>
-            </a:r>
-          </a:p>
-        </p:txBody>
-      </p:sp>
-      <p:sp>
-        <p:nvSpPr>
-          <p:cNvPr id="15" name="Rectangle 14"/>
+              <a:t>Caracterização energética (PCI, cloro, umidade) do material fornecido.</a:t>
+            </a:r>
+          </a:p>
+        </p:txBody>
+      </p:sp>
+      <p:sp>
+        <p:nvSpPr>
+          <p:cNvPr id="13" name="Rectangle 12"/>
           <p:cNvSpPr/>
           <p:nvPr/>
         </p:nvSpPr>
         <p:spPr>
           <a:xfrm>
-            <a:off x="5093208" y="1828800"/>
-            <a:ext cx="2011680" cy="2743200"/>
+            <a:off x="6190488" y="1645920"/>
+            <a:ext cx="2514600" cy="2286000"/>
           </a:xfrm>
           <a:prstGeom prst="rect">
             <a:avLst/>
           </a:prstGeom>
           <a:solidFill>
-            <a:srgbClr val="F4F5FC"/>
+            <a:srgbClr val="FFFFFF"/>
           </a:solidFill>
-          <a:ln>
-            <a:noFill/>
+          <a:ln w="9525">
+            <a:solidFill>
+              <a:srgbClr val="DDDEEE"/>
+            </a:solidFill>
           </a:ln>
           <a:effectLst/>
         </p:spPr>
@@ -5759,14 +5980,14 @@
       </p:sp>
       <p:sp>
         <p:nvSpPr>
-          <p:cNvPr id="16" name="Rectangle 15"/>
+          <p:cNvPr id="14" name="Rectangle 13"/>
           <p:cNvSpPr/>
           <p:nvPr/>
         </p:nvSpPr>
         <p:spPr>
           <a:xfrm>
-            <a:off x="5093208" y="1828800"/>
-            <a:ext cx="2011680" cy="54864"/>
+            <a:off x="6190488" y="1645920"/>
+            <a:ext cx="2514600" cy="54864"/>
           </a:xfrm>
           <a:prstGeom prst="rect">
             <a:avLst/>
@@ -5789,14 +6010,14 @@
       </p:sp>
       <p:sp>
         <p:nvSpPr>
-          <p:cNvPr id="17" name="TextBox 16"/>
-          <p:cNvSpPr txBox="1"/>
-          <p:nvPr/>
-        </p:nvSpPr>
-        <p:spPr>
-          <a:xfrm>
-            <a:off x="5321808" y="2103120"/>
-            <a:ext cx="1371600" cy="457200"/>
+          <p:cNvPr id="15" name="TextBox 14"/>
+          <p:cNvSpPr txBox="1"/>
+          <p:nvPr/>
+        </p:nvSpPr>
+        <p:spPr>
+          <a:xfrm>
+            <a:off x="6464808" y="1920240"/>
+            <a:ext cx="1965960" cy="365760"/>
           </a:xfrm>
           <a:prstGeom prst="rect">
             <a:avLst/>
@@ -5815,27 +6036,27 @@
               </a:lnSpc>
             </a:pPr>
             <a:r>
-              <a:rPr sz="2400" b="0">
-                <a:solidFill>
-                  <a:srgbClr val="3432C9"/>
-                </a:solidFill>
-                <a:latin typeface="Montserrat"/>
-              </a:rPr>
-              <a:t>03</a:t>
-            </a:r>
-          </a:p>
-        </p:txBody>
-      </p:sp>
-      <p:sp>
-        <p:nvSpPr>
-          <p:cNvPr id="18" name="TextBox 17"/>
-          <p:cNvSpPr txBox="1"/>
-          <p:nvPr/>
-        </p:nvSpPr>
-        <p:spPr>
-          <a:xfrm>
-            <a:off x="5321808" y="2743200"/>
-            <a:ext cx="1645920" cy="548640"/>
+              <a:rPr sz="1300" b="1">
+                <a:solidFill>
+                  <a:srgbClr val="1B1B2F"/>
+                </a:solidFill>
+                <a:latin typeface="Montserrat"/>
+              </a:rPr>
+              <a:t>Controle por lote</a:t>
+            </a:r>
+          </a:p>
+        </p:txBody>
+      </p:sp>
+      <p:sp>
+        <p:nvSpPr>
+          <p:cNvPr id="16" name="TextBox 15"/>
+          <p:cNvSpPr txBox="1"/>
+          <p:nvPr/>
+        </p:nvSpPr>
+        <p:spPr>
+          <a:xfrm>
+            <a:off x="6464808" y="2331720"/>
+            <a:ext cx="1965960" cy="1508760"/>
           </a:xfrm>
           <a:prstGeom prst="rect">
             <a:avLst/>
@@ -5854,75 +6075,38 @@
               </a:lnSpc>
             </a:pPr>
             <a:r>
-              <a:rPr sz="1200" b="1">
-                <a:solidFill>
-                  <a:srgbClr val="1B1B2F"/>
-                </a:solidFill>
-                <a:latin typeface="Montserrat"/>
-              </a:rPr>
-              <a:t>Licenciamento</a:t>
-            </a:r>
-          </a:p>
-        </p:txBody>
-      </p:sp>
-      <p:sp>
-        <p:nvSpPr>
-          <p:cNvPr id="19" name="TextBox 18"/>
-          <p:cNvSpPr txBox="1"/>
-          <p:nvPr/>
-        </p:nvSpPr>
-        <p:spPr>
-          <a:xfrm>
-            <a:off x="5321808" y="3337560"/>
-            <a:ext cx="1645920" cy="1097280"/>
-          </a:xfrm>
-          <a:prstGeom prst="rect">
-            <a:avLst/>
-          </a:prstGeom>
-          <a:noFill/>
-        </p:spPr>
-        <p:txBody>
-          <a:bodyPr wrap="square" lIns="0" rIns="0" tIns="0" bIns="0" anchor="t">
-            <a:spAutoFit/>
-          </a:bodyPr>
-          <a:lstStyle/>
-          <a:p>
-            <a:pPr algn="l">
-              <a:lnSpc>
-                <a:spcPct val="115000"/>
-              </a:lnSpc>
-            </a:pPr>
-            <a:r>
               <a:rPr sz="1000" b="0">
                 <a:solidFill>
                   <a:srgbClr val="6B6B80"/>
                 </a:solidFill>
                 <a:latin typeface="Montserrat"/>
               </a:rPr>
-              <a:t>Adequação da licença para uso do combustível alternativo.</a:t>
-            </a:r>
-          </a:p>
-        </p:txBody>
-      </p:sp>
-      <p:sp>
-        <p:nvSpPr>
-          <p:cNvPr id="20" name="Rectangle 19"/>
+              <a:t>Registro fotográfico, pesagem e identificação de cada lote.</a:t>
+            </a:r>
+          </a:p>
+        </p:txBody>
+      </p:sp>
+      <p:sp>
+        <p:nvSpPr>
+          <p:cNvPr id="17" name="Rectangle 16"/>
           <p:cNvSpPr/>
           <p:nvPr/>
         </p:nvSpPr>
         <p:spPr>
           <a:xfrm>
-            <a:off x="7260336" y="1828800"/>
-            <a:ext cx="2011680" cy="2743200"/>
+            <a:off x="8906256" y="1645920"/>
+            <a:ext cx="2514600" cy="2286000"/>
           </a:xfrm>
           <a:prstGeom prst="rect">
             <a:avLst/>
           </a:prstGeom>
           <a:solidFill>
-            <a:srgbClr val="F4F5FC"/>
+            <a:srgbClr val="FFFFFF"/>
           </a:solidFill>
-          <a:ln>
-            <a:noFill/>
+          <a:ln w="9525">
+            <a:solidFill>
+              <a:srgbClr val="DDDEEE"/>
+            </a:solidFill>
           </a:ln>
           <a:effectLst/>
         </p:spPr>
@@ -5936,191 +6120,14 @@
       </p:sp>
       <p:sp>
         <p:nvSpPr>
-          <p:cNvPr id="21" name="Rectangle 20"/>
+          <p:cNvPr id="18" name="Rectangle 17"/>
           <p:cNvSpPr/>
           <p:nvPr/>
         </p:nvSpPr>
         <p:spPr>
           <a:xfrm>
-            <a:off x="7260336" y="1828800"/>
-            <a:ext cx="2011680" cy="54864"/>
-          </a:xfrm>
-          <a:prstGeom prst="rect">
-            <a:avLst/>
-          </a:prstGeom>
-          <a:solidFill>
-            <a:srgbClr val="3432C9"/>
-          </a:solidFill>
-          <a:ln>
-            <a:noFill/>
-          </a:ln>
-          <a:effectLst/>
-        </p:spPr>
-        <p:txBody>
-          <a:bodyPr rtlCol="0" anchor="ctr"/>
-          <a:lstStyle/>
-          <a:p>
-            <a:pPr algn="ctr"/>
-          </a:p>
-        </p:txBody>
-      </p:sp>
-      <p:sp>
-        <p:nvSpPr>
-          <p:cNvPr id="22" name="TextBox 21"/>
-          <p:cNvSpPr txBox="1"/>
-          <p:nvPr/>
-        </p:nvSpPr>
-        <p:spPr>
-          <a:xfrm>
-            <a:off x="7488936" y="2103120"/>
-            <a:ext cx="1371600" cy="457200"/>
-          </a:xfrm>
-          <a:prstGeom prst="rect">
-            <a:avLst/>
-          </a:prstGeom>
-          <a:noFill/>
-        </p:spPr>
-        <p:txBody>
-          <a:bodyPr wrap="square" lIns="0" rIns="0" tIns="0" bIns="0" anchor="t">
-            <a:spAutoFit/>
-          </a:bodyPr>
-          <a:lstStyle/>
-          <a:p>
-            <a:pPr algn="l">
-              <a:lnSpc>
-                <a:spcPct val="115000"/>
-              </a:lnSpc>
-            </a:pPr>
-            <a:r>
-              <a:rPr sz="2400" b="0">
-                <a:solidFill>
-                  <a:srgbClr val="3432C9"/>
-                </a:solidFill>
-                <a:latin typeface="Montserrat"/>
-              </a:rPr>
-              <a:t>04</a:t>
-            </a:r>
-          </a:p>
-        </p:txBody>
-      </p:sp>
-      <p:sp>
-        <p:nvSpPr>
-          <p:cNvPr id="23" name="TextBox 22"/>
-          <p:cNvSpPr txBox="1"/>
-          <p:nvPr/>
-        </p:nvSpPr>
-        <p:spPr>
-          <a:xfrm>
-            <a:off x="7488936" y="2743200"/>
-            <a:ext cx="1645920" cy="548640"/>
-          </a:xfrm>
-          <a:prstGeom prst="rect">
-            <a:avLst/>
-          </a:prstGeom>
-          <a:noFill/>
-        </p:spPr>
-        <p:txBody>
-          <a:bodyPr wrap="square" lIns="0" rIns="0" tIns="0" bIns="0" anchor="t">
-            <a:spAutoFit/>
-          </a:bodyPr>
-          <a:lstStyle/>
-          <a:p>
-            <a:pPr algn="l">
-              <a:lnSpc>
-                <a:spcPct val="115000"/>
-              </a:lnSpc>
-            </a:pPr>
-            <a:r>
-              <a:rPr sz="1200" b="1">
-                <a:solidFill>
-                  <a:srgbClr val="1B1B2F"/>
-                </a:solidFill>
-                <a:latin typeface="Montserrat"/>
-              </a:rPr>
-              <a:t>Fornecimento piloto</a:t>
-            </a:r>
-          </a:p>
-        </p:txBody>
-      </p:sp>
-      <p:sp>
-        <p:nvSpPr>
-          <p:cNvPr id="24" name="TextBox 23"/>
-          <p:cNvSpPr txBox="1"/>
-          <p:nvPr/>
-        </p:nvSpPr>
-        <p:spPr>
-          <a:xfrm>
-            <a:off x="7488936" y="3337560"/>
-            <a:ext cx="1645920" cy="1097280"/>
-          </a:xfrm>
-          <a:prstGeom prst="rect">
-            <a:avLst/>
-          </a:prstGeom>
-          <a:noFill/>
-        </p:spPr>
-        <p:txBody>
-          <a:bodyPr wrap="square" lIns="0" rIns="0" tIns="0" bIns="0" anchor="t">
-            <a:spAutoFit/>
-          </a:bodyPr>
-          <a:lstStyle/>
-          <a:p>
-            <a:pPr algn="l">
-              <a:lnSpc>
-                <a:spcPct val="115000"/>
-              </a:lnSpc>
-            </a:pPr>
-            <a:r>
-              <a:rPr sz="1000" b="0">
-                <a:solidFill>
-                  <a:srgbClr val="6B6B80"/>
-                </a:solidFill>
-                <a:latin typeface="Montserrat"/>
-              </a:rPr>
-              <a:t>Lotes iniciais com monitoramento de desempenho.</a:t>
-            </a:r>
-          </a:p>
-        </p:txBody>
-      </p:sp>
-      <p:sp>
-        <p:nvSpPr>
-          <p:cNvPr id="25" name="Rectangle 24"/>
-          <p:cNvSpPr/>
-          <p:nvPr/>
-        </p:nvSpPr>
-        <p:spPr>
-          <a:xfrm>
-            <a:off x="9427464" y="1828800"/>
-            <a:ext cx="2011680" cy="2743200"/>
-          </a:xfrm>
-          <a:prstGeom prst="rect">
-            <a:avLst/>
-          </a:prstGeom>
-          <a:solidFill>
-            <a:srgbClr val="F4F5FC"/>
-          </a:solidFill>
-          <a:ln>
-            <a:noFill/>
-          </a:ln>
-          <a:effectLst/>
-        </p:spPr>
-        <p:txBody>
-          <a:bodyPr rtlCol="0" anchor="ctr"/>
-          <a:lstStyle/>
-          <a:p>
-            <a:pPr algn="ctr"/>
-          </a:p>
-        </p:txBody>
-      </p:sp>
-      <p:sp>
-        <p:nvSpPr>
-          <p:cNvPr id="26" name="Rectangle 25"/>
-          <p:cNvSpPr/>
-          <p:nvPr/>
-        </p:nvSpPr>
-        <p:spPr>
-          <a:xfrm>
-            <a:off x="9427464" y="1828800"/>
-            <a:ext cx="2011680" cy="54864"/>
+            <a:off x="8906256" y="1645920"/>
+            <a:ext cx="2514600" cy="54864"/>
           </a:xfrm>
           <a:prstGeom prst="rect">
             <a:avLst/>
@@ -6143,14 +6150,14 @@
       </p:sp>
       <p:sp>
         <p:nvSpPr>
-          <p:cNvPr id="27" name="TextBox 26"/>
-          <p:cNvSpPr txBox="1"/>
-          <p:nvPr/>
-        </p:nvSpPr>
-        <p:spPr>
-          <a:xfrm>
-            <a:off x="9656064" y="2103120"/>
-            <a:ext cx="1371600" cy="457200"/>
+          <p:cNvPr id="19" name="TextBox 18"/>
+          <p:cNvSpPr txBox="1"/>
+          <p:nvPr/>
+        </p:nvSpPr>
+        <p:spPr>
+          <a:xfrm>
+            <a:off x="9180576" y="1920240"/>
+            <a:ext cx="1965960" cy="365760"/>
           </a:xfrm>
           <a:prstGeom prst="rect">
             <a:avLst/>
@@ -6169,27 +6176,27 @@
               </a:lnSpc>
             </a:pPr>
             <a:r>
-              <a:rPr sz="2400" b="0">
-                <a:solidFill>
-                  <a:srgbClr val="12A87B"/>
-                </a:solidFill>
-                <a:latin typeface="Montserrat"/>
-              </a:rPr>
-              <a:t>05</a:t>
-            </a:r>
-          </a:p>
-        </p:txBody>
-      </p:sp>
-      <p:sp>
-        <p:nvSpPr>
-          <p:cNvPr id="28" name="TextBox 27"/>
-          <p:cNvSpPr txBox="1"/>
-          <p:nvPr/>
-        </p:nvSpPr>
-        <p:spPr>
-          <a:xfrm>
-            <a:off x="9656064" y="2743200"/>
-            <a:ext cx="1645920" cy="548640"/>
+              <a:rPr sz="1300" b="1">
+                <a:solidFill>
+                  <a:srgbClr val="1B1B2F"/>
+                </a:solidFill>
+                <a:latin typeface="Montserrat"/>
+              </a:rPr>
+              <a:t>Destinação comprovada</a:t>
+            </a:r>
+          </a:p>
+        </p:txBody>
+      </p:sp>
+      <p:sp>
+        <p:nvSpPr>
+          <p:cNvPr id="20" name="TextBox 19"/>
+          <p:cNvSpPr txBox="1"/>
+          <p:nvPr/>
+        </p:nvSpPr>
+        <p:spPr>
+          <a:xfrm>
+            <a:off x="9180576" y="2331720"/>
+            <a:ext cx="1965960" cy="1508760"/>
           </a:xfrm>
           <a:prstGeom prst="rect">
             <a:avLst/>
@@ -6208,113 +6215,26 @@
               </a:lnSpc>
             </a:pPr>
             <a:r>
-              <a:rPr sz="1200" b="1">
-                <a:solidFill>
-                  <a:srgbClr val="1B1B2F"/>
-                </a:solidFill>
-                <a:latin typeface="Montserrat"/>
-              </a:rPr>
-              <a:t>Contrato contínuo</a:t>
-            </a:r>
-          </a:p>
-        </p:txBody>
-      </p:sp>
-      <p:sp>
-        <p:nvSpPr>
-          <p:cNvPr id="29" name="TextBox 28"/>
-          <p:cNvSpPr txBox="1"/>
-          <p:nvPr/>
-        </p:nvSpPr>
-        <p:spPr>
-          <a:xfrm>
-            <a:off x="9656064" y="3337560"/>
-            <a:ext cx="1645920" cy="1097280"/>
-          </a:xfrm>
-          <a:prstGeom prst="rect">
-            <a:avLst/>
-          </a:prstGeom>
-          <a:noFill/>
-        </p:spPr>
-        <p:txBody>
-          <a:bodyPr wrap="square" lIns="0" rIns="0" tIns="0" bIns="0" anchor="t">
-            <a:spAutoFit/>
-          </a:bodyPr>
-          <a:lstStyle/>
-          <a:p>
-            <a:pPr algn="l">
-              <a:lnSpc>
-                <a:spcPct val="115000"/>
-              </a:lnSpc>
-            </a:pPr>
-            <a:r>
               <a:rPr sz="1000" b="0">
                 <a:solidFill>
                   <a:srgbClr val="6B6B80"/>
                 </a:solidFill>
                 <a:latin typeface="Montserrat"/>
               </a:rPr>
-              <a:t>Fornecimento regular e programado.</a:t>
-            </a:r>
-          </a:p>
-        </p:txBody>
-      </p:sp>
-      <p:sp>
-        <p:nvSpPr>
-          <p:cNvPr id="30" name="TextBox 29"/>
-          <p:cNvSpPr txBox="1"/>
-          <p:nvPr/>
-        </p:nvSpPr>
-        <p:spPr>
-          <a:xfrm>
-            <a:off x="758952" y="4892040"/>
-            <a:ext cx="10607040" cy="731520"/>
-          </a:xfrm>
-          <a:prstGeom prst="rect">
-            <a:avLst/>
-          </a:prstGeom>
-          <a:noFill/>
-        </p:spPr>
-        <p:txBody>
-          <a:bodyPr wrap="square" lIns="0" rIns="0" tIns="0" bIns="0" anchor="t">
-            <a:spAutoFit/>
-          </a:bodyPr>
-          <a:lstStyle/>
-          <a:p>
-            <a:pPr algn="l">
-              <a:lnSpc>
-                <a:spcPct val="115000"/>
-              </a:lnSpc>
-            </a:pPr>
-            <a:r>
-              <a:rPr sz="1200" b="1">
-                <a:solidFill>
-                  <a:srgbClr val="3432C9"/>
-                </a:solidFill>
-                <a:latin typeface="Montserrat"/>
-              </a:rPr>
-              <a:t>Condições comerciais </a:t>
-            </a:r>
-            <a:r>
-              <a:rPr sz="1200" b="0">
-                <a:solidFill>
-                  <a:srgbClr val="6B6B80"/>
-                </a:solidFill>
-                <a:latin typeface="Montserrat"/>
-              </a:rPr>
-              <a:t>(preço, volume mensal e frete) a serem definidas em reunião, conforme a demanda e a especificação técnica da operação.</a:t>
+              <a:t>Certificado de destinação final ambientalmente adequada.</a:t>
             </a:r>
           </a:p>
         </p:txBody>
       </p:sp>
       <p:cxnSp>
         <p:nvCxnSpPr>
-          <p:cNvPr id="31" name="Connector 30"/>
+          <p:cNvPr id="21" name="Connector 20"/>
           <p:cNvCxnSpPr/>
           <p:nvPr/>
         </p:nvCxnSpPr>
         <p:spPr>
           <a:xfrm>
-            <a:off x="758952" y="6199632"/>
+            <a:off x="758952" y="4297680"/>
             <a:ext cx="10671048" cy="0"/>
           </a:xfrm>
           <a:prstGeom prst="line">
@@ -6327,9 +6247,94 @@
           </a:ln>
         </p:spPr>
       </p:cxnSp>
+      <p:sp>
+        <p:nvSpPr>
+          <p:cNvPr id="22" name="TextBox 21"/>
+          <p:cNvSpPr txBox="1"/>
+          <p:nvPr/>
+        </p:nvSpPr>
+        <p:spPr>
+          <a:xfrm>
+            <a:off x="758952" y="4480560"/>
+            <a:ext cx="10607040" cy="1280160"/>
+          </a:xfrm>
+          <a:prstGeom prst="rect">
+            <a:avLst/>
+          </a:prstGeom>
+          <a:noFill/>
+        </p:spPr>
+        <p:txBody>
+          <a:bodyPr wrap="square" lIns="0" rIns="0" tIns="0" bIns="0" anchor="t">
+            <a:spAutoFit/>
+          </a:bodyPr>
+          <a:lstStyle/>
+          <a:p>
+            <a:pPr algn="l">
+              <a:lnSpc>
+                <a:spcPct val="140000"/>
+              </a:lnSpc>
+            </a:pPr>
+            <a:r>
+              <a:rPr sz="1500" b="1">
+                <a:solidFill>
+                  <a:srgbClr val="3432C9"/>
+                </a:solidFill>
+                <a:latin typeface="Montserrat"/>
+              </a:rPr>
+              <a:t>Rastreabilidade completa: </a:t>
+            </a:r>
+            <a:r>
+              <a:rPr sz="1500" b="0">
+                <a:solidFill>
+                  <a:srgbClr val="1B1B2F"/>
+                </a:solidFill>
+                <a:latin typeface="Montserrat"/>
+              </a:rPr>
+              <a:t>da indústria geradora ao forno da mineradora.</a:t>
+            </a:r>
+          </a:p>
+          <a:p>
+            <a:pPr algn="l">
+              <a:lnSpc>
+                <a:spcPct val="140000"/>
+              </a:lnSpc>
+            </a:pPr>
+            <a:r>
+              <a:rPr sz="1100" b="0">
+                <a:solidFill>
+                  <a:srgbClr val="6B6B80"/>
+                </a:solidFill>
+                <a:latin typeface="Montserrat"/>
+              </a:rPr>
+              <a:t>Apoio técnico à mineradora nas etapas de licenciamento para uso de combustível derivado de resíduo (ex.: Resolução SIMA nº 47/2020 no Estado de São Paulo).</a:t>
+            </a:r>
+          </a:p>
+        </p:txBody>
+      </p:sp>
+      <p:cxnSp>
+        <p:nvCxnSpPr>
+          <p:cNvPr id="23" name="Connector 22"/>
+          <p:cNvCxnSpPr/>
+          <p:nvPr/>
+        </p:nvCxnSpPr>
+        <p:spPr>
+          <a:xfrm>
+            <a:off x="758952" y="6199632"/>
+            <a:ext cx="10671048" cy="0"/>
+          </a:xfrm>
+          <a:prstGeom prst="line">
+            <a:avLst/>
+          </a:prstGeom>
+          <a:ln w="9525">
+            <a:solidFill>
+              <a:srgbClr val="DDDEEE"/>
+            </a:solidFill>
+          </a:ln>
+        </p:spPr>
+      </p:cxnSp>
       <p:pic>
         <p:nvPicPr>
-          <p:cNvPr id="32" name="Picture 31" descr="logo_dark.png"/>
+          <p:cNvPr id="24" name="Picture 23" descr="logo_dark.png"/>
           <p:cNvPicPr>
             <a:picLocks noChangeAspect="1"/>
           </p:cNvPicPr>
@@ -6353,7 +6358,7 @@
       </p:pic>
       <p:sp>
         <p:nvSpPr>
-          <p:cNvPr id="33" name="TextBox 32"/>
+          <p:cNvPr id="25" name="TextBox 24"/>
           <p:cNvSpPr txBox="1"/>
           <p:nvPr/>
         </p:nvSpPr>
@@ -6399,6 +6404,1157 @@
 </file>
 
 <file path=ppt/slides/slide13.xml><?xml version="1.0" encoding="utf-8"?>
+<p:sld xmlns:a="http://schemas.openxmlformats.org/drawingml/2006/main" xmlns:p="http://schemas.openxmlformats.org/presentationml/2006/main" xmlns:r="http://schemas.openxmlformats.org/officeDocument/2006/relationships">
+  <p:cSld>
+    <p:bg>
+      <p:bgPr>
+        <a:solidFill>
+          <a:srgbClr val="FFFFFF"/>
+        </a:solidFill>
+        <a:effectLst/>
+      </p:bgPr>
+    </p:bg>
+    <p:spTree>
+      <p:nvGrpSpPr>
+        <p:cNvPr id="1" name=""/>
+        <p:cNvGrpSpPr/>
+        <p:nvPr/>
+      </p:nvGrpSpPr>
+      <p:grpSpPr/>
+      <p:cxnSp>
+        <p:nvCxnSpPr>
+          <p:cNvPr id="2" name="Connector 1"/>
+          <p:cNvCxnSpPr/>
+          <p:nvPr/>
+        </p:nvCxnSpPr>
+        <p:spPr>
+          <a:xfrm>
+            <a:off x="758952" y="594360"/>
+            <a:ext cx="292608" cy="0"/>
+          </a:xfrm>
+          <a:prstGeom prst="line">
+            <a:avLst/>
+          </a:prstGeom>
+          <a:ln w="12700">
+            <a:solidFill>
+              <a:srgbClr val="3432C9"/>
+            </a:solidFill>
+          </a:ln>
+        </p:spPr>
+      </p:cxnSp>
+      <p:sp>
+        <p:nvSpPr>
+          <p:cNvPr id="3" name="TextBox 2"/>
+          <p:cNvSpPr txBox="1"/>
+          <p:nvPr/>
+        </p:nvSpPr>
+        <p:spPr>
+          <a:xfrm>
+            <a:off x="1170432" y="502920"/>
+            <a:ext cx="5486400" cy="228600"/>
+          </a:xfrm>
+          <a:prstGeom prst="rect">
+            <a:avLst/>
+          </a:prstGeom>
+          <a:noFill/>
+        </p:spPr>
+        <p:txBody>
+          <a:bodyPr wrap="square" lIns="0" rIns="0" tIns="0" bIns="0" anchor="t">
+            <a:spAutoFit/>
+          </a:bodyPr>
+          <a:lstStyle/>
+          <a:p>
+            <a:pPr algn="l">
+              <a:lnSpc>
+                <a:spcPct val="115000"/>
+              </a:lnSpc>
+            </a:pPr>
+            <a:r>
+              <a:rPr sz="900" b="0" spc="200">
+                <a:solidFill>
+                  <a:srgbClr val="3432C9"/>
+                </a:solidFill>
+                <a:latin typeface="Montserrat"/>
+              </a:rPr>
+              <a:t>Implantação</a:t>
+            </a:r>
+          </a:p>
+        </p:txBody>
+      </p:sp>
+      <p:sp>
+        <p:nvSpPr>
+          <p:cNvPr id="4" name="TextBox 3"/>
+          <p:cNvSpPr txBox="1"/>
+          <p:nvPr/>
+        </p:nvSpPr>
+        <p:spPr>
+          <a:xfrm>
+            <a:off x="758952" y="777240"/>
+            <a:ext cx="10698480" cy="640080"/>
+          </a:xfrm>
+          <a:prstGeom prst="rect">
+            <a:avLst/>
+          </a:prstGeom>
+          <a:noFill/>
+        </p:spPr>
+        <p:txBody>
+          <a:bodyPr wrap="square" lIns="0" rIns="0" tIns="0" bIns="0" anchor="t">
+            <a:spAutoFit/>
+          </a:bodyPr>
+          <a:lstStyle/>
+          <a:p>
+            <a:pPr algn="l">
+              <a:lnSpc>
+                <a:spcPct val="115000"/>
+              </a:lnSpc>
+            </a:pPr>
+            <a:r>
+              <a:rPr sz="2800" b="0">
+                <a:solidFill>
+                  <a:srgbClr val="1B1B2F"/>
+                </a:solidFill>
+                <a:latin typeface="Montserrat"/>
+              </a:rPr>
+              <a:t>Próximos </a:t>
+            </a:r>
+            <a:r>
+              <a:rPr sz="2800" b="1">
+                <a:solidFill>
+                  <a:srgbClr val="1B1B2F"/>
+                </a:solidFill>
+                <a:latin typeface="Montserrat"/>
+              </a:rPr>
+              <a:t>passos</a:t>
+            </a:r>
+          </a:p>
+        </p:txBody>
+      </p:sp>
+      <p:sp>
+        <p:nvSpPr>
+          <p:cNvPr id="5" name="Rectangle 4"/>
+          <p:cNvSpPr/>
+          <p:nvPr/>
+        </p:nvSpPr>
+        <p:spPr>
+          <a:xfrm>
+            <a:off x="758952" y="1828800"/>
+            <a:ext cx="2011680" cy="2743200"/>
+          </a:xfrm>
+          <a:prstGeom prst="rect">
+            <a:avLst/>
+          </a:prstGeom>
+          <a:solidFill>
+            <a:srgbClr val="F4F5FC"/>
+          </a:solidFill>
+          <a:ln>
+            <a:noFill/>
+          </a:ln>
+          <a:effectLst/>
+        </p:spPr>
+        <p:txBody>
+          <a:bodyPr rtlCol="0" anchor="ctr"/>
+          <a:lstStyle/>
+          <a:p>
+            <a:pPr algn="ctr"/>
+          </a:p>
+        </p:txBody>
+      </p:sp>
+      <p:sp>
+        <p:nvSpPr>
+          <p:cNvPr id="6" name="Rectangle 5"/>
+          <p:cNvSpPr/>
+          <p:nvPr/>
+        </p:nvSpPr>
+        <p:spPr>
+          <a:xfrm>
+            <a:off x="758952" y="1828800"/>
+            <a:ext cx="2011680" cy="54864"/>
+          </a:xfrm>
+          <a:prstGeom prst="rect">
+            <a:avLst/>
+          </a:prstGeom>
+          <a:solidFill>
+            <a:srgbClr val="3432C9"/>
+          </a:solidFill>
+          <a:ln>
+            <a:noFill/>
+          </a:ln>
+          <a:effectLst/>
+        </p:spPr>
+        <p:txBody>
+          <a:bodyPr rtlCol="0" anchor="ctr"/>
+          <a:lstStyle/>
+          <a:p>
+            <a:pPr algn="ctr"/>
+          </a:p>
+        </p:txBody>
+      </p:sp>
+      <p:sp>
+        <p:nvSpPr>
+          <p:cNvPr id="7" name="TextBox 6"/>
+          <p:cNvSpPr txBox="1"/>
+          <p:nvPr/>
+        </p:nvSpPr>
+        <p:spPr>
+          <a:xfrm>
+            <a:off x="987552" y="2103120"/>
+            <a:ext cx="1371600" cy="457200"/>
+          </a:xfrm>
+          <a:prstGeom prst="rect">
+            <a:avLst/>
+          </a:prstGeom>
+          <a:noFill/>
+        </p:spPr>
+        <p:txBody>
+          <a:bodyPr wrap="square" lIns="0" rIns="0" tIns="0" bIns="0" anchor="t">
+            <a:spAutoFit/>
+          </a:bodyPr>
+          <a:lstStyle/>
+          <a:p>
+            <a:pPr algn="l">
+              <a:lnSpc>
+                <a:spcPct val="115000"/>
+              </a:lnSpc>
+            </a:pPr>
+            <a:r>
+              <a:rPr sz="2400" b="0">
+                <a:solidFill>
+                  <a:srgbClr val="3432C9"/>
+                </a:solidFill>
+                <a:latin typeface="Montserrat"/>
+              </a:rPr>
+              <a:t>01</a:t>
+            </a:r>
+          </a:p>
+        </p:txBody>
+      </p:sp>
+      <p:sp>
+        <p:nvSpPr>
+          <p:cNvPr id="8" name="TextBox 7"/>
+          <p:cNvSpPr txBox="1"/>
+          <p:nvPr/>
+        </p:nvSpPr>
+        <p:spPr>
+          <a:xfrm>
+            <a:off x="987552" y="2743200"/>
+            <a:ext cx="1645920" cy="548640"/>
+          </a:xfrm>
+          <a:prstGeom prst="rect">
+            <a:avLst/>
+          </a:prstGeom>
+          <a:noFill/>
+        </p:spPr>
+        <p:txBody>
+          <a:bodyPr wrap="square" lIns="0" rIns="0" tIns="0" bIns="0" anchor="t">
+            <a:spAutoFit/>
+          </a:bodyPr>
+          <a:lstStyle/>
+          <a:p>
+            <a:pPr algn="l">
+              <a:lnSpc>
+                <a:spcPct val="115000"/>
+              </a:lnSpc>
+            </a:pPr>
+            <a:r>
+              <a:rPr sz="1200" b="1">
+                <a:solidFill>
+                  <a:srgbClr val="1B1B2F"/>
+                </a:solidFill>
+                <a:latin typeface="Montserrat"/>
+              </a:rPr>
+              <a:t>Envio de amostra</a:t>
+            </a:r>
+          </a:p>
+        </p:txBody>
+      </p:sp>
+      <p:sp>
+        <p:nvSpPr>
+          <p:cNvPr id="9" name="TextBox 8"/>
+          <p:cNvSpPr txBox="1"/>
+          <p:nvPr/>
+        </p:nvSpPr>
+        <p:spPr>
+          <a:xfrm>
+            <a:off x="987552" y="3337560"/>
+            <a:ext cx="1645920" cy="1097280"/>
+          </a:xfrm>
+          <a:prstGeom prst="rect">
+            <a:avLst/>
+          </a:prstGeom>
+          <a:noFill/>
+        </p:spPr>
+        <p:txBody>
+          <a:bodyPr wrap="square" lIns="0" rIns="0" tIns="0" bIns="0" anchor="t">
+            <a:spAutoFit/>
+          </a:bodyPr>
+          <a:lstStyle/>
+          <a:p>
+            <a:pPr algn="l">
+              <a:lnSpc>
+                <a:spcPct val="115000"/>
+              </a:lnSpc>
+            </a:pPr>
+            <a:r>
+              <a:rPr sz="1000" b="0">
+                <a:solidFill>
+                  <a:srgbClr val="6B6B80"/>
+                </a:solidFill>
+                <a:latin typeface="Montserrat"/>
+              </a:rPr>
+              <a:t>Material representativo para análise da mineradora.</a:t>
+            </a:r>
+          </a:p>
+        </p:txBody>
+      </p:sp>
+      <p:sp>
+        <p:nvSpPr>
+          <p:cNvPr id="10" name="Rectangle 9"/>
+          <p:cNvSpPr/>
+          <p:nvPr/>
+        </p:nvSpPr>
+        <p:spPr>
+          <a:xfrm>
+            <a:off x="2926080" y="1828800"/>
+            <a:ext cx="2011680" cy="2743200"/>
+          </a:xfrm>
+          <a:prstGeom prst="rect">
+            <a:avLst/>
+          </a:prstGeom>
+          <a:solidFill>
+            <a:srgbClr val="F4F5FC"/>
+          </a:solidFill>
+          <a:ln>
+            <a:noFill/>
+          </a:ln>
+          <a:effectLst/>
+        </p:spPr>
+        <p:txBody>
+          <a:bodyPr rtlCol="0" anchor="ctr"/>
+          <a:lstStyle/>
+          <a:p>
+            <a:pPr algn="ctr"/>
+          </a:p>
+        </p:txBody>
+      </p:sp>
+      <p:sp>
+        <p:nvSpPr>
+          <p:cNvPr id="11" name="Rectangle 10"/>
+          <p:cNvSpPr/>
+          <p:nvPr/>
+        </p:nvSpPr>
+        <p:spPr>
+          <a:xfrm>
+            <a:off x="2926080" y="1828800"/>
+            <a:ext cx="2011680" cy="54864"/>
+          </a:xfrm>
+          <a:prstGeom prst="rect">
+            <a:avLst/>
+          </a:prstGeom>
+          <a:solidFill>
+            <a:srgbClr val="3432C9"/>
+          </a:solidFill>
+          <a:ln>
+            <a:noFill/>
+          </a:ln>
+          <a:effectLst/>
+        </p:spPr>
+        <p:txBody>
+          <a:bodyPr rtlCol="0" anchor="ctr"/>
+          <a:lstStyle/>
+          <a:p>
+            <a:pPr algn="ctr"/>
+          </a:p>
+        </p:txBody>
+      </p:sp>
+      <p:sp>
+        <p:nvSpPr>
+          <p:cNvPr id="12" name="TextBox 11"/>
+          <p:cNvSpPr txBox="1"/>
+          <p:nvPr/>
+        </p:nvSpPr>
+        <p:spPr>
+          <a:xfrm>
+            <a:off x="3154680" y="2103120"/>
+            <a:ext cx="1371600" cy="457200"/>
+          </a:xfrm>
+          <a:prstGeom prst="rect">
+            <a:avLst/>
+          </a:prstGeom>
+          <a:noFill/>
+        </p:spPr>
+        <p:txBody>
+          <a:bodyPr wrap="square" lIns="0" rIns="0" tIns="0" bIns="0" anchor="t">
+            <a:spAutoFit/>
+          </a:bodyPr>
+          <a:lstStyle/>
+          <a:p>
+            <a:pPr algn="l">
+              <a:lnSpc>
+                <a:spcPct val="115000"/>
+              </a:lnSpc>
+            </a:pPr>
+            <a:r>
+              <a:rPr sz="2400" b="0">
+                <a:solidFill>
+                  <a:srgbClr val="3432C9"/>
+                </a:solidFill>
+                <a:latin typeface="Montserrat"/>
+              </a:rPr>
+              <a:t>02</a:t>
+            </a:r>
+          </a:p>
+        </p:txBody>
+      </p:sp>
+      <p:sp>
+        <p:nvSpPr>
+          <p:cNvPr id="13" name="TextBox 12"/>
+          <p:cNvSpPr txBox="1"/>
+          <p:nvPr/>
+        </p:nvSpPr>
+        <p:spPr>
+          <a:xfrm>
+            <a:off x="3154680" y="2743200"/>
+            <a:ext cx="1645920" cy="548640"/>
+          </a:xfrm>
+          <a:prstGeom prst="rect">
+            <a:avLst/>
+          </a:prstGeom>
+          <a:noFill/>
+        </p:spPr>
+        <p:txBody>
+          <a:bodyPr wrap="square" lIns="0" rIns="0" tIns="0" bIns="0" anchor="t">
+            <a:spAutoFit/>
+          </a:bodyPr>
+          <a:lstStyle/>
+          <a:p>
+            <a:pPr algn="l">
+              <a:lnSpc>
+                <a:spcPct val="115000"/>
+              </a:lnSpc>
+            </a:pPr>
+            <a:r>
+              <a:rPr sz="1200" b="1">
+                <a:solidFill>
+                  <a:srgbClr val="1B1B2F"/>
+                </a:solidFill>
+                <a:latin typeface="Montserrat"/>
+              </a:rPr>
+              <a:t>Teste de queima</a:t>
+            </a:r>
+          </a:p>
+        </p:txBody>
+      </p:sp>
+      <p:sp>
+        <p:nvSpPr>
+          <p:cNvPr id="14" name="TextBox 13"/>
+          <p:cNvSpPr txBox="1"/>
+          <p:nvPr/>
+        </p:nvSpPr>
+        <p:spPr>
+          <a:xfrm>
+            <a:off x="3154680" y="3337560"/>
+            <a:ext cx="1645920" cy="1097280"/>
+          </a:xfrm>
+          <a:prstGeom prst="rect">
+            <a:avLst/>
+          </a:prstGeom>
+          <a:noFill/>
+        </p:spPr>
+        <p:txBody>
+          <a:bodyPr wrap="square" lIns="0" rIns="0" tIns="0" bIns="0" anchor="t">
+            <a:spAutoFit/>
+          </a:bodyPr>
+          <a:lstStyle/>
+          <a:p>
+            <a:pPr algn="l">
+              <a:lnSpc>
+                <a:spcPct val="115000"/>
+              </a:lnSpc>
+            </a:pPr>
+            <a:r>
+              <a:rPr sz="1000" b="0">
+                <a:solidFill>
+                  <a:srgbClr val="6B6B80"/>
+                </a:solidFill>
+                <a:latin typeface="Montserrat"/>
+              </a:rPr>
+              <a:t>Ensaio controlado no equipamento de destino.</a:t>
+            </a:r>
+          </a:p>
+        </p:txBody>
+      </p:sp>
+      <p:sp>
+        <p:nvSpPr>
+          <p:cNvPr id="15" name="Rectangle 14"/>
+          <p:cNvSpPr/>
+          <p:nvPr/>
+        </p:nvSpPr>
+        <p:spPr>
+          <a:xfrm>
+            <a:off x="5093208" y="1828800"/>
+            <a:ext cx="2011680" cy="2743200"/>
+          </a:xfrm>
+          <a:prstGeom prst="rect">
+            <a:avLst/>
+          </a:prstGeom>
+          <a:solidFill>
+            <a:srgbClr val="F4F5FC"/>
+          </a:solidFill>
+          <a:ln>
+            <a:noFill/>
+          </a:ln>
+          <a:effectLst/>
+        </p:spPr>
+        <p:txBody>
+          <a:bodyPr rtlCol="0" anchor="ctr"/>
+          <a:lstStyle/>
+          <a:p>
+            <a:pPr algn="ctr"/>
+          </a:p>
+        </p:txBody>
+      </p:sp>
+      <p:sp>
+        <p:nvSpPr>
+          <p:cNvPr id="16" name="Rectangle 15"/>
+          <p:cNvSpPr/>
+          <p:nvPr/>
+        </p:nvSpPr>
+        <p:spPr>
+          <a:xfrm>
+            <a:off x="5093208" y="1828800"/>
+            <a:ext cx="2011680" cy="54864"/>
+          </a:xfrm>
+          <a:prstGeom prst="rect">
+            <a:avLst/>
+          </a:prstGeom>
+          <a:solidFill>
+            <a:srgbClr val="3432C9"/>
+          </a:solidFill>
+          <a:ln>
+            <a:noFill/>
+          </a:ln>
+          <a:effectLst/>
+        </p:spPr>
+        <p:txBody>
+          <a:bodyPr rtlCol="0" anchor="ctr"/>
+          <a:lstStyle/>
+          <a:p>
+            <a:pPr algn="ctr"/>
+          </a:p>
+        </p:txBody>
+      </p:sp>
+      <p:sp>
+        <p:nvSpPr>
+          <p:cNvPr id="17" name="TextBox 16"/>
+          <p:cNvSpPr txBox="1"/>
+          <p:nvPr/>
+        </p:nvSpPr>
+        <p:spPr>
+          <a:xfrm>
+            <a:off x="5321808" y="2103120"/>
+            <a:ext cx="1371600" cy="457200"/>
+          </a:xfrm>
+          <a:prstGeom prst="rect">
+            <a:avLst/>
+          </a:prstGeom>
+          <a:noFill/>
+        </p:spPr>
+        <p:txBody>
+          <a:bodyPr wrap="square" lIns="0" rIns="0" tIns="0" bIns="0" anchor="t">
+            <a:spAutoFit/>
+          </a:bodyPr>
+          <a:lstStyle/>
+          <a:p>
+            <a:pPr algn="l">
+              <a:lnSpc>
+                <a:spcPct val="115000"/>
+              </a:lnSpc>
+            </a:pPr>
+            <a:r>
+              <a:rPr sz="2400" b="0">
+                <a:solidFill>
+                  <a:srgbClr val="3432C9"/>
+                </a:solidFill>
+                <a:latin typeface="Montserrat"/>
+              </a:rPr>
+              <a:t>03</a:t>
+            </a:r>
+          </a:p>
+        </p:txBody>
+      </p:sp>
+      <p:sp>
+        <p:nvSpPr>
+          <p:cNvPr id="18" name="TextBox 17"/>
+          <p:cNvSpPr txBox="1"/>
+          <p:nvPr/>
+        </p:nvSpPr>
+        <p:spPr>
+          <a:xfrm>
+            <a:off x="5321808" y="2743200"/>
+            <a:ext cx="1645920" cy="548640"/>
+          </a:xfrm>
+          <a:prstGeom prst="rect">
+            <a:avLst/>
+          </a:prstGeom>
+          <a:noFill/>
+        </p:spPr>
+        <p:txBody>
+          <a:bodyPr wrap="square" lIns="0" rIns="0" tIns="0" bIns="0" anchor="t">
+            <a:spAutoFit/>
+          </a:bodyPr>
+          <a:lstStyle/>
+          <a:p>
+            <a:pPr algn="l">
+              <a:lnSpc>
+                <a:spcPct val="115000"/>
+              </a:lnSpc>
+            </a:pPr>
+            <a:r>
+              <a:rPr sz="1200" b="1">
+                <a:solidFill>
+                  <a:srgbClr val="1B1B2F"/>
+                </a:solidFill>
+                <a:latin typeface="Montserrat"/>
+              </a:rPr>
+              <a:t>Licenciamento</a:t>
+            </a:r>
+          </a:p>
+        </p:txBody>
+      </p:sp>
+      <p:sp>
+        <p:nvSpPr>
+          <p:cNvPr id="19" name="TextBox 18"/>
+          <p:cNvSpPr txBox="1"/>
+          <p:nvPr/>
+        </p:nvSpPr>
+        <p:spPr>
+          <a:xfrm>
+            <a:off x="5321808" y="3337560"/>
+            <a:ext cx="1645920" cy="1097280"/>
+          </a:xfrm>
+          <a:prstGeom prst="rect">
+            <a:avLst/>
+          </a:prstGeom>
+          <a:noFill/>
+        </p:spPr>
+        <p:txBody>
+          <a:bodyPr wrap="square" lIns="0" rIns="0" tIns="0" bIns="0" anchor="t">
+            <a:spAutoFit/>
+          </a:bodyPr>
+          <a:lstStyle/>
+          <a:p>
+            <a:pPr algn="l">
+              <a:lnSpc>
+                <a:spcPct val="115000"/>
+              </a:lnSpc>
+            </a:pPr>
+            <a:r>
+              <a:rPr sz="1000" b="0">
+                <a:solidFill>
+                  <a:srgbClr val="6B6B80"/>
+                </a:solidFill>
+                <a:latin typeface="Montserrat"/>
+              </a:rPr>
+              <a:t>Adequação da licença para uso do combustível alternativo.</a:t>
+            </a:r>
+          </a:p>
+        </p:txBody>
+      </p:sp>
+      <p:sp>
+        <p:nvSpPr>
+          <p:cNvPr id="20" name="Rectangle 19"/>
+          <p:cNvSpPr/>
+          <p:nvPr/>
+        </p:nvSpPr>
+        <p:spPr>
+          <a:xfrm>
+            <a:off x="7260336" y="1828800"/>
+            <a:ext cx="2011680" cy="2743200"/>
+          </a:xfrm>
+          <a:prstGeom prst="rect">
+            <a:avLst/>
+          </a:prstGeom>
+          <a:solidFill>
+            <a:srgbClr val="F4F5FC"/>
+          </a:solidFill>
+          <a:ln>
+            <a:noFill/>
+          </a:ln>
+          <a:effectLst/>
+        </p:spPr>
+        <p:txBody>
+          <a:bodyPr rtlCol="0" anchor="ctr"/>
+          <a:lstStyle/>
+          <a:p>
+            <a:pPr algn="ctr"/>
+          </a:p>
+        </p:txBody>
+      </p:sp>
+      <p:sp>
+        <p:nvSpPr>
+          <p:cNvPr id="21" name="Rectangle 20"/>
+          <p:cNvSpPr/>
+          <p:nvPr/>
+        </p:nvSpPr>
+        <p:spPr>
+          <a:xfrm>
+            <a:off x="7260336" y="1828800"/>
+            <a:ext cx="2011680" cy="54864"/>
+          </a:xfrm>
+          <a:prstGeom prst="rect">
+            <a:avLst/>
+          </a:prstGeom>
+          <a:solidFill>
+            <a:srgbClr val="3432C9"/>
+          </a:solidFill>
+          <a:ln>
+            <a:noFill/>
+          </a:ln>
+          <a:effectLst/>
+        </p:spPr>
+        <p:txBody>
+          <a:bodyPr rtlCol="0" anchor="ctr"/>
+          <a:lstStyle/>
+          <a:p>
+            <a:pPr algn="ctr"/>
+          </a:p>
+        </p:txBody>
+      </p:sp>
+      <p:sp>
+        <p:nvSpPr>
+          <p:cNvPr id="22" name="TextBox 21"/>
+          <p:cNvSpPr txBox="1"/>
+          <p:nvPr/>
+        </p:nvSpPr>
+        <p:spPr>
+          <a:xfrm>
+            <a:off x="7488936" y="2103120"/>
+            <a:ext cx="1371600" cy="457200"/>
+          </a:xfrm>
+          <a:prstGeom prst="rect">
+            <a:avLst/>
+          </a:prstGeom>
+          <a:noFill/>
+        </p:spPr>
+        <p:txBody>
+          <a:bodyPr wrap="square" lIns="0" rIns="0" tIns="0" bIns="0" anchor="t">
+            <a:spAutoFit/>
+          </a:bodyPr>
+          <a:lstStyle/>
+          <a:p>
+            <a:pPr algn="l">
+              <a:lnSpc>
+                <a:spcPct val="115000"/>
+              </a:lnSpc>
+            </a:pPr>
+            <a:r>
+              <a:rPr sz="2400" b="0">
+                <a:solidFill>
+                  <a:srgbClr val="3432C9"/>
+                </a:solidFill>
+                <a:latin typeface="Montserrat"/>
+              </a:rPr>
+              <a:t>04</a:t>
+            </a:r>
+          </a:p>
+        </p:txBody>
+      </p:sp>
+      <p:sp>
+        <p:nvSpPr>
+          <p:cNvPr id="23" name="TextBox 22"/>
+          <p:cNvSpPr txBox="1"/>
+          <p:nvPr/>
+        </p:nvSpPr>
+        <p:spPr>
+          <a:xfrm>
+            <a:off x="7488936" y="2743200"/>
+            <a:ext cx="1645920" cy="548640"/>
+          </a:xfrm>
+          <a:prstGeom prst="rect">
+            <a:avLst/>
+          </a:prstGeom>
+          <a:noFill/>
+        </p:spPr>
+        <p:txBody>
+          <a:bodyPr wrap="square" lIns="0" rIns="0" tIns="0" bIns="0" anchor="t">
+            <a:spAutoFit/>
+          </a:bodyPr>
+          <a:lstStyle/>
+          <a:p>
+            <a:pPr algn="l">
+              <a:lnSpc>
+                <a:spcPct val="115000"/>
+              </a:lnSpc>
+            </a:pPr>
+            <a:r>
+              <a:rPr sz="1200" b="1">
+                <a:solidFill>
+                  <a:srgbClr val="1B1B2F"/>
+                </a:solidFill>
+                <a:latin typeface="Montserrat"/>
+              </a:rPr>
+              <a:t>Fornecimento piloto</a:t>
+            </a:r>
+          </a:p>
+        </p:txBody>
+      </p:sp>
+      <p:sp>
+        <p:nvSpPr>
+          <p:cNvPr id="24" name="TextBox 23"/>
+          <p:cNvSpPr txBox="1"/>
+          <p:nvPr/>
+        </p:nvSpPr>
+        <p:spPr>
+          <a:xfrm>
+            <a:off x="7488936" y="3337560"/>
+            <a:ext cx="1645920" cy="1097280"/>
+          </a:xfrm>
+          <a:prstGeom prst="rect">
+            <a:avLst/>
+          </a:prstGeom>
+          <a:noFill/>
+        </p:spPr>
+        <p:txBody>
+          <a:bodyPr wrap="square" lIns="0" rIns="0" tIns="0" bIns="0" anchor="t">
+            <a:spAutoFit/>
+          </a:bodyPr>
+          <a:lstStyle/>
+          <a:p>
+            <a:pPr algn="l">
+              <a:lnSpc>
+                <a:spcPct val="115000"/>
+              </a:lnSpc>
+            </a:pPr>
+            <a:r>
+              <a:rPr sz="1000" b="0">
+                <a:solidFill>
+                  <a:srgbClr val="6B6B80"/>
+                </a:solidFill>
+                <a:latin typeface="Montserrat"/>
+              </a:rPr>
+              <a:t>Lotes iniciais com monitoramento de desempenho.</a:t>
+            </a:r>
+          </a:p>
+        </p:txBody>
+      </p:sp>
+      <p:sp>
+        <p:nvSpPr>
+          <p:cNvPr id="25" name="Rectangle 24"/>
+          <p:cNvSpPr/>
+          <p:nvPr/>
+        </p:nvSpPr>
+        <p:spPr>
+          <a:xfrm>
+            <a:off x="9427464" y="1828800"/>
+            <a:ext cx="2011680" cy="2743200"/>
+          </a:xfrm>
+          <a:prstGeom prst="rect">
+            <a:avLst/>
+          </a:prstGeom>
+          <a:solidFill>
+            <a:srgbClr val="F4F5FC"/>
+          </a:solidFill>
+          <a:ln>
+            <a:noFill/>
+          </a:ln>
+          <a:effectLst/>
+        </p:spPr>
+        <p:txBody>
+          <a:bodyPr rtlCol="0" anchor="ctr"/>
+          <a:lstStyle/>
+          <a:p>
+            <a:pPr algn="ctr"/>
+          </a:p>
+        </p:txBody>
+      </p:sp>
+      <p:sp>
+        <p:nvSpPr>
+          <p:cNvPr id="26" name="Rectangle 25"/>
+          <p:cNvSpPr/>
+          <p:nvPr/>
+        </p:nvSpPr>
+        <p:spPr>
+          <a:xfrm>
+            <a:off x="9427464" y="1828800"/>
+            <a:ext cx="2011680" cy="54864"/>
+          </a:xfrm>
+          <a:prstGeom prst="rect">
+            <a:avLst/>
+          </a:prstGeom>
+          <a:solidFill>
+            <a:srgbClr val="12A87B"/>
+          </a:solidFill>
+          <a:ln>
+            <a:noFill/>
+          </a:ln>
+          <a:effectLst/>
+        </p:spPr>
+        <p:txBody>
+          <a:bodyPr rtlCol="0" anchor="ctr"/>
+          <a:lstStyle/>
+          <a:p>
+            <a:pPr algn="ctr"/>
+          </a:p>
+        </p:txBody>
+      </p:sp>
+      <p:sp>
+        <p:nvSpPr>
+          <p:cNvPr id="27" name="TextBox 26"/>
+          <p:cNvSpPr txBox="1"/>
+          <p:nvPr/>
+        </p:nvSpPr>
+        <p:spPr>
+          <a:xfrm>
+            <a:off x="9656064" y="2103120"/>
+            <a:ext cx="1371600" cy="457200"/>
+          </a:xfrm>
+          <a:prstGeom prst="rect">
+            <a:avLst/>
+          </a:prstGeom>
+          <a:noFill/>
+        </p:spPr>
+        <p:txBody>
+          <a:bodyPr wrap="square" lIns="0" rIns="0" tIns="0" bIns="0" anchor="t">
+            <a:spAutoFit/>
+          </a:bodyPr>
+          <a:lstStyle/>
+          <a:p>
+            <a:pPr algn="l">
+              <a:lnSpc>
+                <a:spcPct val="115000"/>
+              </a:lnSpc>
+            </a:pPr>
+            <a:r>
+              <a:rPr sz="2400" b="0">
+                <a:solidFill>
+                  <a:srgbClr val="12A87B"/>
+                </a:solidFill>
+                <a:latin typeface="Montserrat"/>
+              </a:rPr>
+              <a:t>05</a:t>
+            </a:r>
+          </a:p>
+        </p:txBody>
+      </p:sp>
+      <p:sp>
+        <p:nvSpPr>
+          <p:cNvPr id="28" name="TextBox 27"/>
+          <p:cNvSpPr txBox="1"/>
+          <p:nvPr/>
+        </p:nvSpPr>
+        <p:spPr>
+          <a:xfrm>
+            <a:off x="9656064" y="2743200"/>
+            <a:ext cx="1645920" cy="548640"/>
+          </a:xfrm>
+          <a:prstGeom prst="rect">
+            <a:avLst/>
+          </a:prstGeom>
+          <a:noFill/>
+        </p:spPr>
+        <p:txBody>
+          <a:bodyPr wrap="square" lIns="0" rIns="0" tIns="0" bIns="0" anchor="t">
+            <a:spAutoFit/>
+          </a:bodyPr>
+          <a:lstStyle/>
+          <a:p>
+            <a:pPr algn="l">
+              <a:lnSpc>
+                <a:spcPct val="115000"/>
+              </a:lnSpc>
+            </a:pPr>
+            <a:r>
+              <a:rPr sz="1200" b="1">
+                <a:solidFill>
+                  <a:srgbClr val="1B1B2F"/>
+                </a:solidFill>
+                <a:latin typeface="Montserrat"/>
+              </a:rPr>
+              <a:t>Contrato contínuo</a:t>
+            </a:r>
+          </a:p>
+        </p:txBody>
+      </p:sp>
+      <p:sp>
+        <p:nvSpPr>
+          <p:cNvPr id="29" name="TextBox 28"/>
+          <p:cNvSpPr txBox="1"/>
+          <p:nvPr/>
+        </p:nvSpPr>
+        <p:spPr>
+          <a:xfrm>
+            <a:off x="9656064" y="3337560"/>
+            <a:ext cx="1645920" cy="1097280"/>
+          </a:xfrm>
+          <a:prstGeom prst="rect">
+            <a:avLst/>
+          </a:prstGeom>
+          <a:noFill/>
+        </p:spPr>
+        <p:txBody>
+          <a:bodyPr wrap="square" lIns="0" rIns="0" tIns="0" bIns="0" anchor="t">
+            <a:spAutoFit/>
+          </a:bodyPr>
+          <a:lstStyle/>
+          <a:p>
+            <a:pPr algn="l">
+              <a:lnSpc>
+                <a:spcPct val="115000"/>
+              </a:lnSpc>
+            </a:pPr>
+            <a:r>
+              <a:rPr sz="1000" b="0">
+                <a:solidFill>
+                  <a:srgbClr val="6B6B80"/>
+                </a:solidFill>
+                <a:latin typeface="Montserrat"/>
+              </a:rPr>
+              <a:t>Fornecimento regular e programado.</a:t>
+            </a:r>
+          </a:p>
+        </p:txBody>
+      </p:sp>
+      <p:sp>
+        <p:nvSpPr>
+          <p:cNvPr id="30" name="TextBox 29"/>
+          <p:cNvSpPr txBox="1"/>
+          <p:nvPr/>
+        </p:nvSpPr>
+        <p:spPr>
+          <a:xfrm>
+            <a:off x="758952" y="4892040"/>
+            <a:ext cx="10607040" cy="731520"/>
+          </a:xfrm>
+          <a:prstGeom prst="rect">
+            <a:avLst/>
+          </a:prstGeom>
+          <a:noFill/>
+        </p:spPr>
+        <p:txBody>
+          <a:bodyPr wrap="square" lIns="0" rIns="0" tIns="0" bIns="0" anchor="t">
+            <a:spAutoFit/>
+          </a:bodyPr>
+          <a:lstStyle/>
+          <a:p>
+            <a:pPr algn="l">
+              <a:lnSpc>
+                <a:spcPct val="115000"/>
+              </a:lnSpc>
+            </a:pPr>
+            <a:r>
+              <a:rPr sz="1200" b="1">
+                <a:solidFill>
+                  <a:srgbClr val="3432C9"/>
+                </a:solidFill>
+                <a:latin typeface="Montserrat"/>
+              </a:rPr>
+              <a:t>Solicitamos cotação formal em R$/t </a:t>
+            </a:r>
+            <a:r>
+              <a:rPr sz="1200" b="0">
+                <a:solidFill>
+                  <a:srgbClr val="6B6B80"/>
+                </a:solidFill>
+                <a:latin typeface="Montserrat"/>
+              </a:rPr>
+              <a:t>para o fornecimento de 1.000 t/mês com entrega programada na unidade do cliente. As condições finais serão definidas em reunião.</a:t>
+            </a:r>
+          </a:p>
+        </p:txBody>
+      </p:sp>
+      <p:cxnSp>
+        <p:nvCxnSpPr>
+          <p:cNvPr id="31" name="Connector 30"/>
+          <p:cNvCxnSpPr/>
+          <p:nvPr/>
+        </p:nvCxnSpPr>
+        <p:spPr>
+          <a:xfrm>
+            <a:off x="758952" y="6199632"/>
+            <a:ext cx="10671048" cy="0"/>
+          </a:xfrm>
+          <a:prstGeom prst="line">
+            <a:avLst/>
+          </a:prstGeom>
+          <a:ln w="9525">
+            <a:solidFill>
+              <a:srgbClr val="DDDEEE"/>
+            </a:solidFill>
+          </a:ln>
+        </p:spPr>
+      </p:cxnSp>
+      <p:pic>
+        <p:nvPicPr>
+          <p:cNvPr id="32" name="Picture 31" descr="logo_dark.png"/>
+          <p:cNvPicPr>
+            <a:picLocks noChangeAspect="1"/>
+          </p:cNvPicPr>
+          <p:nvPr/>
+        </p:nvPicPr>
+        <p:blipFill>
+          <a:blip r:embed="rId2"/>
+          <a:stretch>
+            <a:fillRect/>
+          </a:stretch>
+        </p:blipFill>
+        <p:spPr>
+          <a:xfrm>
+            <a:off x="758952" y="6309360"/>
+            <a:ext cx="1150185" cy="274320"/>
+          </a:xfrm>
+          <a:prstGeom prst="rect">
+            <a:avLst/>
+          </a:prstGeom>
+        </p:spPr>
+      </p:pic>
+      <p:sp>
+        <p:nvSpPr>
+          <p:cNvPr id="33" name="TextBox 32"/>
+          <p:cNvSpPr txBox="1"/>
+          <p:nvPr/>
+        </p:nvSpPr>
+        <p:spPr>
+          <a:xfrm>
+            <a:off x="7772400" y="6355080"/>
+            <a:ext cx="3657600" cy="228600"/>
+          </a:xfrm>
+          <a:prstGeom prst="rect">
+            <a:avLst/>
+          </a:prstGeom>
+          <a:noFill/>
+        </p:spPr>
+        <p:txBody>
+          <a:bodyPr wrap="square" lIns="0" rIns="0" tIns="0" bIns="0" anchor="t">
+            <a:spAutoFit/>
+          </a:bodyPr>
+          <a:lstStyle/>
+          <a:p>
+            <a:pPr algn="r">
+              <a:lnSpc>
+                <a:spcPct val="115000"/>
+              </a:lnSpc>
+            </a:pPr>
+            <a:r>
+              <a:rPr sz="800" b="0">
+                <a:solidFill>
+                  <a:srgbClr val="6B6B80"/>
+                </a:solidFill>
+                <a:latin typeface="Montserrat"/>
+              </a:rPr>
+              <a:t>Resíduo Têxtil · Mineração   |   13</a:t>
+            </a:r>
+          </a:p>
+        </p:txBody>
+      </p:sp>
+    </p:spTree>
+  </p:cSld>
+  <p:clrMapOvr>
+    <a:masterClrMapping/>
+  </p:clrMapOvr>
+</p:sld>
+</file>
+
+<file path=ppt/slides/slide14.xml><?xml version="1.0" encoding="utf-8"?>
 <p:sld xmlns:a="http://schemas.openxmlformats.org/drawingml/2006/main" xmlns:p="http://schemas.openxmlformats.org/presentationml/2006/main" xmlns:r="http://schemas.openxmlformats.org/officeDocument/2006/relationships">
   <p:cSld>
     <p:bg>
@@ -8357,7 +9513,7 @@
                 </a:solidFill>
                 <a:latin typeface="Montserrat"/>
               </a:rPr>
-              <a:t>Mix de fibras (algodão, sintéticas e mistas), com triagem para retirar contaminantes.</a:t>
+              <a:t>Mistura de aparas de fibras naturais e sintéticas, padronizada por lote para manter o alto PCI.</a:t>
             </a:r>
           </a:p>
         </p:txBody>
@@ -9505,7 +10661,7 @@
                 </a:solidFill>
                 <a:latin typeface="Montserrat"/>
               </a:rPr>
-              <a:t>Resultado válido para a amostra analisada. Laudo completo disponível mediante solicitação.</a:t>
+              <a:t>Resultado da amostra analisada. O alto PCI vem da mistura de fibras, e a composição é mantida em todos os lotes fornecidos.</a:t>
             </a:r>
           </a:p>
         </p:txBody>

</xml_diff>

<commit_message>
Corrige formatação do card 'Destinação comprovada' (slide 12)
O título quebrava em duas linhas e encostava no texto. Os cards da
fileira agora reservam duas linhas para o título, com o texto alinhado.
</commit_message>
<xml_diff>
--- a/apresentacao-mineradora/Nunes_Lucato_Residuo_Textil_Mineradora.pptx
+++ b/apresentacao-mineradora/Nunes_Lucato_Residuo_Textil_Mineradora.pptx
@@ -5737,7 +5737,7 @@
         <p:spPr>
           <a:xfrm>
             <a:off x="1033271" y="1920240"/>
-            <a:ext cx="1965960" cy="365760"/>
+            <a:ext cx="1965960" cy="502920"/>
           </a:xfrm>
           <a:prstGeom prst="rect">
             <a:avLst/>
@@ -5752,7 +5752,7 @@
           <a:p>
             <a:pPr algn="l">
               <a:lnSpc>
-                <a:spcPct val="115000"/>
+                <a:spcPct val="105000"/>
               </a:lnSpc>
             </a:pPr>
             <a:r>
@@ -5775,8 +5775,8 @@
         </p:nvSpPr>
         <p:spPr>
           <a:xfrm>
-            <a:off x="1033271" y="2331720"/>
-            <a:ext cx="1965960" cy="1508760"/>
+            <a:off x="1033271" y="2560320"/>
+            <a:ext cx="1965960" cy="1188719"/>
           </a:xfrm>
           <a:prstGeom prst="rect">
             <a:avLst/>
@@ -5877,7 +5877,7 @@
         <p:spPr>
           <a:xfrm>
             <a:off x="3749040" y="1920240"/>
-            <a:ext cx="1965960" cy="365760"/>
+            <a:ext cx="1965960" cy="502920"/>
           </a:xfrm>
           <a:prstGeom prst="rect">
             <a:avLst/>
@@ -5892,7 +5892,7 @@
           <a:p>
             <a:pPr algn="l">
               <a:lnSpc>
-                <a:spcPct val="115000"/>
+                <a:spcPct val="105000"/>
               </a:lnSpc>
             </a:pPr>
             <a:r>
@@ -5915,8 +5915,8 @@
         </p:nvSpPr>
         <p:spPr>
           <a:xfrm>
-            <a:off x="3749040" y="2331720"/>
-            <a:ext cx="1965960" cy="1508760"/>
+            <a:off x="3749040" y="2560320"/>
+            <a:ext cx="1965960" cy="1188719"/>
           </a:xfrm>
           <a:prstGeom prst="rect">
             <a:avLst/>
@@ -6017,7 +6017,7 @@
         <p:spPr>
           <a:xfrm>
             <a:off x="6464808" y="1920240"/>
-            <a:ext cx="1965960" cy="365760"/>
+            <a:ext cx="1965960" cy="502920"/>
           </a:xfrm>
           <a:prstGeom prst="rect">
             <a:avLst/>
@@ -6032,7 +6032,7 @@
           <a:p>
             <a:pPr algn="l">
               <a:lnSpc>
-                <a:spcPct val="115000"/>
+                <a:spcPct val="105000"/>
               </a:lnSpc>
             </a:pPr>
             <a:r>
@@ -6055,8 +6055,8 @@
         </p:nvSpPr>
         <p:spPr>
           <a:xfrm>
-            <a:off x="6464808" y="2331720"/>
-            <a:ext cx="1965960" cy="1508760"/>
+            <a:off x="6464808" y="2560320"/>
+            <a:ext cx="1965960" cy="1188719"/>
           </a:xfrm>
           <a:prstGeom prst="rect">
             <a:avLst/>
@@ -6157,7 +6157,7 @@
         <p:spPr>
           <a:xfrm>
             <a:off x="9180576" y="1920240"/>
-            <a:ext cx="1965960" cy="365760"/>
+            <a:ext cx="1965960" cy="502920"/>
           </a:xfrm>
           <a:prstGeom prst="rect">
             <a:avLst/>
@@ -6172,7 +6172,7 @@
           <a:p>
             <a:pPr algn="l">
               <a:lnSpc>
-                <a:spcPct val="115000"/>
+                <a:spcPct val="105000"/>
               </a:lnSpc>
             </a:pPr>
             <a:r>
@@ -6195,8 +6195,8 @@
         </p:nvSpPr>
         <p:spPr>
           <a:xfrm>
-            <a:off x="9180576" y="2331720"/>
-            <a:ext cx="1965960" cy="1508760"/>
+            <a:off x="9180576" y="2560320"/>
+            <a:ext cx="1965960" cy="1188719"/>
           </a:xfrm>
           <a:prstGeom prst="rect">
             <a:avLst/>
@@ -8484,7 +8484,7 @@
         <p:spPr>
           <a:xfrm>
             <a:off x="1033271" y="4251959"/>
-            <a:ext cx="1965960" cy="365760"/>
+            <a:ext cx="1965960" cy="274320"/>
           </a:xfrm>
           <a:prstGeom prst="rect">
             <a:avLst/>
@@ -8499,7 +8499,7 @@
           <a:p>
             <a:pPr algn="l">
               <a:lnSpc>
-                <a:spcPct val="115000"/>
+                <a:spcPct val="105000"/>
               </a:lnSpc>
             </a:pPr>
             <a:r>
@@ -8523,7 +8523,7 @@
         <p:spPr>
           <a:xfrm>
             <a:off x="1033271" y="4663440"/>
-            <a:ext cx="1965960" cy="1143000"/>
+            <a:ext cx="1965960" cy="1051560"/>
           </a:xfrm>
           <a:prstGeom prst="rect">
             <a:avLst/>
@@ -8624,7 +8624,7 @@
         <p:spPr>
           <a:xfrm>
             <a:off x="3749040" y="4251959"/>
-            <a:ext cx="1965960" cy="365760"/>
+            <a:ext cx="1965960" cy="274320"/>
           </a:xfrm>
           <a:prstGeom prst="rect">
             <a:avLst/>
@@ -8639,7 +8639,7 @@
           <a:p>
             <a:pPr algn="l">
               <a:lnSpc>
-                <a:spcPct val="115000"/>
+                <a:spcPct val="105000"/>
               </a:lnSpc>
             </a:pPr>
             <a:r>
@@ -8663,7 +8663,7 @@
         <p:spPr>
           <a:xfrm>
             <a:off x="3749040" y="4663440"/>
-            <a:ext cx="1965960" cy="1143000"/>
+            <a:ext cx="1965960" cy="1051560"/>
           </a:xfrm>
           <a:prstGeom prst="rect">
             <a:avLst/>
@@ -8764,7 +8764,7 @@
         <p:spPr>
           <a:xfrm>
             <a:off x="6464808" y="4251959"/>
-            <a:ext cx="1965960" cy="365760"/>
+            <a:ext cx="1965960" cy="274320"/>
           </a:xfrm>
           <a:prstGeom prst="rect">
             <a:avLst/>
@@ -8779,7 +8779,7 @@
           <a:p>
             <a:pPr algn="l">
               <a:lnSpc>
-                <a:spcPct val="115000"/>
+                <a:spcPct val="105000"/>
               </a:lnSpc>
             </a:pPr>
             <a:r>
@@ -8803,7 +8803,7 @@
         <p:spPr>
           <a:xfrm>
             <a:off x="6464808" y="4663440"/>
-            <a:ext cx="1965960" cy="1143000"/>
+            <a:ext cx="1965960" cy="1051560"/>
           </a:xfrm>
           <a:prstGeom prst="rect">
             <a:avLst/>
@@ -8904,7 +8904,7 @@
         <p:spPr>
           <a:xfrm>
             <a:off x="9180576" y="4251959"/>
-            <a:ext cx="1965960" cy="365760"/>
+            <a:ext cx="1965960" cy="274320"/>
           </a:xfrm>
           <a:prstGeom prst="rect">
             <a:avLst/>
@@ -8919,7 +8919,7 @@
           <a:p>
             <a:pPr algn="l">
               <a:lnSpc>
-                <a:spcPct val="115000"/>
+                <a:spcPct val="105000"/>
               </a:lnSpc>
             </a:pPr>
             <a:r>
@@ -8943,7 +8943,7 @@
         <p:spPr>
           <a:xfrm>
             <a:off x="9180576" y="4663440"/>
-            <a:ext cx="1965960" cy="1143000"/>
+            <a:ext cx="1965960" cy="1051560"/>
           </a:xfrm>
           <a:prstGeom prst="rect">
             <a:avLst/>
@@ -12855,7 +12855,7 @@
         <p:spPr>
           <a:xfrm>
             <a:off x="1033271" y="2377440"/>
-            <a:ext cx="1965960" cy="365760"/>
+            <a:ext cx="1965960" cy="274320"/>
           </a:xfrm>
           <a:prstGeom prst="rect">
             <a:avLst/>
@@ -12870,7 +12870,7 @@
           <a:p>
             <a:pPr algn="l">
               <a:lnSpc>
-                <a:spcPct val="115000"/>
+                <a:spcPct val="105000"/>
               </a:lnSpc>
             </a:pPr>
             <a:r>
@@ -12894,7 +12894,7 @@
         <p:spPr>
           <a:xfrm>
             <a:off x="1033271" y="2788920"/>
-            <a:ext cx="1965960" cy="1783080"/>
+            <a:ext cx="1965960" cy="1691639"/>
           </a:xfrm>
           <a:prstGeom prst="rect">
             <a:avLst/>
@@ -13034,7 +13034,7 @@
         <p:spPr>
           <a:xfrm>
             <a:off x="3749040" y="2377440"/>
-            <a:ext cx="1965960" cy="365760"/>
+            <a:ext cx="1965960" cy="274320"/>
           </a:xfrm>
           <a:prstGeom prst="rect">
             <a:avLst/>
@@ -13049,7 +13049,7 @@
           <a:p>
             <a:pPr algn="l">
               <a:lnSpc>
-                <a:spcPct val="115000"/>
+                <a:spcPct val="105000"/>
               </a:lnSpc>
             </a:pPr>
             <a:r>
@@ -13073,7 +13073,7 @@
         <p:spPr>
           <a:xfrm>
             <a:off x="3749040" y="2788920"/>
-            <a:ext cx="1965960" cy="1783080"/>
+            <a:ext cx="1965960" cy="1691639"/>
           </a:xfrm>
           <a:prstGeom prst="rect">
             <a:avLst/>
@@ -13213,7 +13213,7 @@
         <p:spPr>
           <a:xfrm>
             <a:off x="6464808" y="2377440"/>
-            <a:ext cx="1965960" cy="365760"/>
+            <a:ext cx="1965960" cy="274320"/>
           </a:xfrm>
           <a:prstGeom prst="rect">
             <a:avLst/>
@@ -13228,7 +13228,7 @@
           <a:p>
             <a:pPr algn="l">
               <a:lnSpc>
-                <a:spcPct val="115000"/>
+                <a:spcPct val="105000"/>
               </a:lnSpc>
             </a:pPr>
             <a:r>
@@ -13252,7 +13252,7 @@
         <p:spPr>
           <a:xfrm>
             <a:off x="6464808" y="2788920"/>
-            <a:ext cx="1965960" cy="1783080"/>
+            <a:ext cx="1965960" cy="1691639"/>
           </a:xfrm>
           <a:prstGeom prst="rect">
             <a:avLst/>
@@ -13392,7 +13392,7 @@
         <p:spPr>
           <a:xfrm>
             <a:off x="9180576" y="2377440"/>
-            <a:ext cx="1965960" cy="365760"/>
+            <a:ext cx="1965960" cy="274320"/>
           </a:xfrm>
           <a:prstGeom prst="rect">
             <a:avLst/>
@@ -13407,7 +13407,7 @@
           <a:p>
             <a:pPr algn="l">
               <a:lnSpc>
-                <a:spcPct val="115000"/>
+                <a:spcPct val="105000"/>
               </a:lnSpc>
             </a:pPr>
             <a:r>
@@ -13431,7 +13431,7 @@
         <p:spPr>
           <a:xfrm>
             <a:off x="9180576" y="2788920"/>
-            <a:ext cx="1965960" cy="1783080"/>
+            <a:ext cx="1965960" cy="1691639"/>
           </a:xfrm>
           <a:prstGeom prst="rect">
             <a:avLst/>
@@ -13819,7 +13819,7 @@
         <p:spPr>
           <a:xfrm>
             <a:off x="1033271" y="1920240"/>
-            <a:ext cx="2880360" cy="365760"/>
+            <a:ext cx="2880360" cy="274320"/>
           </a:xfrm>
           <a:prstGeom prst="rect">
             <a:avLst/>
@@ -13834,7 +13834,7 @@
           <a:p>
             <a:pPr algn="l">
               <a:lnSpc>
-                <a:spcPct val="115000"/>
+                <a:spcPct val="105000"/>
               </a:lnSpc>
             </a:pPr>
             <a:r>
@@ -13858,7 +13858,7 @@
         <p:spPr>
           <a:xfrm>
             <a:off x="1033271" y="2331720"/>
-            <a:ext cx="2880360" cy="1188719"/>
+            <a:ext cx="2880360" cy="1097280"/>
           </a:xfrm>
           <a:prstGeom prst="rect">
             <a:avLst/>
@@ -13959,7 +13959,7 @@
         <p:spPr>
           <a:xfrm>
             <a:off x="4645152" y="1920240"/>
-            <a:ext cx="2880360" cy="365760"/>
+            <a:ext cx="2880360" cy="274320"/>
           </a:xfrm>
           <a:prstGeom prst="rect">
             <a:avLst/>
@@ -13974,7 +13974,7 @@
           <a:p>
             <a:pPr algn="l">
               <a:lnSpc>
-                <a:spcPct val="115000"/>
+                <a:spcPct val="105000"/>
               </a:lnSpc>
             </a:pPr>
             <a:r>
@@ -13998,7 +13998,7 @@
         <p:spPr>
           <a:xfrm>
             <a:off x="4645152" y="2331720"/>
-            <a:ext cx="2880360" cy="1188719"/>
+            <a:ext cx="2880360" cy="1097280"/>
           </a:xfrm>
           <a:prstGeom prst="rect">
             <a:avLst/>
@@ -14099,7 +14099,7 @@
         <p:spPr>
           <a:xfrm>
             <a:off x="8257032" y="1920240"/>
-            <a:ext cx="2880360" cy="365760"/>
+            <a:ext cx="2880360" cy="274320"/>
           </a:xfrm>
           <a:prstGeom prst="rect">
             <a:avLst/>
@@ -14114,7 +14114,7 @@
           <a:p>
             <a:pPr algn="l">
               <a:lnSpc>
-                <a:spcPct val="115000"/>
+                <a:spcPct val="105000"/>
               </a:lnSpc>
             </a:pPr>
             <a:r>
@@ -14138,7 +14138,7 @@
         <p:spPr>
           <a:xfrm>
             <a:off x="8257032" y="2331720"/>
-            <a:ext cx="2880360" cy="1188719"/>
+            <a:ext cx="2880360" cy="1097280"/>
           </a:xfrm>
           <a:prstGeom prst="rect">
             <a:avLst/>
@@ -14239,7 +14239,7 @@
         <p:spPr>
           <a:xfrm>
             <a:off x="1033271" y="4114800"/>
-            <a:ext cx="2880360" cy="365760"/>
+            <a:ext cx="2880360" cy="274320"/>
           </a:xfrm>
           <a:prstGeom prst="rect">
             <a:avLst/>
@@ -14254,7 +14254,7 @@
           <a:p>
             <a:pPr algn="l">
               <a:lnSpc>
-                <a:spcPct val="115000"/>
+                <a:spcPct val="105000"/>
               </a:lnSpc>
             </a:pPr>
             <a:r>
@@ -14278,7 +14278,7 @@
         <p:spPr>
           <a:xfrm>
             <a:off x="1033271" y="4526280"/>
-            <a:ext cx="2880360" cy="1188720"/>
+            <a:ext cx="2880360" cy="1097280"/>
           </a:xfrm>
           <a:prstGeom prst="rect">
             <a:avLst/>
@@ -14379,7 +14379,7 @@
         <p:spPr>
           <a:xfrm>
             <a:off x="4645152" y="4114800"/>
-            <a:ext cx="2880360" cy="365760"/>
+            <a:ext cx="2880360" cy="274320"/>
           </a:xfrm>
           <a:prstGeom prst="rect">
             <a:avLst/>
@@ -14394,7 +14394,7 @@
           <a:p>
             <a:pPr algn="l">
               <a:lnSpc>
-                <a:spcPct val="115000"/>
+                <a:spcPct val="105000"/>
               </a:lnSpc>
             </a:pPr>
             <a:r>
@@ -14418,7 +14418,7 @@
         <p:spPr>
           <a:xfrm>
             <a:off x="4645152" y="4526280"/>
-            <a:ext cx="2880360" cy="1188720"/>
+            <a:ext cx="2880360" cy="1097280"/>
           </a:xfrm>
           <a:prstGeom prst="rect">
             <a:avLst/>
@@ -14519,7 +14519,7 @@
         <p:spPr>
           <a:xfrm>
             <a:off x="8257032" y="4114800"/>
-            <a:ext cx="2880360" cy="365760"/>
+            <a:ext cx="2880360" cy="274320"/>
           </a:xfrm>
           <a:prstGeom prst="rect">
             <a:avLst/>
@@ -14534,7 +14534,7 @@
           <a:p>
             <a:pPr algn="l">
               <a:lnSpc>
-                <a:spcPct val="115000"/>
+                <a:spcPct val="105000"/>
               </a:lnSpc>
             </a:pPr>
             <a:r>
@@ -14558,7 +14558,7 @@
         <p:spPr>
           <a:xfrm>
             <a:off x="8257032" y="4526280"/>
-            <a:ext cx="2880360" cy="1188720"/>
+            <a:ext cx="2880360" cy="1097280"/>
           </a:xfrm>
           <a:prstGeom prst="rect">
             <a:avLst/>

</xml_diff>

<commit_message>
Adiciona slide de amostras (5 kg picotado, moído e pedra-brita)
</commit_message>
<xml_diff>
--- a/apresentacao-mineradora/Nunes_Lucato_Residuo_Textil_Mineradora.pptx
+++ b/apresentacao-mineradora/Nunes_Lucato_Residuo_Textil_Mineradora.pptx
@@ -19,6 +19,7 @@
     <p:sldId id="267" r:id="rId18"/>
     <p:sldId id="268" r:id="rId19"/>
     <p:sldId id="269" r:id="rId20"/>
+    <p:sldId id="270" r:id="rId21"/>
   </p:sldIdLst>
   <p:sldSz cx="12191695" cy="6858000" type="screen4x3"/>
   <p:notesSz cx="6858000" cy="9144000"/>
@@ -6540,7 +6541,7 @@
                 </a:solidFill>
                 <a:latin typeface="Montserrat"/>
               </a:rPr>
-              <a:t>Implantação</a:t>
+              <a:t>Amostras para avaliação</a:t>
             </a:r>
           </a:p>
         </p:txBody>
@@ -6579,7 +6580,7 @@
                 </a:solidFill>
                 <a:latin typeface="Montserrat"/>
               </a:rPr>
-              <a:t>Próximos </a:t>
+              <a:t>Enviaremos </a:t>
             </a:r>
             <a:r>
               <a:rPr sz="2800" b="1">
@@ -6588,21 +6589,93 @@
                 </a:solidFill>
                 <a:latin typeface="Montserrat"/>
               </a:rPr>
-              <a:t>passos</a:t>
-            </a:r>
-          </a:p>
-        </p:txBody>
-      </p:sp>
-      <p:sp>
-        <p:nvSpPr>
-          <p:cNvPr id="5" name="Rectangle 4"/>
+              <a:t>15 kg de amostras</a:t>
+            </a:r>
+            <a:r>
+              <a:rPr sz="2800" b="0">
+                <a:solidFill>
+                  <a:srgbClr val="1B1B2F"/>
+                </a:solidFill>
+                <a:latin typeface="Montserrat"/>
+              </a:rPr>
+              <a:t> em três formatos</a:t>
+            </a:r>
+          </a:p>
+        </p:txBody>
+      </p:sp>
+      <p:sp>
+        <p:nvSpPr>
+          <p:cNvPr id="5" name="TextBox 4"/>
+          <p:cNvSpPr txBox="1"/>
+          <p:nvPr/>
+        </p:nvSpPr>
+        <p:spPr>
+          <a:xfrm>
+            <a:off x="758952" y="1463040"/>
+            <a:ext cx="10515600" cy="457200"/>
+          </a:xfrm>
+          <a:prstGeom prst="rect">
+            <a:avLst/>
+          </a:prstGeom>
+          <a:noFill/>
+        </p:spPr>
+        <p:txBody>
+          <a:bodyPr wrap="square" lIns="0" rIns="0" tIns="0" bIns="0" anchor="t">
+            <a:spAutoFit/>
+          </a:bodyPr>
+          <a:lstStyle/>
+          <a:p>
+            <a:pPr algn="l">
+              <a:lnSpc>
+                <a:spcPct val="115000"/>
+              </a:lnSpc>
+            </a:pPr>
+            <a:r>
+              <a:rPr sz="1200" b="0">
+                <a:solidFill>
+                  <a:srgbClr val="6B6B80"/>
+                </a:solidFill>
+                <a:latin typeface="Montserrat"/>
+              </a:rPr>
+              <a:t>5 kg de cada apresentação do material, para análise e teste de queima na sua unidade.</a:t>
+            </a:r>
+          </a:p>
+        </p:txBody>
+      </p:sp>
+      <p:pic>
+        <p:nvPicPr>
+          <p:cNvPr id="6" name="Picture 5" descr="amostra_1.jpg"/>
+          <p:cNvPicPr>
+            <a:picLocks noChangeAspect="1"/>
+          </p:cNvPicPr>
+          <p:nvPr/>
+        </p:nvPicPr>
+        <p:blipFill>
+          <a:blip r:embed="rId2"/>
+          <a:stretch>
+            <a:fillRect/>
+          </a:stretch>
+        </p:blipFill>
+        <p:spPr>
+          <a:xfrm>
+            <a:off x="758952" y="2011680"/>
+            <a:ext cx="3429000" cy="1920240"/>
+          </a:xfrm>
+          <a:prstGeom prst="rect">
+            <a:avLst/>
+          </a:prstGeom>
+        </p:spPr>
+      </p:pic>
+      <p:sp>
+        <p:nvSpPr>
+          <p:cNvPr id="7" name="Rectangle 6"/>
           <p:cNvSpPr/>
           <p:nvPr/>
         </p:nvSpPr>
         <p:spPr>
           <a:xfrm>
-            <a:off x="758952" y="1828800"/>
-            <a:ext cx="2011680" cy="2743200"/>
+            <a:off x="758952" y="3931920"/>
+            <a:ext cx="3429000" cy="1691640"/>
           </a:xfrm>
           <a:prstGeom prst="rect">
             <a:avLst/>
@@ -6625,14 +6698,14 @@
       </p:sp>
       <p:sp>
         <p:nvSpPr>
-          <p:cNvPr id="6" name="Rectangle 5"/>
+          <p:cNvPr id="8" name="Rectangle 7"/>
           <p:cNvSpPr/>
           <p:nvPr/>
         </p:nvSpPr>
         <p:spPr>
           <a:xfrm>
-            <a:off x="758952" y="1828800"/>
-            <a:ext cx="2011680" cy="54864"/>
+            <a:off x="758952" y="3931920"/>
+            <a:ext cx="3429000" cy="54864"/>
           </a:xfrm>
           <a:prstGeom prst="rect">
             <a:avLst/>
@@ -6653,62 +6726,23 @@
           </a:p>
         </p:txBody>
       </p:sp>
-      <p:sp>
-        <p:nvSpPr>
-          <p:cNvPr id="7" name="TextBox 6"/>
-          <p:cNvSpPr txBox="1"/>
-          <p:nvPr/>
-        </p:nvSpPr>
-        <p:spPr>
-          <a:xfrm>
-            <a:off x="987552" y="2103120"/>
-            <a:ext cx="1371600" cy="457200"/>
-          </a:xfrm>
-          <a:prstGeom prst="rect">
-            <a:avLst/>
-          </a:prstGeom>
-          <a:noFill/>
-        </p:spPr>
-        <p:txBody>
-          <a:bodyPr wrap="square" lIns="0" rIns="0" tIns="0" bIns="0" anchor="t">
-            <a:spAutoFit/>
-          </a:bodyPr>
-          <a:lstStyle/>
-          <a:p>
-            <a:pPr algn="l">
-              <a:lnSpc>
-                <a:spcPct val="115000"/>
-              </a:lnSpc>
-            </a:pPr>
-            <a:r>
-              <a:rPr sz="2400" b="0">
-                <a:solidFill>
-                  <a:srgbClr val="3432C9"/>
-                </a:solidFill>
-                <a:latin typeface="Montserrat"/>
-              </a:rPr>
-              <a:t>01</a:t>
-            </a:r>
-          </a:p>
-        </p:txBody>
-      </p:sp>
       <p:pic>
         <p:nvPicPr>
-          <p:cNvPr id="8" name="Picture 7" descr="send_royal.png"/>
+          <p:cNvPr id="9" name="Picture 8" descr="scissors_royal.png"/>
           <p:cNvPicPr>
             <a:picLocks noChangeAspect="1"/>
           </p:cNvPicPr>
           <p:nvPr/>
         </p:nvPicPr>
         <p:blipFill>
-          <a:blip r:embed="rId2"/>
+          <a:blip r:embed="rId3"/>
           <a:stretch>
             <a:fillRect/>
           </a:stretch>
         </p:blipFill>
         <p:spPr>
           <a:xfrm>
-            <a:off x="2176272" y="2148840"/>
+            <a:off x="1033271" y="4187952"/>
             <a:ext cx="365760" cy="365760"/>
           </a:xfrm>
           <a:prstGeom prst="rect">
@@ -6718,22 +6752,22 @@
       </p:pic>
       <p:sp>
         <p:nvSpPr>
-          <p:cNvPr id="9" name="TextBox 8"/>
-          <p:cNvSpPr txBox="1"/>
-          <p:nvPr/>
-        </p:nvSpPr>
-        <p:spPr>
-          <a:xfrm>
-            <a:off x="987552" y="2743200"/>
-            <a:ext cx="1645920" cy="548640"/>
-          </a:xfrm>
-          <a:prstGeom prst="rect">
-            <a:avLst/>
-          </a:prstGeom>
-          <a:noFill/>
-        </p:spPr>
-        <p:txBody>
-          <a:bodyPr wrap="square" lIns="0" rIns="0" tIns="0" bIns="0" anchor="t">
+          <p:cNvPr id="10" name="TextBox 9"/>
+          <p:cNvSpPr txBox="1"/>
+          <p:nvPr/>
+        </p:nvSpPr>
+        <p:spPr>
+          <a:xfrm>
+            <a:off x="1536192" y="4160520"/>
+            <a:ext cx="1737360" cy="411480"/>
+          </a:xfrm>
+          <a:prstGeom prst="rect">
+            <a:avLst/>
+          </a:prstGeom>
+          <a:noFill/>
+        </p:spPr>
+        <p:txBody>
+          <a:bodyPr wrap="square" lIns="0" rIns="0" tIns="0" bIns="0" anchor="ctr">
             <a:spAutoFit/>
           </a:bodyPr>
           <a:lstStyle/>
@@ -6744,27 +6778,75 @@
               </a:lnSpc>
             </a:pPr>
             <a:r>
-              <a:rPr sz="1200" b="1">
+              <a:rPr sz="1400" b="1">
                 <a:solidFill>
                   <a:srgbClr val="1B1B2F"/>
                 </a:solidFill>
                 <a:latin typeface="Montserrat"/>
               </a:rPr>
-              <a:t>Envio de amostra</a:t>
-            </a:r>
-          </a:p>
-        </p:txBody>
-      </p:sp>
-      <p:sp>
-        <p:nvSpPr>
-          <p:cNvPr id="10" name="TextBox 9"/>
-          <p:cNvSpPr txBox="1"/>
-          <p:nvPr/>
-        </p:nvSpPr>
-        <p:spPr>
-          <a:xfrm>
-            <a:off x="987552" y="3337560"/>
-            <a:ext cx="1645920" cy="1097280"/>
+              <a:t>Picotado</a:t>
+            </a:r>
+          </a:p>
+        </p:txBody>
+      </p:sp>
+      <p:sp>
+        <p:nvSpPr>
+          <p:cNvPr id="11" name="TextBox 10"/>
+          <p:cNvSpPr txBox="1"/>
+          <p:nvPr/>
+        </p:nvSpPr>
+        <p:spPr>
+          <a:xfrm>
+            <a:off x="3090672" y="4114800"/>
+            <a:ext cx="868680" cy="502920"/>
+          </a:xfrm>
+          <a:prstGeom prst="rect">
+            <a:avLst/>
+          </a:prstGeom>
+          <a:noFill/>
+        </p:spPr>
+        <p:txBody>
+          <a:bodyPr wrap="square" lIns="0" rIns="0" tIns="0" bIns="0" anchor="t">
+            <a:spAutoFit/>
+          </a:bodyPr>
+          <a:lstStyle/>
+          <a:p>
+            <a:pPr algn="r">
+              <a:lnSpc>
+                <a:spcPct val="115000"/>
+              </a:lnSpc>
+            </a:pPr>
+            <a:r>
+              <a:rPr sz="2600" b="1">
+                <a:solidFill>
+                  <a:srgbClr val="3432C9"/>
+                </a:solidFill>
+                <a:latin typeface="Montserrat"/>
+              </a:rPr>
+              <a:t>5</a:t>
+            </a:r>
+            <a:r>
+              <a:rPr sz="1200" b="0">
+                <a:solidFill>
+                  <a:srgbClr val="3432C9"/>
+                </a:solidFill>
+                <a:latin typeface="Montserrat"/>
+              </a:rPr>
+              <a:t> kg</a:t>
+            </a:r>
+          </a:p>
+        </p:txBody>
+      </p:sp>
+      <p:sp>
+        <p:nvSpPr>
+          <p:cNvPr id="12" name="TextBox 11"/>
+          <p:cNvSpPr txBox="1"/>
+          <p:nvPr/>
+        </p:nvSpPr>
+        <p:spPr>
+          <a:xfrm>
+            <a:off x="1033271" y="4754880"/>
+            <a:ext cx="2880360" cy="731520"/>
           </a:xfrm>
           <a:prstGeom prst="rect">
             <a:avLst/>
@@ -6789,21 +6871,45 @@
                 </a:solidFill>
                 <a:latin typeface="Montserrat"/>
               </a:rPr>
-              <a:t>Material representativo para análise da mineradora.</a:t>
-            </a:r>
-          </a:p>
-        </p:txBody>
-      </p:sp>
-      <p:sp>
-        <p:nvSpPr>
-          <p:cNvPr id="11" name="Rectangle 10"/>
+              <a:t>Fragmentos de tecido cortados, prontos para alimentação direta.</a:t>
+            </a:r>
+          </a:p>
+        </p:txBody>
+      </p:sp>
+      <p:pic>
+        <p:nvPicPr>
+          <p:cNvPr id="13" name="Picture 12" descr="amostra_2.jpg"/>
+          <p:cNvPicPr>
+            <a:picLocks noChangeAspect="1"/>
+          </p:cNvPicPr>
+          <p:nvPr/>
+        </p:nvPicPr>
+        <p:blipFill>
+          <a:blip r:embed="rId4"/>
+          <a:stretch>
+            <a:fillRect/>
+          </a:stretch>
+        </p:blipFill>
+        <p:spPr>
+          <a:xfrm>
+            <a:off x="4370832" y="2011680"/>
+            <a:ext cx="3429000" cy="1920240"/>
+          </a:xfrm>
+          <a:prstGeom prst="rect">
+            <a:avLst/>
+          </a:prstGeom>
+        </p:spPr>
+      </p:pic>
+      <p:sp>
+        <p:nvSpPr>
+          <p:cNvPr id="14" name="Rectangle 13"/>
           <p:cNvSpPr/>
           <p:nvPr/>
         </p:nvSpPr>
         <p:spPr>
           <a:xfrm>
-            <a:off x="2926080" y="1828800"/>
-            <a:ext cx="2011680" cy="2743200"/>
+            <a:off x="4370832" y="3931920"/>
+            <a:ext cx="3429000" cy="1691640"/>
           </a:xfrm>
           <a:prstGeom prst="rect">
             <a:avLst/>
@@ -6826,20 +6932,20 @@
       </p:sp>
       <p:sp>
         <p:nvSpPr>
-          <p:cNvPr id="12" name="Rectangle 11"/>
+          <p:cNvPr id="15" name="Rectangle 14"/>
           <p:cNvSpPr/>
           <p:nvPr/>
         </p:nvSpPr>
         <p:spPr>
           <a:xfrm>
-            <a:off x="2926080" y="1828800"/>
-            <a:ext cx="2011680" cy="54864"/>
+            <a:off x="4370832" y="3931920"/>
+            <a:ext cx="3429000" cy="54864"/>
           </a:xfrm>
           <a:prstGeom prst="rect">
             <a:avLst/>
           </a:prstGeom>
           <a:solidFill>
-            <a:srgbClr val="3432C9"/>
+            <a:srgbClr val="1E86C9"/>
           </a:solidFill>
           <a:ln>
             <a:noFill/>
@@ -6854,62 +6960,23 @@
           </a:p>
         </p:txBody>
       </p:sp>
-      <p:sp>
-        <p:nvSpPr>
-          <p:cNvPr id="13" name="TextBox 12"/>
-          <p:cNvSpPr txBox="1"/>
-          <p:nvPr/>
-        </p:nvSpPr>
-        <p:spPr>
-          <a:xfrm>
-            <a:off x="3154680" y="2103120"/>
-            <a:ext cx="1371600" cy="457200"/>
-          </a:xfrm>
-          <a:prstGeom prst="rect">
-            <a:avLst/>
-          </a:prstGeom>
-          <a:noFill/>
-        </p:spPr>
-        <p:txBody>
-          <a:bodyPr wrap="square" lIns="0" rIns="0" tIns="0" bIns="0" anchor="t">
-            <a:spAutoFit/>
-          </a:bodyPr>
-          <a:lstStyle/>
-          <a:p>
-            <a:pPr algn="l">
-              <a:lnSpc>
-                <a:spcPct val="115000"/>
-              </a:lnSpc>
-            </a:pPr>
-            <a:r>
-              <a:rPr sz="2400" b="0">
-                <a:solidFill>
-                  <a:srgbClr val="3432C9"/>
-                </a:solidFill>
-                <a:latin typeface="Montserrat"/>
-              </a:rPr>
-              <a:t>02</a:t>
-            </a:r>
-          </a:p>
-        </p:txBody>
-      </p:sp>
       <p:pic>
         <p:nvPicPr>
-          <p:cNvPr id="14" name="Picture 13" descr="flame_royal.png"/>
+          <p:cNvPr id="16" name="Picture 15" descr="layers_blue.png"/>
           <p:cNvPicPr>
             <a:picLocks noChangeAspect="1"/>
           </p:cNvPicPr>
           <p:nvPr/>
         </p:nvPicPr>
         <p:blipFill>
-          <a:blip r:embed="rId3"/>
+          <a:blip r:embed="rId5"/>
           <a:stretch>
             <a:fillRect/>
           </a:stretch>
         </p:blipFill>
         <p:spPr>
           <a:xfrm>
-            <a:off x="4343400" y="2148840"/>
+            <a:off x="4645152" y="4187952"/>
             <a:ext cx="365760" cy="365760"/>
           </a:xfrm>
           <a:prstGeom prst="rect">
@@ -6919,22 +6986,22 @@
       </p:pic>
       <p:sp>
         <p:nvSpPr>
-          <p:cNvPr id="15" name="TextBox 14"/>
-          <p:cNvSpPr txBox="1"/>
-          <p:nvPr/>
-        </p:nvSpPr>
-        <p:spPr>
-          <a:xfrm>
-            <a:off x="3154680" y="2743200"/>
-            <a:ext cx="1645920" cy="548640"/>
-          </a:xfrm>
-          <a:prstGeom prst="rect">
-            <a:avLst/>
-          </a:prstGeom>
-          <a:noFill/>
-        </p:spPr>
-        <p:txBody>
-          <a:bodyPr wrap="square" lIns="0" rIns="0" tIns="0" bIns="0" anchor="t">
+          <p:cNvPr id="17" name="TextBox 16"/>
+          <p:cNvSpPr txBox="1"/>
+          <p:nvPr/>
+        </p:nvSpPr>
+        <p:spPr>
+          <a:xfrm>
+            <a:off x="5148072" y="4160520"/>
+            <a:ext cx="1737360" cy="411480"/>
+          </a:xfrm>
+          <a:prstGeom prst="rect">
+            <a:avLst/>
+          </a:prstGeom>
+          <a:noFill/>
+        </p:spPr>
+        <p:txBody>
+          <a:bodyPr wrap="square" lIns="0" rIns="0" tIns="0" bIns="0" anchor="ctr">
             <a:spAutoFit/>
           </a:bodyPr>
           <a:lstStyle/>
@@ -6945,27 +7012,75 @@
               </a:lnSpc>
             </a:pPr>
             <a:r>
-              <a:rPr sz="1200" b="1">
+              <a:rPr sz="1400" b="1">
                 <a:solidFill>
                   <a:srgbClr val="1B1B2F"/>
                 </a:solidFill>
                 <a:latin typeface="Montserrat"/>
               </a:rPr>
-              <a:t>Teste de queima</a:t>
-            </a:r>
-          </a:p>
-        </p:txBody>
-      </p:sp>
-      <p:sp>
-        <p:nvSpPr>
-          <p:cNvPr id="16" name="TextBox 15"/>
-          <p:cNvSpPr txBox="1"/>
-          <p:nvPr/>
-        </p:nvSpPr>
-        <p:spPr>
-          <a:xfrm>
-            <a:off x="3154680" y="3337560"/>
-            <a:ext cx="1645920" cy="1097280"/>
+              <a:t>Moído</a:t>
+            </a:r>
+          </a:p>
+        </p:txBody>
+      </p:sp>
+      <p:sp>
+        <p:nvSpPr>
+          <p:cNvPr id="18" name="TextBox 17"/>
+          <p:cNvSpPr txBox="1"/>
+          <p:nvPr/>
+        </p:nvSpPr>
+        <p:spPr>
+          <a:xfrm>
+            <a:off x="6702552" y="4114800"/>
+            <a:ext cx="868680" cy="502920"/>
+          </a:xfrm>
+          <a:prstGeom prst="rect">
+            <a:avLst/>
+          </a:prstGeom>
+          <a:noFill/>
+        </p:spPr>
+        <p:txBody>
+          <a:bodyPr wrap="square" lIns="0" rIns="0" tIns="0" bIns="0" anchor="t">
+            <a:spAutoFit/>
+          </a:bodyPr>
+          <a:lstStyle/>
+          <a:p>
+            <a:pPr algn="r">
+              <a:lnSpc>
+                <a:spcPct val="115000"/>
+              </a:lnSpc>
+            </a:pPr>
+            <a:r>
+              <a:rPr sz="2600" b="1">
+                <a:solidFill>
+                  <a:srgbClr val="1E86C9"/>
+                </a:solidFill>
+                <a:latin typeface="Montserrat"/>
+              </a:rPr>
+              <a:t>5</a:t>
+            </a:r>
+            <a:r>
+              <a:rPr sz="1200" b="0">
+                <a:solidFill>
+                  <a:srgbClr val="1E86C9"/>
+                </a:solidFill>
+                <a:latin typeface="Montserrat"/>
+              </a:rPr>
+              <a:t> kg</a:t>
+            </a:r>
+          </a:p>
+        </p:txBody>
+      </p:sp>
+      <p:sp>
+        <p:nvSpPr>
+          <p:cNvPr id="19" name="TextBox 18"/>
+          <p:cNvSpPr txBox="1"/>
+          <p:nvPr/>
+        </p:nvSpPr>
+        <p:spPr>
+          <a:xfrm>
+            <a:off x="4645152" y="4754880"/>
+            <a:ext cx="2880360" cy="731520"/>
           </a:xfrm>
           <a:prstGeom prst="rect">
             <a:avLst/>
@@ -6990,21 +7105,45 @@
                 </a:solidFill>
                 <a:latin typeface="Montserrat"/>
               </a:rPr>
-              <a:t>Ensaio controlado no equipamento de destino.</a:t>
-            </a:r>
-          </a:p>
-        </p:txBody>
-      </p:sp>
-      <p:sp>
-        <p:nvSpPr>
-          <p:cNvPr id="17" name="Rectangle 16"/>
+              <a:t>Fibra triturada fina, homogênea e de fácil dosagem.</a:t>
+            </a:r>
+          </a:p>
+        </p:txBody>
+      </p:sp>
+      <p:pic>
+        <p:nvPicPr>
+          <p:cNvPr id="20" name="Picture 19" descr="amostra_3.jpg"/>
+          <p:cNvPicPr>
+            <a:picLocks noChangeAspect="1"/>
+          </p:cNvPicPr>
+          <p:nvPr/>
+        </p:nvPicPr>
+        <p:blipFill>
+          <a:blip r:embed="rId6"/>
+          <a:stretch>
+            <a:fillRect/>
+          </a:stretch>
+        </p:blipFill>
+        <p:spPr>
+          <a:xfrm>
+            <a:off x="7982712" y="2011680"/>
+            <a:ext cx="3429000" cy="1920240"/>
+          </a:xfrm>
+          <a:prstGeom prst="rect">
+            <a:avLst/>
+          </a:prstGeom>
+        </p:spPr>
+      </p:pic>
+      <p:sp>
+        <p:nvSpPr>
+          <p:cNvPr id="21" name="Rectangle 20"/>
           <p:cNvSpPr/>
           <p:nvPr/>
         </p:nvSpPr>
         <p:spPr>
           <a:xfrm>
-            <a:off x="5093208" y="1828800"/>
-            <a:ext cx="2011680" cy="2743200"/>
+            <a:off x="7982712" y="3931920"/>
+            <a:ext cx="3429000" cy="1691640"/>
           </a:xfrm>
           <a:prstGeom prst="rect">
             <a:avLst/>
@@ -7027,416 +7166,14 @@
       </p:sp>
       <p:sp>
         <p:nvSpPr>
-          <p:cNvPr id="18" name="Rectangle 17"/>
+          <p:cNvPr id="22" name="Rectangle 21"/>
           <p:cNvSpPr/>
           <p:nvPr/>
         </p:nvSpPr>
         <p:spPr>
           <a:xfrm>
-            <a:off x="5093208" y="1828800"/>
-            <a:ext cx="2011680" cy="54864"/>
-          </a:xfrm>
-          <a:prstGeom prst="rect">
-            <a:avLst/>
-          </a:prstGeom>
-          <a:solidFill>
-            <a:srgbClr val="3432C9"/>
-          </a:solidFill>
-          <a:ln>
-            <a:noFill/>
-          </a:ln>
-          <a:effectLst/>
-        </p:spPr>
-        <p:txBody>
-          <a:bodyPr rtlCol="0" anchor="ctr"/>
-          <a:lstStyle/>
-          <a:p>
-            <a:pPr algn="ctr"/>
-          </a:p>
-        </p:txBody>
-      </p:sp>
-      <p:sp>
-        <p:nvSpPr>
-          <p:cNvPr id="19" name="TextBox 18"/>
-          <p:cNvSpPr txBox="1"/>
-          <p:nvPr/>
-        </p:nvSpPr>
-        <p:spPr>
-          <a:xfrm>
-            <a:off x="5321808" y="2103120"/>
-            <a:ext cx="1371600" cy="457200"/>
-          </a:xfrm>
-          <a:prstGeom prst="rect">
-            <a:avLst/>
-          </a:prstGeom>
-          <a:noFill/>
-        </p:spPr>
-        <p:txBody>
-          <a:bodyPr wrap="square" lIns="0" rIns="0" tIns="0" bIns="0" anchor="t">
-            <a:spAutoFit/>
-          </a:bodyPr>
-          <a:lstStyle/>
-          <a:p>
-            <a:pPr algn="l">
-              <a:lnSpc>
-                <a:spcPct val="115000"/>
-              </a:lnSpc>
-            </a:pPr>
-            <a:r>
-              <a:rPr sz="2400" b="0">
-                <a:solidFill>
-                  <a:srgbClr val="3432C9"/>
-                </a:solidFill>
-                <a:latin typeface="Montserrat"/>
-              </a:rPr>
-              <a:t>03</a:t>
-            </a:r>
-          </a:p>
-        </p:txBody>
-      </p:sp>
-      <p:pic>
-        <p:nvPicPr>
-          <p:cNvPr id="20" name="Picture 19" descr="clipboard-check_royal.png"/>
-          <p:cNvPicPr>
-            <a:picLocks noChangeAspect="1"/>
-          </p:cNvPicPr>
-          <p:nvPr/>
-        </p:nvPicPr>
-        <p:blipFill>
-          <a:blip r:embed="rId4"/>
-          <a:stretch>
-            <a:fillRect/>
-          </a:stretch>
-        </p:blipFill>
-        <p:spPr>
-          <a:xfrm>
-            <a:off x="6510528" y="2148840"/>
-            <a:ext cx="365760" cy="365760"/>
-          </a:xfrm>
-          <a:prstGeom prst="rect">
-            <a:avLst/>
-          </a:prstGeom>
-        </p:spPr>
-      </p:pic>
-      <p:sp>
-        <p:nvSpPr>
-          <p:cNvPr id="21" name="TextBox 20"/>
-          <p:cNvSpPr txBox="1"/>
-          <p:nvPr/>
-        </p:nvSpPr>
-        <p:spPr>
-          <a:xfrm>
-            <a:off x="5321808" y="2743200"/>
-            <a:ext cx="1645920" cy="548640"/>
-          </a:xfrm>
-          <a:prstGeom prst="rect">
-            <a:avLst/>
-          </a:prstGeom>
-          <a:noFill/>
-        </p:spPr>
-        <p:txBody>
-          <a:bodyPr wrap="square" lIns="0" rIns="0" tIns="0" bIns="0" anchor="t">
-            <a:spAutoFit/>
-          </a:bodyPr>
-          <a:lstStyle/>
-          <a:p>
-            <a:pPr algn="l">
-              <a:lnSpc>
-                <a:spcPct val="115000"/>
-              </a:lnSpc>
-            </a:pPr>
-            <a:r>
-              <a:rPr sz="1200" b="1">
-                <a:solidFill>
-                  <a:srgbClr val="1B1B2F"/>
-                </a:solidFill>
-                <a:latin typeface="Montserrat"/>
-              </a:rPr>
-              <a:t>Licenciamento</a:t>
-            </a:r>
-          </a:p>
-        </p:txBody>
-      </p:sp>
-      <p:sp>
-        <p:nvSpPr>
-          <p:cNvPr id="22" name="TextBox 21"/>
-          <p:cNvSpPr txBox="1"/>
-          <p:nvPr/>
-        </p:nvSpPr>
-        <p:spPr>
-          <a:xfrm>
-            <a:off x="5321808" y="3337560"/>
-            <a:ext cx="1645920" cy="1097280"/>
-          </a:xfrm>
-          <a:prstGeom prst="rect">
-            <a:avLst/>
-          </a:prstGeom>
-          <a:noFill/>
-        </p:spPr>
-        <p:txBody>
-          <a:bodyPr wrap="square" lIns="0" rIns="0" tIns="0" bIns="0" anchor="t">
-            <a:spAutoFit/>
-          </a:bodyPr>
-          <a:lstStyle/>
-          <a:p>
-            <a:pPr algn="l">
-              <a:lnSpc>
-                <a:spcPct val="115000"/>
-              </a:lnSpc>
-            </a:pPr>
-            <a:r>
-              <a:rPr sz="1000" b="0">
-                <a:solidFill>
-                  <a:srgbClr val="6B6B80"/>
-                </a:solidFill>
-                <a:latin typeface="Montserrat"/>
-              </a:rPr>
-              <a:t>Adequação da licença para uso do combustível alternativo.</a:t>
-            </a:r>
-          </a:p>
-        </p:txBody>
-      </p:sp>
-      <p:sp>
-        <p:nvSpPr>
-          <p:cNvPr id="23" name="Rectangle 22"/>
-          <p:cNvSpPr/>
-          <p:nvPr/>
-        </p:nvSpPr>
-        <p:spPr>
-          <a:xfrm>
-            <a:off x="7260336" y="1828800"/>
-            <a:ext cx="2011680" cy="2743200"/>
-          </a:xfrm>
-          <a:prstGeom prst="rect">
-            <a:avLst/>
-          </a:prstGeom>
-          <a:solidFill>
-            <a:srgbClr val="F4F5FC"/>
-          </a:solidFill>
-          <a:ln>
-            <a:noFill/>
-          </a:ln>
-          <a:effectLst/>
-        </p:spPr>
-        <p:txBody>
-          <a:bodyPr rtlCol="0" anchor="ctr"/>
-          <a:lstStyle/>
-          <a:p>
-            <a:pPr algn="ctr"/>
-          </a:p>
-        </p:txBody>
-      </p:sp>
-      <p:sp>
-        <p:nvSpPr>
-          <p:cNvPr id="24" name="Rectangle 23"/>
-          <p:cNvSpPr/>
-          <p:nvPr/>
-        </p:nvSpPr>
-        <p:spPr>
-          <a:xfrm>
-            <a:off x="7260336" y="1828800"/>
-            <a:ext cx="2011680" cy="54864"/>
-          </a:xfrm>
-          <a:prstGeom prst="rect">
-            <a:avLst/>
-          </a:prstGeom>
-          <a:solidFill>
-            <a:srgbClr val="3432C9"/>
-          </a:solidFill>
-          <a:ln>
-            <a:noFill/>
-          </a:ln>
-          <a:effectLst/>
-        </p:spPr>
-        <p:txBody>
-          <a:bodyPr rtlCol="0" anchor="ctr"/>
-          <a:lstStyle/>
-          <a:p>
-            <a:pPr algn="ctr"/>
-          </a:p>
-        </p:txBody>
-      </p:sp>
-      <p:sp>
-        <p:nvSpPr>
-          <p:cNvPr id="25" name="TextBox 24"/>
-          <p:cNvSpPr txBox="1"/>
-          <p:nvPr/>
-        </p:nvSpPr>
-        <p:spPr>
-          <a:xfrm>
-            <a:off x="7488936" y="2103120"/>
-            <a:ext cx="1371600" cy="457200"/>
-          </a:xfrm>
-          <a:prstGeom prst="rect">
-            <a:avLst/>
-          </a:prstGeom>
-          <a:noFill/>
-        </p:spPr>
-        <p:txBody>
-          <a:bodyPr wrap="square" lIns="0" rIns="0" tIns="0" bIns="0" anchor="t">
-            <a:spAutoFit/>
-          </a:bodyPr>
-          <a:lstStyle/>
-          <a:p>
-            <a:pPr algn="l">
-              <a:lnSpc>
-                <a:spcPct val="115000"/>
-              </a:lnSpc>
-            </a:pPr>
-            <a:r>
-              <a:rPr sz="2400" b="0">
-                <a:solidFill>
-                  <a:srgbClr val="3432C9"/>
-                </a:solidFill>
-                <a:latin typeface="Montserrat"/>
-              </a:rPr>
-              <a:t>04</a:t>
-            </a:r>
-          </a:p>
-        </p:txBody>
-      </p:sp>
-      <p:pic>
-        <p:nvPicPr>
-          <p:cNvPr id="26" name="Picture 25" descr="play_royal.png"/>
-          <p:cNvPicPr>
-            <a:picLocks noChangeAspect="1"/>
-          </p:cNvPicPr>
-          <p:nvPr/>
-        </p:nvPicPr>
-        <p:blipFill>
-          <a:blip r:embed="rId5"/>
-          <a:stretch>
-            <a:fillRect/>
-          </a:stretch>
-        </p:blipFill>
-        <p:spPr>
-          <a:xfrm>
-            <a:off x="8677656" y="2148840"/>
-            <a:ext cx="365760" cy="365760"/>
-          </a:xfrm>
-          <a:prstGeom prst="rect">
-            <a:avLst/>
-          </a:prstGeom>
-        </p:spPr>
-      </p:pic>
-      <p:sp>
-        <p:nvSpPr>
-          <p:cNvPr id="27" name="TextBox 26"/>
-          <p:cNvSpPr txBox="1"/>
-          <p:nvPr/>
-        </p:nvSpPr>
-        <p:spPr>
-          <a:xfrm>
-            <a:off x="7488936" y="2743200"/>
-            <a:ext cx="1645920" cy="548640"/>
-          </a:xfrm>
-          <a:prstGeom prst="rect">
-            <a:avLst/>
-          </a:prstGeom>
-          <a:noFill/>
-        </p:spPr>
-        <p:txBody>
-          <a:bodyPr wrap="square" lIns="0" rIns="0" tIns="0" bIns="0" anchor="t">
-            <a:spAutoFit/>
-          </a:bodyPr>
-          <a:lstStyle/>
-          <a:p>
-            <a:pPr algn="l">
-              <a:lnSpc>
-                <a:spcPct val="115000"/>
-              </a:lnSpc>
-            </a:pPr>
-            <a:r>
-              <a:rPr sz="1200" b="1">
-                <a:solidFill>
-                  <a:srgbClr val="1B1B2F"/>
-                </a:solidFill>
-                <a:latin typeface="Montserrat"/>
-              </a:rPr>
-              <a:t>Fornecimento piloto</a:t>
-            </a:r>
-          </a:p>
-        </p:txBody>
-      </p:sp>
-      <p:sp>
-        <p:nvSpPr>
-          <p:cNvPr id="28" name="TextBox 27"/>
-          <p:cNvSpPr txBox="1"/>
-          <p:nvPr/>
-        </p:nvSpPr>
-        <p:spPr>
-          <a:xfrm>
-            <a:off x="7488936" y="3337560"/>
-            <a:ext cx="1645920" cy="1097280"/>
-          </a:xfrm>
-          <a:prstGeom prst="rect">
-            <a:avLst/>
-          </a:prstGeom>
-          <a:noFill/>
-        </p:spPr>
-        <p:txBody>
-          <a:bodyPr wrap="square" lIns="0" rIns="0" tIns="0" bIns="0" anchor="t">
-            <a:spAutoFit/>
-          </a:bodyPr>
-          <a:lstStyle/>
-          <a:p>
-            <a:pPr algn="l">
-              <a:lnSpc>
-                <a:spcPct val="115000"/>
-              </a:lnSpc>
-            </a:pPr>
-            <a:r>
-              <a:rPr sz="1000" b="0">
-                <a:solidFill>
-                  <a:srgbClr val="6B6B80"/>
-                </a:solidFill>
-                <a:latin typeface="Montserrat"/>
-              </a:rPr>
-              <a:t>Lotes iniciais com monitoramento de desempenho.</a:t>
-            </a:r>
-          </a:p>
-        </p:txBody>
-      </p:sp>
-      <p:sp>
-        <p:nvSpPr>
-          <p:cNvPr id="29" name="Rectangle 28"/>
-          <p:cNvSpPr/>
-          <p:nvPr/>
-        </p:nvSpPr>
-        <p:spPr>
-          <a:xfrm>
-            <a:off x="9427464" y="1828800"/>
-            <a:ext cx="2011680" cy="2743200"/>
-          </a:xfrm>
-          <a:prstGeom prst="rect">
-            <a:avLst/>
-          </a:prstGeom>
-          <a:solidFill>
-            <a:srgbClr val="F4F5FC"/>
-          </a:solidFill>
-          <a:ln>
-            <a:noFill/>
-          </a:ln>
-          <a:effectLst/>
-        </p:spPr>
-        <p:txBody>
-          <a:bodyPr rtlCol="0" anchor="ctr"/>
-          <a:lstStyle/>
-          <a:p>
-            <a:pPr algn="ctr"/>
-          </a:p>
-        </p:txBody>
-      </p:sp>
-      <p:sp>
-        <p:nvSpPr>
-          <p:cNvPr id="30" name="Rectangle 29"/>
-          <p:cNvSpPr/>
-          <p:nvPr/>
-        </p:nvSpPr>
-        <p:spPr>
-          <a:xfrm>
-            <a:off x="9427464" y="1828800"/>
-            <a:ext cx="2011680" cy="54864"/>
+            <a:off x="7982712" y="3931920"/>
+            <a:ext cx="3429000" cy="54864"/>
           </a:xfrm>
           <a:prstGeom prst="rect">
             <a:avLst/>
@@ -7457,219 +7194,9 @@
           </a:p>
         </p:txBody>
       </p:sp>
-      <p:sp>
-        <p:nvSpPr>
-          <p:cNvPr id="31" name="TextBox 30"/>
-          <p:cNvSpPr txBox="1"/>
-          <p:nvPr/>
-        </p:nvSpPr>
-        <p:spPr>
-          <a:xfrm>
-            <a:off x="9656064" y="2103120"/>
-            <a:ext cx="1371600" cy="457200"/>
-          </a:xfrm>
-          <a:prstGeom prst="rect">
-            <a:avLst/>
-          </a:prstGeom>
-          <a:noFill/>
-        </p:spPr>
-        <p:txBody>
-          <a:bodyPr wrap="square" lIns="0" rIns="0" tIns="0" bIns="0" anchor="t">
-            <a:spAutoFit/>
-          </a:bodyPr>
-          <a:lstStyle/>
-          <a:p>
-            <a:pPr algn="l">
-              <a:lnSpc>
-                <a:spcPct val="115000"/>
-              </a:lnSpc>
-            </a:pPr>
-            <a:r>
-              <a:rPr sz="2400" b="0">
-                <a:solidFill>
-                  <a:srgbClr val="12A87B"/>
-                </a:solidFill>
-                <a:latin typeface="Montserrat"/>
-              </a:rPr>
-              <a:t>05</a:t>
-            </a:r>
-          </a:p>
-        </p:txBody>
-      </p:sp>
       <p:pic>
         <p:nvPicPr>
-          <p:cNvPr id="32" name="Picture 31" descr="handshake_green.png"/>
-          <p:cNvPicPr>
-            <a:picLocks noChangeAspect="1"/>
-          </p:cNvPicPr>
-          <p:nvPr/>
-        </p:nvPicPr>
-        <p:blipFill>
-          <a:blip r:embed="rId6"/>
-          <a:stretch>
-            <a:fillRect/>
-          </a:stretch>
-        </p:blipFill>
-        <p:spPr>
-          <a:xfrm>
-            <a:off x="10844784" y="2148840"/>
-            <a:ext cx="365760" cy="365760"/>
-          </a:xfrm>
-          <a:prstGeom prst="rect">
-            <a:avLst/>
-          </a:prstGeom>
-        </p:spPr>
-      </p:pic>
-      <p:sp>
-        <p:nvSpPr>
-          <p:cNvPr id="33" name="TextBox 32"/>
-          <p:cNvSpPr txBox="1"/>
-          <p:nvPr/>
-        </p:nvSpPr>
-        <p:spPr>
-          <a:xfrm>
-            <a:off x="9656064" y="2743200"/>
-            <a:ext cx="1645920" cy="548640"/>
-          </a:xfrm>
-          <a:prstGeom prst="rect">
-            <a:avLst/>
-          </a:prstGeom>
-          <a:noFill/>
-        </p:spPr>
-        <p:txBody>
-          <a:bodyPr wrap="square" lIns="0" rIns="0" tIns="0" bIns="0" anchor="t">
-            <a:spAutoFit/>
-          </a:bodyPr>
-          <a:lstStyle/>
-          <a:p>
-            <a:pPr algn="l">
-              <a:lnSpc>
-                <a:spcPct val="115000"/>
-              </a:lnSpc>
-            </a:pPr>
-            <a:r>
-              <a:rPr sz="1200" b="1">
-                <a:solidFill>
-                  <a:srgbClr val="1B1B2F"/>
-                </a:solidFill>
-                <a:latin typeface="Montserrat"/>
-              </a:rPr>
-              <a:t>Contrato contínuo</a:t>
-            </a:r>
-          </a:p>
-        </p:txBody>
-      </p:sp>
-      <p:sp>
-        <p:nvSpPr>
-          <p:cNvPr id="34" name="TextBox 33"/>
-          <p:cNvSpPr txBox="1"/>
-          <p:nvPr/>
-        </p:nvSpPr>
-        <p:spPr>
-          <a:xfrm>
-            <a:off x="9656064" y="3337560"/>
-            <a:ext cx="1645920" cy="1097280"/>
-          </a:xfrm>
-          <a:prstGeom prst="rect">
-            <a:avLst/>
-          </a:prstGeom>
-          <a:noFill/>
-        </p:spPr>
-        <p:txBody>
-          <a:bodyPr wrap="square" lIns="0" rIns="0" tIns="0" bIns="0" anchor="t">
-            <a:spAutoFit/>
-          </a:bodyPr>
-          <a:lstStyle/>
-          <a:p>
-            <a:pPr algn="l">
-              <a:lnSpc>
-                <a:spcPct val="115000"/>
-              </a:lnSpc>
-            </a:pPr>
-            <a:r>
-              <a:rPr sz="1000" b="0">
-                <a:solidFill>
-                  <a:srgbClr val="6B6B80"/>
-                </a:solidFill>
-                <a:latin typeface="Montserrat"/>
-              </a:rPr>
-              <a:t>Fornecimento regular e programado.</a:t>
-            </a:r>
-          </a:p>
-        </p:txBody>
-      </p:sp>
-      <p:sp>
-        <p:nvSpPr>
-          <p:cNvPr id="35" name="TextBox 34"/>
-          <p:cNvSpPr txBox="1"/>
-          <p:nvPr/>
-        </p:nvSpPr>
-        <p:spPr>
-          <a:xfrm>
-            <a:off x="758952" y="4892040"/>
-            <a:ext cx="10607040" cy="731520"/>
-          </a:xfrm>
-          <a:prstGeom prst="rect">
-            <a:avLst/>
-          </a:prstGeom>
-          <a:noFill/>
-        </p:spPr>
-        <p:txBody>
-          <a:bodyPr wrap="square" lIns="0" rIns="0" tIns="0" bIns="0" anchor="t">
-            <a:spAutoFit/>
-          </a:bodyPr>
-          <a:lstStyle/>
-          <a:p>
-            <a:pPr algn="l">
-              <a:lnSpc>
-                <a:spcPct val="115000"/>
-              </a:lnSpc>
-            </a:pPr>
-            <a:r>
-              <a:rPr sz="1200" b="1">
-                <a:solidFill>
-                  <a:srgbClr val="3432C9"/>
-                </a:solidFill>
-                <a:latin typeface="Montserrat"/>
-              </a:rPr>
-              <a:t>Solicitamos cotação formal em R$/t </a:t>
-            </a:r>
-            <a:r>
-              <a:rPr sz="1200" b="0">
-                <a:solidFill>
-                  <a:srgbClr val="6B6B80"/>
-                </a:solidFill>
-                <a:latin typeface="Montserrat"/>
-              </a:rPr>
-              <a:t>para o fornecimento de 1.000 t/mês com entrega programada na unidade do cliente. As condições finais serão definidas em reunião.</a:t>
-            </a:r>
-          </a:p>
-        </p:txBody>
-      </p:sp>
-      <p:cxnSp>
-        <p:nvCxnSpPr>
-          <p:cNvPr id="36" name="Connector 35"/>
-          <p:cNvCxnSpPr/>
-          <p:nvPr/>
-        </p:nvCxnSpPr>
-        <p:spPr>
-          <a:xfrm>
-            <a:off x="758952" y="6199632"/>
-            <a:ext cx="10671048" cy="0"/>
-          </a:xfrm>
-          <a:prstGeom prst="line">
-            <a:avLst/>
-          </a:prstGeom>
-          <a:ln w="9525">
-            <a:solidFill>
-              <a:srgbClr val="DDDEEE"/>
-            </a:solidFill>
-          </a:ln>
-        </p:spPr>
-      </p:cxnSp>
-      <p:pic>
-        <p:nvPicPr>
-          <p:cNvPr id="37" name="Picture 36" descr="logo_dark.png"/>
+          <p:cNvPr id="23" name="Picture 22" descr="mountain_green.png"/>
           <p:cNvPicPr>
             <a:picLocks noChangeAspect="1"/>
           </p:cNvPicPr>
@@ -7683,6 +7210,216 @@
         </p:blipFill>
         <p:spPr>
           <a:xfrm>
+            <a:off x="8257032" y="4187952"/>
+            <a:ext cx="365760" cy="365760"/>
+          </a:xfrm>
+          <a:prstGeom prst="rect">
+            <a:avLst/>
+          </a:prstGeom>
+        </p:spPr>
+      </p:pic>
+      <p:sp>
+        <p:nvSpPr>
+          <p:cNvPr id="24" name="TextBox 23"/>
+          <p:cNvSpPr txBox="1"/>
+          <p:nvPr/>
+        </p:nvSpPr>
+        <p:spPr>
+          <a:xfrm>
+            <a:off x="8759952" y="4160520"/>
+            <a:ext cx="1737360" cy="411480"/>
+          </a:xfrm>
+          <a:prstGeom prst="rect">
+            <a:avLst/>
+          </a:prstGeom>
+          <a:noFill/>
+        </p:spPr>
+        <p:txBody>
+          <a:bodyPr wrap="square" lIns="0" rIns="0" tIns="0" bIns="0" anchor="ctr">
+            <a:spAutoFit/>
+          </a:bodyPr>
+          <a:lstStyle/>
+          <a:p>
+            <a:pPr algn="l">
+              <a:lnSpc>
+                <a:spcPct val="115000"/>
+              </a:lnSpc>
+            </a:pPr>
+            <a:r>
+              <a:rPr sz="1400" b="1">
+                <a:solidFill>
+                  <a:srgbClr val="1B1B2F"/>
+                </a:solidFill>
+                <a:latin typeface="Montserrat"/>
+              </a:rPr>
+              <a:t>Pedra-brita</a:t>
+            </a:r>
+          </a:p>
+        </p:txBody>
+      </p:sp>
+      <p:sp>
+        <p:nvSpPr>
+          <p:cNvPr id="25" name="TextBox 24"/>
+          <p:cNvSpPr txBox="1"/>
+          <p:nvPr/>
+        </p:nvSpPr>
+        <p:spPr>
+          <a:xfrm>
+            <a:off x="10314432" y="4114800"/>
+            <a:ext cx="868680" cy="502920"/>
+          </a:xfrm>
+          <a:prstGeom prst="rect">
+            <a:avLst/>
+          </a:prstGeom>
+          <a:noFill/>
+        </p:spPr>
+        <p:txBody>
+          <a:bodyPr wrap="square" lIns="0" rIns="0" tIns="0" bIns="0" anchor="t">
+            <a:spAutoFit/>
+          </a:bodyPr>
+          <a:lstStyle/>
+          <a:p>
+            <a:pPr algn="r">
+              <a:lnSpc>
+                <a:spcPct val="115000"/>
+              </a:lnSpc>
+            </a:pPr>
+            <a:r>
+              <a:rPr sz="2600" b="1">
+                <a:solidFill>
+                  <a:srgbClr val="12A87B"/>
+                </a:solidFill>
+                <a:latin typeface="Montserrat"/>
+              </a:rPr>
+              <a:t>5</a:t>
+            </a:r>
+            <a:r>
+              <a:rPr sz="1200" b="0">
+                <a:solidFill>
+                  <a:srgbClr val="12A87B"/>
+                </a:solidFill>
+                <a:latin typeface="Montserrat"/>
+              </a:rPr>
+              <a:t> kg</a:t>
+            </a:r>
+          </a:p>
+        </p:txBody>
+      </p:sp>
+      <p:sp>
+        <p:nvSpPr>
+          <p:cNvPr id="26" name="TextBox 25"/>
+          <p:cNvSpPr txBox="1"/>
+          <p:nvPr/>
+        </p:nvSpPr>
+        <p:spPr>
+          <a:xfrm>
+            <a:off x="8257032" y="4754880"/>
+            <a:ext cx="2880360" cy="731520"/>
+          </a:xfrm>
+          <a:prstGeom prst="rect">
+            <a:avLst/>
+          </a:prstGeom>
+          <a:noFill/>
+        </p:spPr>
+        <p:txBody>
+          <a:bodyPr wrap="square" lIns="0" rIns="0" tIns="0" bIns="0" anchor="t">
+            <a:spAutoFit/>
+          </a:bodyPr>
+          <a:lstStyle/>
+          <a:p>
+            <a:pPr algn="l">
+              <a:lnSpc>
+                <a:spcPct val="115000"/>
+              </a:lnSpc>
+            </a:pPr>
+            <a:r>
+              <a:rPr sz="1000" b="0">
+                <a:solidFill>
+                  <a:srgbClr val="6B6B80"/>
+                </a:solidFill>
+                <a:latin typeface="Montserrat"/>
+              </a:rPr>
+              <a:t>Material compactado em blocos, mais denso para transporte e estocagem.</a:t>
+            </a:r>
+          </a:p>
+        </p:txBody>
+      </p:sp>
+      <p:sp>
+        <p:nvSpPr>
+          <p:cNvPr id="27" name="TextBox 26"/>
+          <p:cNvSpPr txBox="1"/>
+          <p:nvPr/>
+        </p:nvSpPr>
+        <p:spPr>
+          <a:xfrm>
+            <a:off x="758952" y="5760720"/>
+            <a:ext cx="10607040" cy="320040"/>
+          </a:xfrm>
+          <a:prstGeom prst="rect">
+            <a:avLst/>
+          </a:prstGeom>
+          <a:noFill/>
+        </p:spPr>
+        <p:txBody>
+          <a:bodyPr wrap="square" lIns="0" rIns="0" tIns="0" bIns="0" anchor="t">
+            <a:spAutoFit/>
+          </a:bodyPr>
+          <a:lstStyle/>
+          <a:p>
+            <a:pPr algn="l">
+              <a:lnSpc>
+                <a:spcPct val="115000"/>
+              </a:lnSpc>
+            </a:pPr>
+            <a:r>
+              <a:rPr sz="900" b="0">
+                <a:solidFill>
+                  <a:srgbClr val="6B6B80"/>
+                </a:solidFill>
+                <a:latin typeface="Montserrat"/>
+              </a:rPr>
+              <a:t>Amostras identificadas por lote e acompanhadas da ficha técnica do material.</a:t>
+            </a:r>
+          </a:p>
+        </p:txBody>
+      </p:sp>
+      <p:cxnSp>
+        <p:nvCxnSpPr>
+          <p:cNvPr id="28" name="Connector 27"/>
+          <p:cNvCxnSpPr/>
+          <p:nvPr/>
+        </p:nvCxnSpPr>
+        <p:spPr>
+          <a:xfrm>
+            <a:off x="758952" y="6199632"/>
+            <a:ext cx="10671048" cy="0"/>
+          </a:xfrm>
+          <a:prstGeom prst="line">
+            <a:avLst/>
+          </a:prstGeom>
+          <a:ln w="9525">
+            <a:solidFill>
+              <a:srgbClr val="DDDEEE"/>
+            </a:solidFill>
+          </a:ln>
+        </p:spPr>
+      </p:cxnSp>
+      <p:pic>
+        <p:nvPicPr>
+          <p:cNvPr id="29" name="Picture 28" descr="logo_dark.png"/>
+          <p:cNvPicPr>
+            <a:picLocks noChangeAspect="1"/>
+          </p:cNvPicPr>
+          <p:nvPr/>
+        </p:nvPicPr>
+        <p:blipFill>
+          <a:blip r:embed="rId8"/>
+          <a:stretch>
+            <a:fillRect/>
+          </a:stretch>
+        </p:blipFill>
+        <p:spPr>
+          <a:xfrm>
             <a:off x="758952" y="6309360"/>
             <a:ext cx="1150185" cy="274320"/>
           </a:xfrm>
@@ -7693,7 +7430,7 @@
       </p:pic>
       <p:sp>
         <p:nvSpPr>
-          <p:cNvPr id="38" name="TextBox 37"/>
+          <p:cNvPr id="30" name="TextBox 29"/>
           <p:cNvSpPr txBox="1"/>
           <p:nvPr/>
         </p:nvSpPr>
@@ -7739,6 +7476,1277 @@
 </file>
 
 <file path=ppt/slides/slide14.xml><?xml version="1.0" encoding="utf-8"?>
+<p:sld xmlns:a="http://schemas.openxmlformats.org/drawingml/2006/main" xmlns:p="http://schemas.openxmlformats.org/presentationml/2006/main" xmlns:r="http://schemas.openxmlformats.org/officeDocument/2006/relationships">
+  <p:cSld>
+    <p:bg>
+      <p:bgPr>
+        <a:solidFill>
+          <a:srgbClr val="FFFFFF"/>
+        </a:solidFill>
+        <a:effectLst/>
+      </p:bgPr>
+    </p:bg>
+    <p:spTree>
+      <p:nvGrpSpPr>
+        <p:cNvPr id="1" name=""/>
+        <p:cNvGrpSpPr/>
+        <p:nvPr/>
+      </p:nvGrpSpPr>
+      <p:grpSpPr/>
+      <p:cxnSp>
+        <p:nvCxnSpPr>
+          <p:cNvPr id="2" name="Connector 1"/>
+          <p:cNvCxnSpPr/>
+          <p:nvPr/>
+        </p:nvCxnSpPr>
+        <p:spPr>
+          <a:xfrm>
+            <a:off x="758952" y="594360"/>
+            <a:ext cx="292608" cy="0"/>
+          </a:xfrm>
+          <a:prstGeom prst="line">
+            <a:avLst/>
+          </a:prstGeom>
+          <a:ln w="12700">
+            <a:solidFill>
+              <a:srgbClr val="3432C9"/>
+            </a:solidFill>
+          </a:ln>
+        </p:spPr>
+      </p:cxnSp>
+      <p:sp>
+        <p:nvSpPr>
+          <p:cNvPr id="3" name="TextBox 2"/>
+          <p:cNvSpPr txBox="1"/>
+          <p:nvPr/>
+        </p:nvSpPr>
+        <p:spPr>
+          <a:xfrm>
+            <a:off x="1170432" y="502920"/>
+            <a:ext cx="5486400" cy="228600"/>
+          </a:xfrm>
+          <a:prstGeom prst="rect">
+            <a:avLst/>
+          </a:prstGeom>
+          <a:noFill/>
+        </p:spPr>
+        <p:txBody>
+          <a:bodyPr wrap="square" lIns="0" rIns="0" tIns="0" bIns="0" anchor="t">
+            <a:spAutoFit/>
+          </a:bodyPr>
+          <a:lstStyle/>
+          <a:p>
+            <a:pPr algn="l">
+              <a:lnSpc>
+                <a:spcPct val="115000"/>
+              </a:lnSpc>
+            </a:pPr>
+            <a:r>
+              <a:rPr sz="900" b="0" spc="200">
+                <a:solidFill>
+                  <a:srgbClr val="3432C9"/>
+                </a:solidFill>
+                <a:latin typeface="Montserrat"/>
+              </a:rPr>
+              <a:t>Implantação</a:t>
+            </a:r>
+          </a:p>
+        </p:txBody>
+      </p:sp>
+      <p:sp>
+        <p:nvSpPr>
+          <p:cNvPr id="4" name="TextBox 3"/>
+          <p:cNvSpPr txBox="1"/>
+          <p:nvPr/>
+        </p:nvSpPr>
+        <p:spPr>
+          <a:xfrm>
+            <a:off x="758952" y="777240"/>
+            <a:ext cx="10698480" cy="640080"/>
+          </a:xfrm>
+          <a:prstGeom prst="rect">
+            <a:avLst/>
+          </a:prstGeom>
+          <a:noFill/>
+        </p:spPr>
+        <p:txBody>
+          <a:bodyPr wrap="square" lIns="0" rIns="0" tIns="0" bIns="0" anchor="t">
+            <a:spAutoFit/>
+          </a:bodyPr>
+          <a:lstStyle/>
+          <a:p>
+            <a:pPr algn="l">
+              <a:lnSpc>
+                <a:spcPct val="115000"/>
+              </a:lnSpc>
+            </a:pPr>
+            <a:r>
+              <a:rPr sz="2800" b="0">
+                <a:solidFill>
+                  <a:srgbClr val="1B1B2F"/>
+                </a:solidFill>
+                <a:latin typeface="Montserrat"/>
+              </a:rPr>
+              <a:t>Próximos </a:t>
+            </a:r>
+            <a:r>
+              <a:rPr sz="2800" b="1">
+                <a:solidFill>
+                  <a:srgbClr val="1B1B2F"/>
+                </a:solidFill>
+                <a:latin typeface="Montserrat"/>
+              </a:rPr>
+              <a:t>passos</a:t>
+            </a:r>
+          </a:p>
+        </p:txBody>
+      </p:sp>
+      <p:sp>
+        <p:nvSpPr>
+          <p:cNvPr id="5" name="Rectangle 4"/>
+          <p:cNvSpPr/>
+          <p:nvPr/>
+        </p:nvSpPr>
+        <p:spPr>
+          <a:xfrm>
+            <a:off x="758952" y="1828800"/>
+            <a:ext cx="2011680" cy="2743200"/>
+          </a:xfrm>
+          <a:prstGeom prst="rect">
+            <a:avLst/>
+          </a:prstGeom>
+          <a:solidFill>
+            <a:srgbClr val="F4F5FC"/>
+          </a:solidFill>
+          <a:ln>
+            <a:noFill/>
+          </a:ln>
+          <a:effectLst/>
+        </p:spPr>
+        <p:txBody>
+          <a:bodyPr rtlCol="0" anchor="ctr"/>
+          <a:lstStyle/>
+          <a:p>
+            <a:pPr algn="ctr"/>
+          </a:p>
+        </p:txBody>
+      </p:sp>
+      <p:sp>
+        <p:nvSpPr>
+          <p:cNvPr id="6" name="Rectangle 5"/>
+          <p:cNvSpPr/>
+          <p:nvPr/>
+        </p:nvSpPr>
+        <p:spPr>
+          <a:xfrm>
+            <a:off x="758952" y="1828800"/>
+            <a:ext cx="2011680" cy="54864"/>
+          </a:xfrm>
+          <a:prstGeom prst="rect">
+            <a:avLst/>
+          </a:prstGeom>
+          <a:solidFill>
+            <a:srgbClr val="3432C9"/>
+          </a:solidFill>
+          <a:ln>
+            <a:noFill/>
+          </a:ln>
+          <a:effectLst/>
+        </p:spPr>
+        <p:txBody>
+          <a:bodyPr rtlCol="0" anchor="ctr"/>
+          <a:lstStyle/>
+          <a:p>
+            <a:pPr algn="ctr"/>
+          </a:p>
+        </p:txBody>
+      </p:sp>
+      <p:sp>
+        <p:nvSpPr>
+          <p:cNvPr id="7" name="TextBox 6"/>
+          <p:cNvSpPr txBox="1"/>
+          <p:nvPr/>
+        </p:nvSpPr>
+        <p:spPr>
+          <a:xfrm>
+            <a:off x="987552" y="2103120"/>
+            <a:ext cx="1371600" cy="457200"/>
+          </a:xfrm>
+          <a:prstGeom prst="rect">
+            <a:avLst/>
+          </a:prstGeom>
+          <a:noFill/>
+        </p:spPr>
+        <p:txBody>
+          <a:bodyPr wrap="square" lIns="0" rIns="0" tIns="0" bIns="0" anchor="t">
+            <a:spAutoFit/>
+          </a:bodyPr>
+          <a:lstStyle/>
+          <a:p>
+            <a:pPr algn="l">
+              <a:lnSpc>
+                <a:spcPct val="115000"/>
+              </a:lnSpc>
+            </a:pPr>
+            <a:r>
+              <a:rPr sz="2400" b="0">
+                <a:solidFill>
+                  <a:srgbClr val="3432C9"/>
+                </a:solidFill>
+                <a:latin typeface="Montserrat"/>
+              </a:rPr>
+              <a:t>01</a:t>
+            </a:r>
+          </a:p>
+        </p:txBody>
+      </p:sp>
+      <p:pic>
+        <p:nvPicPr>
+          <p:cNvPr id="8" name="Picture 7" descr="send_royal.png"/>
+          <p:cNvPicPr>
+            <a:picLocks noChangeAspect="1"/>
+          </p:cNvPicPr>
+          <p:nvPr/>
+        </p:nvPicPr>
+        <p:blipFill>
+          <a:blip r:embed="rId2"/>
+          <a:stretch>
+            <a:fillRect/>
+          </a:stretch>
+        </p:blipFill>
+        <p:spPr>
+          <a:xfrm>
+            <a:off x="2176272" y="2148840"/>
+            <a:ext cx="365760" cy="365760"/>
+          </a:xfrm>
+          <a:prstGeom prst="rect">
+            <a:avLst/>
+          </a:prstGeom>
+        </p:spPr>
+      </p:pic>
+      <p:sp>
+        <p:nvSpPr>
+          <p:cNvPr id="9" name="TextBox 8"/>
+          <p:cNvSpPr txBox="1"/>
+          <p:nvPr/>
+        </p:nvSpPr>
+        <p:spPr>
+          <a:xfrm>
+            <a:off x="987552" y="2743200"/>
+            <a:ext cx="1645920" cy="548640"/>
+          </a:xfrm>
+          <a:prstGeom prst="rect">
+            <a:avLst/>
+          </a:prstGeom>
+          <a:noFill/>
+        </p:spPr>
+        <p:txBody>
+          <a:bodyPr wrap="square" lIns="0" rIns="0" tIns="0" bIns="0" anchor="t">
+            <a:spAutoFit/>
+          </a:bodyPr>
+          <a:lstStyle/>
+          <a:p>
+            <a:pPr algn="l">
+              <a:lnSpc>
+                <a:spcPct val="115000"/>
+              </a:lnSpc>
+            </a:pPr>
+            <a:r>
+              <a:rPr sz="1200" b="1">
+                <a:solidFill>
+                  <a:srgbClr val="1B1B2F"/>
+                </a:solidFill>
+                <a:latin typeface="Montserrat"/>
+              </a:rPr>
+              <a:t>Envio de amostras</a:t>
+            </a:r>
+          </a:p>
+        </p:txBody>
+      </p:sp>
+      <p:sp>
+        <p:nvSpPr>
+          <p:cNvPr id="10" name="TextBox 9"/>
+          <p:cNvSpPr txBox="1"/>
+          <p:nvPr/>
+        </p:nvSpPr>
+        <p:spPr>
+          <a:xfrm>
+            <a:off x="987552" y="3337560"/>
+            <a:ext cx="1645920" cy="1097280"/>
+          </a:xfrm>
+          <a:prstGeom prst="rect">
+            <a:avLst/>
+          </a:prstGeom>
+          <a:noFill/>
+        </p:spPr>
+        <p:txBody>
+          <a:bodyPr wrap="square" lIns="0" rIns="0" tIns="0" bIns="0" anchor="t">
+            <a:spAutoFit/>
+          </a:bodyPr>
+          <a:lstStyle/>
+          <a:p>
+            <a:pPr algn="l">
+              <a:lnSpc>
+                <a:spcPct val="115000"/>
+              </a:lnSpc>
+            </a:pPr>
+            <a:r>
+              <a:rPr sz="1000" b="0">
+                <a:solidFill>
+                  <a:srgbClr val="6B6B80"/>
+                </a:solidFill>
+                <a:latin typeface="Montserrat"/>
+              </a:rPr>
+              <a:t>5 kg de picotado, 5 kg de moído e 5 kg de pedra-brita.</a:t>
+            </a:r>
+          </a:p>
+        </p:txBody>
+      </p:sp>
+      <p:sp>
+        <p:nvSpPr>
+          <p:cNvPr id="11" name="Rectangle 10"/>
+          <p:cNvSpPr/>
+          <p:nvPr/>
+        </p:nvSpPr>
+        <p:spPr>
+          <a:xfrm>
+            <a:off x="2926080" y="1828800"/>
+            <a:ext cx="2011680" cy="2743200"/>
+          </a:xfrm>
+          <a:prstGeom prst="rect">
+            <a:avLst/>
+          </a:prstGeom>
+          <a:solidFill>
+            <a:srgbClr val="F4F5FC"/>
+          </a:solidFill>
+          <a:ln>
+            <a:noFill/>
+          </a:ln>
+          <a:effectLst/>
+        </p:spPr>
+        <p:txBody>
+          <a:bodyPr rtlCol="0" anchor="ctr"/>
+          <a:lstStyle/>
+          <a:p>
+            <a:pPr algn="ctr"/>
+          </a:p>
+        </p:txBody>
+      </p:sp>
+      <p:sp>
+        <p:nvSpPr>
+          <p:cNvPr id="12" name="Rectangle 11"/>
+          <p:cNvSpPr/>
+          <p:nvPr/>
+        </p:nvSpPr>
+        <p:spPr>
+          <a:xfrm>
+            <a:off x="2926080" y="1828800"/>
+            <a:ext cx="2011680" cy="54864"/>
+          </a:xfrm>
+          <a:prstGeom prst="rect">
+            <a:avLst/>
+          </a:prstGeom>
+          <a:solidFill>
+            <a:srgbClr val="3432C9"/>
+          </a:solidFill>
+          <a:ln>
+            <a:noFill/>
+          </a:ln>
+          <a:effectLst/>
+        </p:spPr>
+        <p:txBody>
+          <a:bodyPr rtlCol="0" anchor="ctr"/>
+          <a:lstStyle/>
+          <a:p>
+            <a:pPr algn="ctr"/>
+          </a:p>
+        </p:txBody>
+      </p:sp>
+      <p:sp>
+        <p:nvSpPr>
+          <p:cNvPr id="13" name="TextBox 12"/>
+          <p:cNvSpPr txBox="1"/>
+          <p:nvPr/>
+        </p:nvSpPr>
+        <p:spPr>
+          <a:xfrm>
+            <a:off x="3154680" y="2103120"/>
+            <a:ext cx="1371600" cy="457200"/>
+          </a:xfrm>
+          <a:prstGeom prst="rect">
+            <a:avLst/>
+          </a:prstGeom>
+          <a:noFill/>
+        </p:spPr>
+        <p:txBody>
+          <a:bodyPr wrap="square" lIns="0" rIns="0" tIns="0" bIns="0" anchor="t">
+            <a:spAutoFit/>
+          </a:bodyPr>
+          <a:lstStyle/>
+          <a:p>
+            <a:pPr algn="l">
+              <a:lnSpc>
+                <a:spcPct val="115000"/>
+              </a:lnSpc>
+            </a:pPr>
+            <a:r>
+              <a:rPr sz="2400" b="0">
+                <a:solidFill>
+                  <a:srgbClr val="3432C9"/>
+                </a:solidFill>
+                <a:latin typeface="Montserrat"/>
+              </a:rPr>
+              <a:t>02</a:t>
+            </a:r>
+          </a:p>
+        </p:txBody>
+      </p:sp>
+      <p:pic>
+        <p:nvPicPr>
+          <p:cNvPr id="14" name="Picture 13" descr="flame_royal.png"/>
+          <p:cNvPicPr>
+            <a:picLocks noChangeAspect="1"/>
+          </p:cNvPicPr>
+          <p:nvPr/>
+        </p:nvPicPr>
+        <p:blipFill>
+          <a:blip r:embed="rId3"/>
+          <a:stretch>
+            <a:fillRect/>
+          </a:stretch>
+        </p:blipFill>
+        <p:spPr>
+          <a:xfrm>
+            <a:off x="4343400" y="2148840"/>
+            <a:ext cx="365760" cy="365760"/>
+          </a:xfrm>
+          <a:prstGeom prst="rect">
+            <a:avLst/>
+          </a:prstGeom>
+        </p:spPr>
+      </p:pic>
+      <p:sp>
+        <p:nvSpPr>
+          <p:cNvPr id="15" name="TextBox 14"/>
+          <p:cNvSpPr txBox="1"/>
+          <p:nvPr/>
+        </p:nvSpPr>
+        <p:spPr>
+          <a:xfrm>
+            <a:off x="3154680" y="2743200"/>
+            <a:ext cx="1645920" cy="548640"/>
+          </a:xfrm>
+          <a:prstGeom prst="rect">
+            <a:avLst/>
+          </a:prstGeom>
+          <a:noFill/>
+        </p:spPr>
+        <p:txBody>
+          <a:bodyPr wrap="square" lIns="0" rIns="0" tIns="0" bIns="0" anchor="t">
+            <a:spAutoFit/>
+          </a:bodyPr>
+          <a:lstStyle/>
+          <a:p>
+            <a:pPr algn="l">
+              <a:lnSpc>
+                <a:spcPct val="115000"/>
+              </a:lnSpc>
+            </a:pPr>
+            <a:r>
+              <a:rPr sz="1200" b="1">
+                <a:solidFill>
+                  <a:srgbClr val="1B1B2F"/>
+                </a:solidFill>
+                <a:latin typeface="Montserrat"/>
+              </a:rPr>
+              <a:t>Teste de queima</a:t>
+            </a:r>
+          </a:p>
+        </p:txBody>
+      </p:sp>
+      <p:sp>
+        <p:nvSpPr>
+          <p:cNvPr id="16" name="TextBox 15"/>
+          <p:cNvSpPr txBox="1"/>
+          <p:nvPr/>
+        </p:nvSpPr>
+        <p:spPr>
+          <a:xfrm>
+            <a:off x="3154680" y="3337560"/>
+            <a:ext cx="1645920" cy="1097280"/>
+          </a:xfrm>
+          <a:prstGeom prst="rect">
+            <a:avLst/>
+          </a:prstGeom>
+          <a:noFill/>
+        </p:spPr>
+        <p:txBody>
+          <a:bodyPr wrap="square" lIns="0" rIns="0" tIns="0" bIns="0" anchor="t">
+            <a:spAutoFit/>
+          </a:bodyPr>
+          <a:lstStyle/>
+          <a:p>
+            <a:pPr algn="l">
+              <a:lnSpc>
+                <a:spcPct val="115000"/>
+              </a:lnSpc>
+            </a:pPr>
+            <a:r>
+              <a:rPr sz="1000" b="0">
+                <a:solidFill>
+                  <a:srgbClr val="6B6B80"/>
+                </a:solidFill>
+                <a:latin typeface="Montserrat"/>
+              </a:rPr>
+              <a:t>Ensaio controlado no equipamento de destino.</a:t>
+            </a:r>
+          </a:p>
+        </p:txBody>
+      </p:sp>
+      <p:sp>
+        <p:nvSpPr>
+          <p:cNvPr id="17" name="Rectangle 16"/>
+          <p:cNvSpPr/>
+          <p:nvPr/>
+        </p:nvSpPr>
+        <p:spPr>
+          <a:xfrm>
+            <a:off x="5093208" y="1828800"/>
+            <a:ext cx="2011680" cy="2743200"/>
+          </a:xfrm>
+          <a:prstGeom prst="rect">
+            <a:avLst/>
+          </a:prstGeom>
+          <a:solidFill>
+            <a:srgbClr val="F4F5FC"/>
+          </a:solidFill>
+          <a:ln>
+            <a:noFill/>
+          </a:ln>
+          <a:effectLst/>
+        </p:spPr>
+        <p:txBody>
+          <a:bodyPr rtlCol="0" anchor="ctr"/>
+          <a:lstStyle/>
+          <a:p>
+            <a:pPr algn="ctr"/>
+          </a:p>
+        </p:txBody>
+      </p:sp>
+      <p:sp>
+        <p:nvSpPr>
+          <p:cNvPr id="18" name="Rectangle 17"/>
+          <p:cNvSpPr/>
+          <p:nvPr/>
+        </p:nvSpPr>
+        <p:spPr>
+          <a:xfrm>
+            <a:off x="5093208" y="1828800"/>
+            <a:ext cx="2011680" cy="54864"/>
+          </a:xfrm>
+          <a:prstGeom prst="rect">
+            <a:avLst/>
+          </a:prstGeom>
+          <a:solidFill>
+            <a:srgbClr val="3432C9"/>
+          </a:solidFill>
+          <a:ln>
+            <a:noFill/>
+          </a:ln>
+          <a:effectLst/>
+        </p:spPr>
+        <p:txBody>
+          <a:bodyPr rtlCol="0" anchor="ctr"/>
+          <a:lstStyle/>
+          <a:p>
+            <a:pPr algn="ctr"/>
+          </a:p>
+        </p:txBody>
+      </p:sp>
+      <p:sp>
+        <p:nvSpPr>
+          <p:cNvPr id="19" name="TextBox 18"/>
+          <p:cNvSpPr txBox="1"/>
+          <p:nvPr/>
+        </p:nvSpPr>
+        <p:spPr>
+          <a:xfrm>
+            <a:off x="5321808" y="2103120"/>
+            <a:ext cx="1371600" cy="457200"/>
+          </a:xfrm>
+          <a:prstGeom prst="rect">
+            <a:avLst/>
+          </a:prstGeom>
+          <a:noFill/>
+        </p:spPr>
+        <p:txBody>
+          <a:bodyPr wrap="square" lIns="0" rIns="0" tIns="0" bIns="0" anchor="t">
+            <a:spAutoFit/>
+          </a:bodyPr>
+          <a:lstStyle/>
+          <a:p>
+            <a:pPr algn="l">
+              <a:lnSpc>
+                <a:spcPct val="115000"/>
+              </a:lnSpc>
+            </a:pPr>
+            <a:r>
+              <a:rPr sz="2400" b="0">
+                <a:solidFill>
+                  <a:srgbClr val="3432C9"/>
+                </a:solidFill>
+                <a:latin typeface="Montserrat"/>
+              </a:rPr>
+              <a:t>03</a:t>
+            </a:r>
+          </a:p>
+        </p:txBody>
+      </p:sp>
+      <p:pic>
+        <p:nvPicPr>
+          <p:cNvPr id="20" name="Picture 19" descr="clipboard-check_royal.png"/>
+          <p:cNvPicPr>
+            <a:picLocks noChangeAspect="1"/>
+          </p:cNvPicPr>
+          <p:nvPr/>
+        </p:nvPicPr>
+        <p:blipFill>
+          <a:blip r:embed="rId4"/>
+          <a:stretch>
+            <a:fillRect/>
+          </a:stretch>
+        </p:blipFill>
+        <p:spPr>
+          <a:xfrm>
+            <a:off x="6510528" y="2148840"/>
+            <a:ext cx="365760" cy="365760"/>
+          </a:xfrm>
+          <a:prstGeom prst="rect">
+            <a:avLst/>
+          </a:prstGeom>
+        </p:spPr>
+      </p:pic>
+      <p:sp>
+        <p:nvSpPr>
+          <p:cNvPr id="21" name="TextBox 20"/>
+          <p:cNvSpPr txBox="1"/>
+          <p:nvPr/>
+        </p:nvSpPr>
+        <p:spPr>
+          <a:xfrm>
+            <a:off x="5321808" y="2743200"/>
+            <a:ext cx="1645920" cy="548640"/>
+          </a:xfrm>
+          <a:prstGeom prst="rect">
+            <a:avLst/>
+          </a:prstGeom>
+          <a:noFill/>
+        </p:spPr>
+        <p:txBody>
+          <a:bodyPr wrap="square" lIns="0" rIns="0" tIns="0" bIns="0" anchor="t">
+            <a:spAutoFit/>
+          </a:bodyPr>
+          <a:lstStyle/>
+          <a:p>
+            <a:pPr algn="l">
+              <a:lnSpc>
+                <a:spcPct val="115000"/>
+              </a:lnSpc>
+            </a:pPr>
+            <a:r>
+              <a:rPr sz="1200" b="1">
+                <a:solidFill>
+                  <a:srgbClr val="1B1B2F"/>
+                </a:solidFill>
+                <a:latin typeface="Montserrat"/>
+              </a:rPr>
+              <a:t>Licenciamento</a:t>
+            </a:r>
+          </a:p>
+        </p:txBody>
+      </p:sp>
+      <p:sp>
+        <p:nvSpPr>
+          <p:cNvPr id="22" name="TextBox 21"/>
+          <p:cNvSpPr txBox="1"/>
+          <p:nvPr/>
+        </p:nvSpPr>
+        <p:spPr>
+          <a:xfrm>
+            <a:off x="5321808" y="3337560"/>
+            <a:ext cx="1645920" cy="1097280"/>
+          </a:xfrm>
+          <a:prstGeom prst="rect">
+            <a:avLst/>
+          </a:prstGeom>
+          <a:noFill/>
+        </p:spPr>
+        <p:txBody>
+          <a:bodyPr wrap="square" lIns="0" rIns="0" tIns="0" bIns="0" anchor="t">
+            <a:spAutoFit/>
+          </a:bodyPr>
+          <a:lstStyle/>
+          <a:p>
+            <a:pPr algn="l">
+              <a:lnSpc>
+                <a:spcPct val="115000"/>
+              </a:lnSpc>
+            </a:pPr>
+            <a:r>
+              <a:rPr sz="1000" b="0">
+                <a:solidFill>
+                  <a:srgbClr val="6B6B80"/>
+                </a:solidFill>
+                <a:latin typeface="Montserrat"/>
+              </a:rPr>
+              <a:t>Adequação da licença para uso do combustível alternativo.</a:t>
+            </a:r>
+          </a:p>
+        </p:txBody>
+      </p:sp>
+      <p:sp>
+        <p:nvSpPr>
+          <p:cNvPr id="23" name="Rectangle 22"/>
+          <p:cNvSpPr/>
+          <p:nvPr/>
+        </p:nvSpPr>
+        <p:spPr>
+          <a:xfrm>
+            <a:off x="7260336" y="1828800"/>
+            <a:ext cx="2011680" cy="2743200"/>
+          </a:xfrm>
+          <a:prstGeom prst="rect">
+            <a:avLst/>
+          </a:prstGeom>
+          <a:solidFill>
+            <a:srgbClr val="F4F5FC"/>
+          </a:solidFill>
+          <a:ln>
+            <a:noFill/>
+          </a:ln>
+          <a:effectLst/>
+        </p:spPr>
+        <p:txBody>
+          <a:bodyPr rtlCol="0" anchor="ctr"/>
+          <a:lstStyle/>
+          <a:p>
+            <a:pPr algn="ctr"/>
+          </a:p>
+        </p:txBody>
+      </p:sp>
+      <p:sp>
+        <p:nvSpPr>
+          <p:cNvPr id="24" name="Rectangle 23"/>
+          <p:cNvSpPr/>
+          <p:nvPr/>
+        </p:nvSpPr>
+        <p:spPr>
+          <a:xfrm>
+            <a:off x="7260336" y="1828800"/>
+            <a:ext cx="2011680" cy="54864"/>
+          </a:xfrm>
+          <a:prstGeom prst="rect">
+            <a:avLst/>
+          </a:prstGeom>
+          <a:solidFill>
+            <a:srgbClr val="3432C9"/>
+          </a:solidFill>
+          <a:ln>
+            <a:noFill/>
+          </a:ln>
+          <a:effectLst/>
+        </p:spPr>
+        <p:txBody>
+          <a:bodyPr rtlCol="0" anchor="ctr"/>
+          <a:lstStyle/>
+          <a:p>
+            <a:pPr algn="ctr"/>
+          </a:p>
+        </p:txBody>
+      </p:sp>
+      <p:sp>
+        <p:nvSpPr>
+          <p:cNvPr id="25" name="TextBox 24"/>
+          <p:cNvSpPr txBox="1"/>
+          <p:nvPr/>
+        </p:nvSpPr>
+        <p:spPr>
+          <a:xfrm>
+            <a:off x="7488936" y="2103120"/>
+            <a:ext cx="1371600" cy="457200"/>
+          </a:xfrm>
+          <a:prstGeom prst="rect">
+            <a:avLst/>
+          </a:prstGeom>
+          <a:noFill/>
+        </p:spPr>
+        <p:txBody>
+          <a:bodyPr wrap="square" lIns="0" rIns="0" tIns="0" bIns="0" anchor="t">
+            <a:spAutoFit/>
+          </a:bodyPr>
+          <a:lstStyle/>
+          <a:p>
+            <a:pPr algn="l">
+              <a:lnSpc>
+                <a:spcPct val="115000"/>
+              </a:lnSpc>
+            </a:pPr>
+            <a:r>
+              <a:rPr sz="2400" b="0">
+                <a:solidFill>
+                  <a:srgbClr val="3432C9"/>
+                </a:solidFill>
+                <a:latin typeface="Montserrat"/>
+              </a:rPr>
+              <a:t>04</a:t>
+            </a:r>
+          </a:p>
+        </p:txBody>
+      </p:sp>
+      <p:pic>
+        <p:nvPicPr>
+          <p:cNvPr id="26" name="Picture 25" descr="play_royal.png"/>
+          <p:cNvPicPr>
+            <a:picLocks noChangeAspect="1"/>
+          </p:cNvPicPr>
+          <p:nvPr/>
+        </p:nvPicPr>
+        <p:blipFill>
+          <a:blip r:embed="rId5"/>
+          <a:stretch>
+            <a:fillRect/>
+          </a:stretch>
+        </p:blipFill>
+        <p:spPr>
+          <a:xfrm>
+            <a:off x="8677656" y="2148840"/>
+            <a:ext cx="365760" cy="365760"/>
+          </a:xfrm>
+          <a:prstGeom prst="rect">
+            <a:avLst/>
+          </a:prstGeom>
+        </p:spPr>
+      </p:pic>
+      <p:sp>
+        <p:nvSpPr>
+          <p:cNvPr id="27" name="TextBox 26"/>
+          <p:cNvSpPr txBox="1"/>
+          <p:nvPr/>
+        </p:nvSpPr>
+        <p:spPr>
+          <a:xfrm>
+            <a:off x="7488936" y="2743200"/>
+            <a:ext cx="1645920" cy="548640"/>
+          </a:xfrm>
+          <a:prstGeom prst="rect">
+            <a:avLst/>
+          </a:prstGeom>
+          <a:noFill/>
+        </p:spPr>
+        <p:txBody>
+          <a:bodyPr wrap="square" lIns="0" rIns="0" tIns="0" bIns="0" anchor="t">
+            <a:spAutoFit/>
+          </a:bodyPr>
+          <a:lstStyle/>
+          <a:p>
+            <a:pPr algn="l">
+              <a:lnSpc>
+                <a:spcPct val="115000"/>
+              </a:lnSpc>
+            </a:pPr>
+            <a:r>
+              <a:rPr sz="1200" b="1">
+                <a:solidFill>
+                  <a:srgbClr val="1B1B2F"/>
+                </a:solidFill>
+                <a:latin typeface="Montserrat"/>
+              </a:rPr>
+              <a:t>Fornecimento piloto</a:t>
+            </a:r>
+          </a:p>
+        </p:txBody>
+      </p:sp>
+      <p:sp>
+        <p:nvSpPr>
+          <p:cNvPr id="28" name="TextBox 27"/>
+          <p:cNvSpPr txBox="1"/>
+          <p:nvPr/>
+        </p:nvSpPr>
+        <p:spPr>
+          <a:xfrm>
+            <a:off x="7488936" y="3337560"/>
+            <a:ext cx="1645920" cy="1097280"/>
+          </a:xfrm>
+          <a:prstGeom prst="rect">
+            <a:avLst/>
+          </a:prstGeom>
+          <a:noFill/>
+        </p:spPr>
+        <p:txBody>
+          <a:bodyPr wrap="square" lIns="0" rIns="0" tIns="0" bIns="0" anchor="t">
+            <a:spAutoFit/>
+          </a:bodyPr>
+          <a:lstStyle/>
+          <a:p>
+            <a:pPr algn="l">
+              <a:lnSpc>
+                <a:spcPct val="115000"/>
+              </a:lnSpc>
+            </a:pPr>
+            <a:r>
+              <a:rPr sz="1000" b="0">
+                <a:solidFill>
+                  <a:srgbClr val="6B6B80"/>
+                </a:solidFill>
+                <a:latin typeface="Montserrat"/>
+              </a:rPr>
+              <a:t>Lotes iniciais com monitoramento de desempenho.</a:t>
+            </a:r>
+          </a:p>
+        </p:txBody>
+      </p:sp>
+      <p:sp>
+        <p:nvSpPr>
+          <p:cNvPr id="29" name="Rectangle 28"/>
+          <p:cNvSpPr/>
+          <p:nvPr/>
+        </p:nvSpPr>
+        <p:spPr>
+          <a:xfrm>
+            <a:off x="9427464" y="1828800"/>
+            <a:ext cx="2011680" cy="2743200"/>
+          </a:xfrm>
+          <a:prstGeom prst="rect">
+            <a:avLst/>
+          </a:prstGeom>
+          <a:solidFill>
+            <a:srgbClr val="F4F5FC"/>
+          </a:solidFill>
+          <a:ln>
+            <a:noFill/>
+          </a:ln>
+          <a:effectLst/>
+        </p:spPr>
+        <p:txBody>
+          <a:bodyPr rtlCol="0" anchor="ctr"/>
+          <a:lstStyle/>
+          <a:p>
+            <a:pPr algn="ctr"/>
+          </a:p>
+        </p:txBody>
+      </p:sp>
+      <p:sp>
+        <p:nvSpPr>
+          <p:cNvPr id="30" name="Rectangle 29"/>
+          <p:cNvSpPr/>
+          <p:nvPr/>
+        </p:nvSpPr>
+        <p:spPr>
+          <a:xfrm>
+            <a:off x="9427464" y="1828800"/>
+            <a:ext cx="2011680" cy="54864"/>
+          </a:xfrm>
+          <a:prstGeom prst="rect">
+            <a:avLst/>
+          </a:prstGeom>
+          <a:solidFill>
+            <a:srgbClr val="12A87B"/>
+          </a:solidFill>
+          <a:ln>
+            <a:noFill/>
+          </a:ln>
+          <a:effectLst/>
+        </p:spPr>
+        <p:txBody>
+          <a:bodyPr rtlCol="0" anchor="ctr"/>
+          <a:lstStyle/>
+          <a:p>
+            <a:pPr algn="ctr"/>
+          </a:p>
+        </p:txBody>
+      </p:sp>
+      <p:sp>
+        <p:nvSpPr>
+          <p:cNvPr id="31" name="TextBox 30"/>
+          <p:cNvSpPr txBox="1"/>
+          <p:nvPr/>
+        </p:nvSpPr>
+        <p:spPr>
+          <a:xfrm>
+            <a:off x="9656064" y="2103120"/>
+            <a:ext cx="1371600" cy="457200"/>
+          </a:xfrm>
+          <a:prstGeom prst="rect">
+            <a:avLst/>
+          </a:prstGeom>
+          <a:noFill/>
+        </p:spPr>
+        <p:txBody>
+          <a:bodyPr wrap="square" lIns="0" rIns="0" tIns="0" bIns="0" anchor="t">
+            <a:spAutoFit/>
+          </a:bodyPr>
+          <a:lstStyle/>
+          <a:p>
+            <a:pPr algn="l">
+              <a:lnSpc>
+                <a:spcPct val="115000"/>
+              </a:lnSpc>
+            </a:pPr>
+            <a:r>
+              <a:rPr sz="2400" b="0">
+                <a:solidFill>
+                  <a:srgbClr val="12A87B"/>
+                </a:solidFill>
+                <a:latin typeface="Montserrat"/>
+              </a:rPr>
+              <a:t>05</a:t>
+            </a:r>
+          </a:p>
+        </p:txBody>
+      </p:sp>
+      <p:pic>
+        <p:nvPicPr>
+          <p:cNvPr id="32" name="Picture 31" descr="handshake_green.png"/>
+          <p:cNvPicPr>
+            <a:picLocks noChangeAspect="1"/>
+          </p:cNvPicPr>
+          <p:nvPr/>
+        </p:nvPicPr>
+        <p:blipFill>
+          <a:blip r:embed="rId6"/>
+          <a:stretch>
+            <a:fillRect/>
+          </a:stretch>
+        </p:blipFill>
+        <p:spPr>
+          <a:xfrm>
+            <a:off x="10844784" y="2148840"/>
+            <a:ext cx="365760" cy="365760"/>
+          </a:xfrm>
+          <a:prstGeom prst="rect">
+            <a:avLst/>
+          </a:prstGeom>
+        </p:spPr>
+      </p:pic>
+      <p:sp>
+        <p:nvSpPr>
+          <p:cNvPr id="33" name="TextBox 32"/>
+          <p:cNvSpPr txBox="1"/>
+          <p:nvPr/>
+        </p:nvSpPr>
+        <p:spPr>
+          <a:xfrm>
+            <a:off x="9656064" y="2743200"/>
+            <a:ext cx="1645920" cy="548640"/>
+          </a:xfrm>
+          <a:prstGeom prst="rect">
+            <a:avLst/>
+          </a:prstGeom>
+          <a:noFill/>
+        </p:spPr>
+        <p:txBody>
+          <a:bodyPr wrap="square" lIns="0" rIns="0" tIns="0" bIns="0" anchor="t">
+            <a:spAutoFit/>
+          </a:bodyPr>
+          <a:lstStyle/>
+          <a:p>
+            <a:pPr algn="l">
+              <a:lnSpc>
+                <a:spcPct val="115000"/>
+              </a:lnSpc>
+            </a:pPr>
+            <a:r>
+              <a:rPr sz="1200" b="1">
+                <a:solidFill>
+                  <a:srgbClr val="1B1B2F"/>
+                </a:solidFill>
+                <a:latin typeface="Montserrat"/>
+              </a:rPr>
+              <a:t>Contrato contínuo</a:t>
+            </a:r>
+          </a:p>
+        </p:txBody>
+      </p:sp>
+      <p:sp>
+        <p:nvSpPr>
+          <p:cNvPr id="34" name="TextBox 33"/>
+          <p:cNvSpPr txBox="1"/>
+          <p:nvPr/>
+        </p:nvSpPr>
+        <p:spPr>
+          <a:xfrm>
+            <a:off x="9656064" y="3337560"/>
+            <a:ext cx="1645920" cy="1097280"/>
+          </a:xfrm>
+          <a:prstGeom prst="rect">
+            <a:avLst/>
+          </a:prstGeom>
+          <a:noFill/>
+        </p:spPr>
+        <p:txBody>
+          <a:bodyPr wrap="square" lIns="0" rIns="0" tIns="0" bIns="0" anchor="t">
+            <a:spAutoFit/>
+          </a:bodyPr>
+          <a:lstStyle/>
+          <a:p>
+            <a:pPr algn="l">
+              <a:lnSpc>
+                <a:spcPct val="115000"/>
+              </a:lnSpc>
+            </a:pPr>
+            <a:r>
+              <a:rPr sz="1000" b="0">
+                <a:solidFill>
+                  <a:srgbClr val="6B6B80"/>
+                </a:solidFill>
+                <a:latin typeface="Montserrat"/>
+              </a:rPr>
+              <a:t>Fornecimento regular e programado.</a:t>
+            </a:r>
+          </a:p>
+        </p:txBody>
+      </p:sp>
+      <p:sp>
+        <p:nvSpPr>
+          <p:cNvPr id="35" name="TextBox 34"/>
+          <p:cNvSpPr txBox="1"/>
+          <p:nvPr/>
+        </p:nvSpPr>
+        <p:spPr>
+          <a:xfrm>
+            <a:off x="758952" y="4892040"/>
+            <a:ext cx="10607040" cy="731520"/>
+          </a:xfrm>
+          <a:prstGeom prst="rect">
+            <a:avLst/>
+          </a:prstGeom>
+          <a:noFill/>
+        </p:spPr>
+        <p:txBody>
+          <a:bodyPr wrap="square" lIns="0" rIns="0" tIns="0" bIns="0" anchor="t">
+            <a:spAutoFit/>
+          </a:bodyPr>
+          <a:lstStyle/>
+          <a:p>
+            <a:pPr algn="l">
+              <a:lnSpc>
+                <a:spcPct val="115000"/>
+              </a:lnSpc>
+            </a:pPr>
+            <a:r>
+              <a:rPr sz="1200" b="1">
+                <a:solidFill>
+                  <a:srgbClr val="3432C9"/>
+                </a:solidFill>
+                <a:latin typeface="Montserrat"/>
+              </a:rPr>
+              <a:t>Solicitamos cotação formal em R$/t </a:t>
+            </a:r>
+            <a:r>
+              <a:rPr sz="1200" b="0">
+                <a:solidFill>
+                  <a:srgbClr val="6B6B80"/>
+                </a:solidFill>
+                <a:latin typeface="Montserrat"/>
+              </a:rPr>
+              <a:t>para o fornecimento de 1.000 t/mês com entrega programada na unidade do cliente. As condições finais serão definidas em reunião.</a:t>
+            </a:r>
+          </a:p>
+        </p:txBody>
+      </p:sp>
+      <p:cxnSp>
+        <p:nvCxnSpPr>
+          <p:cNvPr id="36" name="Connector 35"/>
+          <p:cNvCxnSpPr/>
+          <p:nvPr/>
+        </p:nvCxnSpPr>
+        <p:spPr>
+          <a:xfrm>
+            <a:off x="758952" y="6199632"/>
+            <a:ext cx="10671048" cy="0"/>
+          </a:xfrm>
+          <a:prstGeom prst="line">
+            <a:avLst/>
+          </a:prstGeom>
+          <a:ln w="9525">
+            <a:solidFill>
+              <a:srgbClr val="DDDEEE"/>
+            </a:solidFill>
+          </a:ln>
+        </p:spPr>
+      </p:cxnSp>
+      <p:pic>
+        <p:nvPicPr>
+          <p:cNvPr id="37" name="Picture 36" descr="logo_dark.png"/>
+          <p:cNvPicPr>
+            <a:picLocks noChangeAspect="1"/>
+          </p:cNvPicPr>
+          <p:nvPr/>
+        </p:nvPicPr>
+        <p:blipFill>
+          <a:blip r:embed="rId7"/>
+          <a:stretch>
+            <a:fillRect/>
+          </a:stretch>
+        </p:blipFill>
+        <p:spPr>
+          <a:xfrm>
+            <a:off x="758952" y="6309360"/>
+            <a:ext cx="1150185" cy="274320"/>
+          </a:xfrm>
+          <a:prstGeom prst="rect">
+            <a:avLst/>
+          </a:prstGeom>
+        </p:spPr>
+      </p:pic>
+      <p:sp>
+        <p:nvSpPr>
+          <p:cNvPr id="38" name="TextBox 37"/>
+          <p:cNvSpPr txBox="1"/>
+          <p:nvPr/>
+        </p:nvSpPr>
+        <p:spPr>
+          <a:xfrm>
+            <a:off x="7772400" y="6355080"/>
+            <a:ext cx="3657600" cy="228600"/>
+          </a:xfrm>
+          <a:prstGeom prst="rect">
+            <a:avLst/>
+          </a:prstGeom>
+          <a:noFill/>
+        </p:spPr>
+        <p:txBody>
+          <a:bodyPr wrap="square" lIns="0" rIns="0" tIns="0" bIns="0" anchor="t">
+            <a:spAutoFit/>
+          </a:bodyPr>
+          <a:lstStyle/>
+          <a:p>
+            <a:pPr algn="r">
+              <a:lnSpc>
+                <a:spcPct val="115000"/>
+              </a:lnSpc>
+            </a:pPr>
+            <a:r>
+              <a:rPr sz="800" b="0">
+                <a:solidFill>
+                  <a:srgbClr val="6B6B80"/>
+                </a:solidFill>
+                <a:latin typeface="Montserrat"/>
+              </a:rPr>
+              <a:t>Resíduo Têxtil · Mineração   |   14</a:t>
+            </a:r>
+          </a:p>
+        </p:txBody>
+      </p:sp>
+    </p:spTree>
+  </p:cSld>
+  <p:clrMapOvr>
+    <a:masterClrMapping/>
+  </p:clrMapOvr>
+</p:sld>
+</file>
+
+<file path=ppt/slides/slide15.xml><?xml version="1.0" encoding="utf-8"?>
 <p:sld xmlns:a="http://schemas.openxmlformats.org/drawingml/2006/main" xmlns:p="http://schemas.openxmlformats.org/presentationml/2006/main" xmlns:r="http://schemas.openxmlformats.org/officeDocument/2006/relationships">
   <p:cSld>
     <p:bg>

</xml_diff>